<commit_message>
Add 20 roles and publish cumulative 43-role workforce scenario
</commit_message>
<xml_diff>
--- a/board-deck.pptx
+++ b/board-deck.pptx
@@ -2,35 +2,35 @@
 <file path=ppt/presentation.xml><?xml version="1.0" encoding="utf-8"?>
 <p:presentation xmlns:p="http://schemas.openxmlformats.org/presentationml/2006/main">
   <p:sldMasterIdLst>
-    <p:sldMasterId xmlns:r="http://schemas.openxmlformats.org/officeDocument/2006/relationships" id="2147483648" r:id="R6405ba63e0984e71"/>
+    <p:sldMasterId xmlns:r="http://schemas.openxmlformats.org/officeDocument/2006/relationships" id="2147483648" r:id="Rdd295afa624b49db"/>
   </p:sldMasterIdLst>
   <p:notesMasterIdLst>
-    <p:notesMasterId xmlns:r="http://schemas.openxmlformats.org/officeDocument/2006/relationships" r:id="R9a3a6425a4524c2c"/>
+    <p:notesMasterId xmlns:r="http://schemas.openxmlformats.org/officeDocument/2006/relationships" r:id="R84a71871709c4176"/>
   </p:notesMasterIdLst>
   <p:sldIdLst>
-    <p:sldId xmlns:r="http://schemas.openxmlformats.org/officeDocument/2006/relationships" id="256" r:id="R4281160c45044f08"/>
-    <p:sldId xmlns:r="http://schemas.openxmlformats.org/officeDocument/2006/relationships" id="257" r:id="R8d999cd3daa241d1"/>
-    <p:sldId xmlns:r="http://schemas.openxmlformats.org/officeDocument/2006/relationships" id="258" r:id="Rdc0ed13148e04c46"/>
-    <p:sldId xmlns:r="http://schemas.openxmlformats.org/officeDocument/2006/relationships" id="259" r:id="R0bbee0a698194f87"/>
-    <p:sldId xmlns:r="http://schemas.openxmlformats.org/officeDocument/2006/relationships" id="260" r:id="Rc1d91d8383794980"/>
-    <p:sldId xmlns:r="http://schemas.openxmlformats.org/officeDocument/2006/relationships" id="261" r:id="R146b041f235246b5"/>
-    <p:sldId xmlns:r="http://schemas.openxmlformats.org/officeDocument/2006/relationships" id="262" r:id="R56f7b279d7d94537"/>
-    <p:sldId xmlns:r="http://schemas.openxmlformats.org/officeDocument/2006/relationships" id="263" r:id="Rc61de36b305c49ee"/>
-    <p:sldId xmlns:r="http://schemas.openxmlformats.org/officeDocument/2006/relationships" id="264" r:id="Ra14997b7d7e54d1f"/>
-    <p:sldId xmlns:r="http://schemas.openxmlformats.org/officeDocument/2006/relationships" id="265" r:id="R57a7857e22af4b1c"/>
-    <p:sldId xmlns:r="http://schemas.openxmlformats.org/officeDocument/2006/relationships" id="266" r:id="R9b7cfdd3e97d4de1"/>
-    <p:sldId xmlns:r="http://schemas.openxmlformats.org/officeDocument/2006/relationships" id="267" r:id="Rb2d2ff499b6b4ec8"/>
-    <p:sldId xmlns:r="http://schemas.openxmlformats.org/officeDocument/2006/relationships" id="268" r:id="Rc2badde820f641df"/>
-    <p:sldId xmlns:r="http://schemas.openxmlformats.org/officeDocument/2006/relationships" id="269" r:id="Rd6072aecf0d64c5c"/>
-    <p:sldId xmlns:r="http://schemas.openxmlformats.org/officeDocument/2006/relationships" id="270" r:id="R5011b64668ac4a4b"/>
-    <p:sldId xmlns:r="http://schemas.openxmlformats.org/officeDocument/2006/relationships" id="271" r:id="R64d4aa3cfce443e2"/>
-    <p:sldId xmlns:r="http://schemas.openxmlformats.org/officeDocument/2006/relationships" id="272" r:id="R29d9a6a96c2549c3"/>
-    <p:sldId xmlns:r="http://schemas.openxmlformats.org/officeDocument/2006/relationships" id="273" r:id="R3a4d7071fbe84ae3"/>
-    <p:sldId xmlns:r="http://schemas.openxmlformats.org/officeDocument/2006/relationships" id="274" r:id="R291077cc83694b87"/>
-    <p:sldId xmlns:r="http://schemas.openxmlformats.org/officeDocument/2006/relationships" id="275" r:id="R6921394596fe44ad"/>
-    <p:sldId xmlns:r="http://schemas.openxmlformats.org/officeDocument/2006/relationships" id="276" r:id="R8f3f6f464850479f"/>
-    <p:sldId xmlns:r="http://schemas.openxmlformats.org/officeDocument/2006/relationships" id="277" r:id="Rbee7adbf1c9a4bee"/>
-    <p:sldId xmlns:r="http://schemas.openxmlformats.org/officeDocument/2006/relationships" id="278" r:id="R3e6bff2625d3498f"/>
+    <p:sldId xmlns:r="http://schemas.openxmlformats.org/officeDocument/2006/relationships" id="256" r:id="Refe25534c32046d2"/>
+    <p:sldId xmlns:r="http://schemas.openxmlformats.org/officeDocument/2006/relationships" id="257" r:id="R9969af65764d4e6f"/>
+    <p:sldId xmlns:r="http://schemas.openxmlformats.org/officeDocument/2006/relationships" id="258" r:id="Rc43236b7a2eb4400"/>
+    <p:sldId xmlns:r="http://schemas.openxmlformats.org/officeDocument/2006/relationships" id="259" r:id="R2a6ebadb156d4a3b"/>
+    <p:sldId xmlns:r="http://schemas.openxmlformats.org/officeDocument/2006/relationships" id="260" r:id="Rc0982af930234d87"/>
+    <p:sldId xmlns:r="http://schemas.openxmlformats.org/officeDocument/2006/relationships" id="261" r:id="R28a43899c40e4901"/>
+    <p:sldId xmlns:r="http://schemas.openxmlformats.org/officeDocument/2006/relationships" id="262" r:id="Rc1515dfce2ea405d"/>
+    <p:sldId xmlns:r="http://schemas.openxmlformats.org/officeDocument/2006/relationships" id="263" r:id="Rb50db109d5a8459a"/>
+    <p:sldId xmlns:r="http://schemas.openxmlformats.org/officeDocument/2006/relationships" id="264" r:id="R8a45f1d9afad4866"/>
+    <p:sldId xmlns:r="http://schemas.openxmlformats.org/officeDocument/2006/relationships" id="265" r:id="R9f23073b2a544353"/>
+    <p:sldId xmlns:r="http://schemas.openxmlformats.org/officeDocument/2006/relationships" id="266" r:id="Rc035749c133e4d54"/>
+    <p:sldId xmlns:r="http://schemas.openxmlformats.org/officeDocument/2006/relationships" id="267" r:id="Re04e2727d3c84554"/>
+    <p:sldId xmlns:r="http://schemas.openxmlformats.org/officeDocument/2006/relationships" id="268" r:id="Rf23084c1ce474047"/>
+    <p:sldId xmlns:r="http://schemas.openxmlformats.org/officeDocument/2006/relationships" id="269" r:id="R46eacb6fe65045e3"/>
+    <p:sldId xmlns:r="http://schemas.openxmlformats.org/officeDocument/2006/relationships" id="270" r:id="R9d1ab2b3e61e4668"/>
+    <p:sldId xmlns:r="http://schemas.openxmlformats.org/officeDocument/2006/relationships" id="271" r:id="R23d4f7f2ae53459d"/>
+    <p:sldId xmlns:r="http://schemas.openxmlformats.org/officeDocument/2006/relationships" id="272" r:id="R20210241369b4846"/>
+    <p:sldId xmlns:r="http://schemas.openxmlformats.org/officeDocument/2006/relationships" id="273" r:id="Rba6f6f5046b54929"/>
+    <p:sldId xmlns:r="http://schemas.openxmlformats.org/officeDocument/2006/relationships" id="274" r:id="Rf1ab7f14797a4c49"/>
+    <p:sldId xmlns:r="http://schemas.openxmlformats.org/officeDocument/2006/relationships" id="275" r:id="R625e6a1a42154574"/>
+    <p:sldId xmlns:r="http://schemas.openxmlformats.org/officeDocument/2006/relationships" id="276" r:id="R30818e4902824e4d"/>
+    <p:sldId xmlns:r="http://schemas.openxmlformats.org/officeDocument/2006/relationships" id="277" r:id="Ra99584d98a964c65"/>
+    <p:sldId xmlns:r="http://schemas.openxmlformats.org/officeDocument/2006/relationships" id="278" r:id="R14d079d6e828434a"/>
   </p:sldIdLst>
   <p:sldSz cx="12192000" cy="6858000"/>
   <p:notesSz cx="6858000" cy="9144000"/>
@@ -1304,7 +1304,7 @@
           <a:lstStyle xmlns:a="http://schemas.openxmlformats.org/drawingml/2006/main"/>
           <a:p xmlns:a="http://schemas.openxmlformats.org/drawingml/2006/main">
             <a:r>
-              <a:t>52,200 小时是将29岗按每岗1,800小时估算的必要容量检验，不能单凭工时推导合法减编。</a:t>
+              <a:t>77,400 小时是将43岗按每岗1,800小时估算的必要容量检验，不能单凭工时推导具体人员退出。</a:t>
             </a:r>
           </a:p>
         </p:txBody>
@@ -2137,7 +2137,7 @@
   </p:cSld>
   <p:clrMap bg1="lt1" tx1="dk1" bg2="lt2" tx2="dk2" accent1="accent1" accent2="accent2" accent3="accent3" accent4="accent4" accent5="accent5" accent6="accent6" hlink="hlink" folHlink="folHlink"/>
   <p:sldLayoutIdLst>
-    <p:sldLayoutId xmlns:r="http://schemas.openxmlformats.org/officeDocument/2006/relationships" id="2147483649" r:id="R6b2b7eb588934516"/>
+    <p:sldLayoutId xmlns:r="http://schemas.openxmlformats.org/officeDocument/2006/relationships" id="2147483649" r:id="R78ffb724a4b34509"/>
   </p:sldLayoutIdLst>
   <p:txStyles>
     <p:titleStyle>
@@ -2692,7 +2692,7 @@
           <p:nvPr/>
         </p:nvPicPr>
         <p:blipFill>
-          <a:blip xmlns:r="http://schemas.openxmlformats.org/officeDocument/2006/relationships" xmlns:a="http://schemas.openxmlformats.org/drawingml/2006/main" r:embed="Rfec59037048047a7"/>
+          <a:blip xmlns:r="http://schemas.openxmlformats.org/officeDocument/2006/relationships" xmlns:a="http://schemas.openxmlformats.org/drawingml/2006/main" r:embed="Rf471798113314f35"/>
           <a:srcRect xmlns:a="http://schemas.openxmlformats.org/drawingml/2006/main" l="0" t="27" r="0" b="27"/>
           <a:stretch xmlns:a="http://schemas.openxmlformats.org/drawingml/2006/main">
             <a:fillRect l="0" t="0" r="0" b="0"/>
@@ -2713,7 +2713,7 @@
           <p:cNvPr id="2" name="">
             <a:extLst xmlns:a="http://schemas.openxmlformats.org/drawingml/2006/main">
               <a:ext uri="{FF2B5EF4-FFF2-40B4-BE49-F238E27FC236}">
-                <a16:creationId xmlns:a16="http://schemas.microsoft.com/office/drawing/2014/main" id="{279B1D05-AA6A-4BD6-8E9E-1C4A9AB540A7}"/>
+                <a16:creationId xmlns:a16="http://schemas.microsoft.com/office/drawing/2014/main" id="{FEFD4BA8-0ECA-475E-BCB7-846F480EED5B}"/>
               </a:ext>
             </a:extLst>
           </p:cNvPr>
@@ -2762,7 +2762,7 @@
           <p:cNvPr id="3" name="">
             <a:extLst xmlns:a="http://schemas.openxmlformats.org/drawingml/2006/main">
               <a:ext uri="{FF2B5EF4-FFF2-40B4-BE49-F238E27FC236}">
-                <a16:creationId xmlns:a16="http://schemas.microsoft.com/office/drawing/2014/main" id="{14BB0111-0254-4228-BD17-EF9E56D31AD4}"/>
+                <a16:creationId xmlns:a16="http://schemas.microsoft.com/office/drawing/2014/main" id="{43CA9BE2-8BF8-4380-B42A-126444937FA4}"/>
               </a:ext>
             </a:extLst>
           </p:cNvPr>
@@ -2816,7 +2816,7 @@
               </a:defRPr>
             </a:pPr>
             <a:r>
-              <a:t>年度节约 200 万</a:t>
+              <a:t>累计压减 43 岗</a:t>
             </a:r>
           </a:p>
         </p:txBody>
@@ -2826,7 +2826,7 @@
           <p:cNvPr id="4" name="">
             <a:extLst xmlns:a="http://schemas.openxmlformats.org/drawingml/2006/main">
               <a:ext uri="{FF2B5EF4-FFF2-40B4-BE49-F238E27FC236}">
-                <a16:creationId xmlns:a16="http://schemas.microsoft.com/office/drawing/2014/main" id="{B2A78C4B-ADF7-4423-92C7-3C80DB6B1B7E}"/>
+                <a16:creationId xmlns:a16="http://schemas.microsoft.com/office/drawing/2014/main" id="{32CBB272-3FF3-44DA-9FEE-9049581410C5}"/>
               </a:ext>
             </a:extLst>
           </p:cNvPr>
@@ -2875,7 +2875,7 @@
           <p:cNvPr id="5" name="">
             <a:extLst xmlns:a="http://schemas.openxmlformats.org/drawingml/2006/main">
               <a:ext uri="{FF2B5EF4-FFF2-40B4-BE49-F238E27FC236}">
-                <a16:creationId xmlns:a16="http://schemas.microsoft.com/office/drawing/2014/main" id="{27DA23D2-9520-4AF2-A03E-3BCCE73ECFA6}"/>
+                <a16:creationId xmlns:a16="http://schemas.microsoft.com/office/drawing/2014/main" id="{DD41E0F4-D9D6-4CD2-B485-392D5F6FF094}"/>
               </a:ext>
             </a:extLst>
           </p:cNvPr>
@@ -2922,7 +2922,7 @@
     </p:spTree>
     <p:extLst>
       <p:ext uri="{BB962C8B-B14F-4D97-AF65-F5344CB8AC3E}">
-        <p14:creationId xmlns:p14="http://schemas.microsoft.com/office/powerpoint/2010/main" val="74035981"/>
+        <p14:creationId xmlns:p14="http://schemas.microsoft.com/office/powerpoint/2010/main" val="1941485065"/>
       </p:ext>
     </p:extLst>
   </p:cSld>
@@ -2953,7 +2953,7 @@
           <p:cNvPr id="10" name="">
             <a:extLst xmlns:a="http://schemas.openxmlformats.org/drawingml/2006/main">
               <a:ext uri="{FF2B5EF4-FFF2-40B4-BE49-F238E27FC236}">
-                <a16:creationId xmlns:a16="http://schemas.microsoft.com/office/drawing/2014/main" id="{77790FEE-0843-424B-969C-8E0B19A9EB36}"/>
+                <a16:creationId xmlns:a16="http://schemas.microsoft.com/office/drawing/2014/main" id="{4272FB7E-7122-46A1-9ABF-C52128B73B1A}"/>
               </a:ext>
             </a:extLst>
           </p:cNvPr>
@@ -3002,7 +3002,7 @@
           <p:cNvPr id="2" name="">
             <a:extLst xmlns:a="http://schemas.openxmlformats.org/drawingml/2006/main">
               <a:ext uri="{FF2B5EF4-FFF2-40B4-BE49-F238E27FC236}">
-                <a16:creationId xmlns:a16="http://schemas.microsoft.com/office/drawing/2014/main" id="{292384DB-931C-44A7-B434-C5A732860A14}"/>
+                <a16:creationId xmlns:a16="http://schemas.microsoft.com/office/drawing/2014/main" id="{1CD1F59E-7AA1-45B8-9BF3-C6042B97D994}"/>
               </a:ext>
             </a:extLst>
           </p:cNvPr>
@@ -3051,7 +3051,7 @@
           <p:cNvPr id="3" name="">
             <a:extLst xmlns:a="http://schemas.openxmlformats.org/drawingml/2006/main">
               <a:ext uri="{FF2B5EF4-FFF2-40B4-BE49-F238E27FC236}">
-                <a16:creationId xmlns:a16="http://schemas.microsoft.com/office/drawing/2014/main" id="{BC0A5BD0-D339-41CF-83FC-DCEF5AC69F01}"/>
+                <a16:creationId xmlns:a16="http://schemas.microsoft.com/office/drawing/2014/main" id="{A41D5612-A11E-4034-A99D-F4C8DB99E39E}"/>
               </a:ext>
             </a:extLst>
           </p:cNvPr>
@@ -3100,7 +3100,7 @@
           <p:cNvPr id="4" name="">
             <a:extLst xmlns:a="http://schemas.openxmlformats.org/drawingml/2006/main">
               <a:ext uri="{FF2B5EF4-FFF2-40B4-BE49-F238E27FC236}">
-                <a16:creationId xmlns:a16="http://schemas.microsoft.com/office/drawing/2014/main" id="{B2268D38-60AC-40D6-931C-9012E7775F71}"/>
+                <a16:creationId xmlns:a16="http://schemas.microsoft.com/office/drawing/2014/main" id="{71C6CB1A-5F0C-457B-A694-88D8AD03CB9E}"/>
               </a:ext>
             </a:extLst>
           </p:cNvPr>
@@ -3149,7 +3149,7 @@
           <p:cNvPr id="5" name="">
             <a:extLst xmlns:a="http://schemas.openxmlformats.org/drawingml/2006/main">
               <a:ext uri="{FF2B5EF4-FFF2-40B4-BE49-F238E27FC236}">
-                <a16:creationId xmlns:a16="http://schemas.microsoft.com/office/drawing/2014/main" id="{511F661F-5D2A-4848-8950-D1440B6A21E9}"/>
+                <a16:creationId xmlns:a16="http://schemas.microsoft.com/office/drawing/2014/main" id="{A36362B4-FE7D-4333-9215-0BFC5AA23FC1}"/>
               </a:ext>
             </a:extLst>
           </p:cNvPr>
@@ -3198,7 +3198,7 @@
           <p:cNvPr id="6" name="">
             <a:extLst xmlns:a="http://schemas.openxmlformats.org/drawingml/2006/main">
               <a:ext uri="{FF2B5EF4-FFF2-40B4-BE49-F238E27FC236}">
-                <a16:creationId xmlns:a16="http://schemas.microsoft.com/office/drawing/2014/main" id="{89754072-8B9B-48EC-B62B-D8EB0150D86C}"/>
+                <a16:creationId xmlns:a16="http://schemas.microsoft.com/office/drawing/2014/main" id="{73AF27CB-DFC2-4345-883B-6770B7EC8E10}"/>
               </a:ext>
             </a:extLst>
           </p:cNvPr>
@@ -3247,7 +3247,7 @@
           <p:cNvPr id="7" name="">
             <a:extLst xmlns:a="http://schemas.openxmlformats.org/drawingml/2006/main">
               <a:ext uri="{FF2B5EF4-FFF2-40B4-BE49-F238E27FC236}">
-                <a16:creationId xmlns:a16="http://schemas.microsoft.com/office/drawing/2014/main" id="{C6D80722-6A93-4898-95D1-2416AEC8D841}"/>
+                <a16:creationId xmlns:a16="http://schemas.microsoft.com/office/drawing/2014/main" id="{7BDB485F-E6F3-4262-AF37-C29592CAB95C}"/>
               </a:ext>
             </a:extLst>
           </p:cNvPr>
@@ -3296,7 +3296,7 @@
           <p:cNvPr id="8" name="">
             <a:extLst xmlns:a="http://schemas.openxmlformats.org/drawingml/2006/main">
               <a:ext uri="{FF2B5EF4-FFF2-40B4-BE49-F238E27FC236}">
-                <a16:creationId xmlns:a16="http://schemas.microsoft.com/office/drawing/2014/main" id="{7BEA41BE-CB63-4456-85F6-EE2E7905FD3D}"/>
+                <a16:creationId xmlns:a16="http://schemas.microsoft.com/office/drawing/2014/main" id="{CA520AA1-ED63-4213-A220-41336EADA095}"/>
               </a:ext>
             </a:extLst>
           </p:cNvPr>
@@ -3345,7 +3345,7 @@
           <p:cNvPr id="9" name="">
             <a:extLst xmlns:a="http://schemas.openxmlformats.org/drawingml/2006/main">
               <a:ext uri="{FF2B5EF4-FFF2-40B4-BE49-F238E27FC236}">
-                <a16:creationId xmlns:a16="http://schemas.microsoft.com/office/drawing/2014/main" id="{5C3C5ABA-30C8-4342-886C-B57DC811367D}"/>
+                <a16:creationId xmlns:a16="http://schemas.microsoft.com/office/drawing/2014/main" id="{95B9C71B-143B-4AB9-A7AD-AA0176C52F75}"/>
               </a:ext>
             </a:extLst>
           </p:cNvPr>
@@ -3392,7 +3392,7 @@
     </p:spTree>
     <p:extLst>
       <p:ext uri="{BB962C8B-B14F-4D97-AF65-F5344CB8AC3E}">
-        <p14:creationId xmlns:p14="http://schemas.microsoft.com/office/powerpoint/2010/main" val="1799893027"/>
+        <p14:creationId xmlns:p14="http://schemas.microsoft.com/office/powerpoint/2010/main" val="944277426"/>
       </p:ext>
     </p:extLst>
   </p:cSld>
@@ -3423,7 +3423,7 @@
           <p:cNvPr id="18" name="">
             <a:extLst xmlns:a="http://schemas.openxmlformats.org/drawingml/2006/main">
               <a:ext uri="{FF2B5EF4-FFF2-40B4-BE49-F238E27FC236}">
-                <a16:creationId xmlns:a16="http://schemas.microsoft.com/office/drawing/2014/main" id="{12FD5AF7-A2F3-4E49-B363-E73F27CD98D7}"/>
+                <a16:creationId xmlns:a16="http://schemas.microsoft.com/office/drawing/2014/main" id="{981299D2-47F4-4E2A-AED9-21A8F948202C}"/>
               </a:ext>
             </a:extLst>
           </p:cNvPr>
@@ -3472,7 +3472,7 @@
           <p:cNvPr id="2" name="">
             <a:extLst xmlns:a="http://schemas.openxmlformats.org/drawingml/2006/main">
               <a:ext uri="{FF2B5EF4-FFF2-40B4-BE49-F238E27FC236}">
-                <a16:creationId xmlns:a16="http://schemas.microsoft.com/office/drawing/2014/main" id="{7A06EACA-C04F-4931-8DB2-93D4018BDEC5}"/>
+                <a16:creationId xmlns:a16="http://schemas.microsoft.com/office/drawing/2014/main" id="{36FBA11B-12FB-42D7-B047-192960E99B9F}"/>
               </a:ext>
             </a:extLst>
           </p:cNvPr>
@@ -3521,7 +3521,7 @@
           <p:cNvPr id="3" name="">
             <a:extLst xmlns:a="http://schemas.openxmlformats.org/drawingml/2006/main">
               <a:ext uri="{FF2B5EF4-FFF2-40B4-BE49-F238E27FC236}">
-                <a16:creationId xmlns:a16="http://schemas.microsoft.com/office/drawing/2014/main" id="{A414ABB6-BFAE-411A-8BE5-FDB55C625F29}"/>
+                <a16:creationId xmlns:a16="http://schemas.microsoft.com/office/drawing/2014/main" id="{7FC31C09-8748-4C6E-A53D-2BD912A57C9F}"/>
               </a:ext>
             </a:extLst>
           </p:cNvPr>
@@ -3570,7 +3570,7 @@
           <p:cNvPr id="4" name="">
             <a:extLst xmlns:a="http://schemas.openxmlformats.org/drawingml/2006/main">
               <a:ext uri="{FF2B5EF4-FFF2-40B4-BE49-F238E27FC236}">
-                <a16:creationId xmlns:a16="http://schemas.microsoft.com/office/drawing/2014/main" id="{9623E59D-BECA-4702-9397-740C9A1A9AEF}"/>
+                <a16:creationId xmlns:a16="http://schemas.microsoft.com/office/drawing/2014/main" id="{AC23A2DE-7CD3-437D-BA2B-A712AE143112}"/>
               </a:ext>
             </a:extLst>
           </p:cNvPr>
@@ -3619,7 +3619,7 @@
           <p:cNvPr id="5" name="">
             <a:extLst xmlns:a="http://schemas.openxmlformats.org/drawingml/2006/main">
               <a:ext uri="{FF2B5EF4-FFF2-40B4-BE49-F238E27FC236}">
-                <a16:creationId xmlns:a16="http://schemas.microsoft.com/office/drawing/2014/main" id="{FC2A6D5E-2294-4C01-919E-B06D9F825ED7}"/>
+                <a16:creationId xmlns:a16="http://schemas.microsoft.com/office/drawing/2014/main" id="{37034827-154D-46FF-A476-B85435427577}"/>
               </a:ext>
             </a:extLst>
           </p:cNvPr>
@@ -3668,7 +3668,7 @@
           <p:cNvPr id="6" name="">
             <a:extLst xmlns:a="http://schemas.openxmlformats.org/drawingml/2006/main">
               <a:ext uri="{FF2B5EF4-FFF2-40B4-BE49-F238E27FC236}">
-                <a16:creationId xmlns:a16="http://schemas.microsoft.com/office/drawing/2014/main" id="{846DB3EA-614F-4F43-9A33-9E9FAA35BAC9}"/>
+                <a16:creationId xmlns:a16="http://schemas.microsoft.com/office/drawing/2014/main" id="{5BA3C240-2C1A-4FCA-90A3-D20D12574F3E}"/>
               </a:ext>
             </a:extLst>
           </p:cNvPr>
@@ -3717,7 +3717,7 @@
           <p:cNvPr id="7" name="">
             <a:extLst xmlns:a="http://schemas.openxmlformats.org/drawingml/2006/main">
               <a:ext uri="{FF2B5EF4-FFF2-40B4-BE49-F238E27FC236}">
-                <a16:creationId xmlns:a16="http://schemas.microsoft.com/office/drawing/2014/main" id="{C31D76F7-9B63-43EF-85D0-646F9D7DA201}"/>
+                <a16:creationId xmlns:a16="http://schemas.microsoft.com/office/drawing/2014/main" id="{A49ABB49-1E35-4495-87AE-CA6355413D48}"/>
               </a:ext>
             </a:extLst>
           </p:cNvPr>
@@ -3766,7 +3766,7 @@
           <p:cNvPr id="8" name="">
             <a:extLst xmlns:a="http://schemas.openxmlformats.org/drawingml/2006/main">
               <a:ext uri="{FF2B5EF4-FFF2-40B4-BE49-F238E27FC236}">
-                <a16:creationId xmlns:a16="http://schemas.microsoft.com/office/drawing/2014/main" id="{3F5ABB98-EBFD-4101-ADE2-26C4557ABDE1}"/>
+                <a16:creationId xmlns:a16="http://schemas.microsoft.com/office/drawing/2014/main" id="{BF280442-B815-4ABB-9A18-6A85A4FE2C41}"/>
               </a:ext>
             </a:extLst>
           </p:cNvPr>
@@ -3815,7 +3815,7 @@
           <p:cNvPr id="9" name="">
             <a:extLst xmlns:a="http://schemas.openxmlformats.org/drawingml/2006/main">
               <a:ext uri="{FF2B5EF4-FFF2-40B4-BE49-F238E27FC236}">
-                <a16:creationId xmlns:a16="http://schemas.microsoft.com/office/drawing/2014/main" id="{FD70F025-5B8F-416F-ACDC-F925C2DEC4CC}"/>
+                <a16:creationId xmlns:a16="http://schemas.microsoft.com/office/drawing/2014/main" id="{63B740CB-697D-4D87-9584-9803C7ED4154}"/>
               </a:ext>
             </a:extLst>
           </p:cNvPr>
@@ -3864,7 +3864,7 @@
           <p:cNvPr id="10" name="">
             <a:extLst xmlns:a="http://schemas.openxmlformats.org/drawingml/2006/main">
               <a:ext uri="{FF2B5EF4-FFF2-40B4-BE49-F238E27FC236}">
-                <a16:creationId xmlns:a16="http://schemas.microsoft.com/office/drawing/2014/main" id="{CB1790A9-68A8-482E-A88E-247949818A37}"/>
+                <a16:creationId xmlns:a16="http://schemas.microsoft.com/office/drawing/2014/main" id="{CBFD50C4-6A53-48C6-85A5-7C4680511EA7}"/>
               </a:ext>
             </a:extLst>
           </p:cNvPr>
@@ -3913,7 +3913,7 @@
           <p:cNvPr id="11" name="">
             <a:extLst xmlns:a="http://schemas.openxmlformats.org/drawingml/2006/main">
               <a:ext uri="{FF2B5EF4-FFF2-40B4-BE49-F238E27FC236}">
-                <a16:creationId xmlns:a16="http://schemas.microsoft.com/office/drawing/2014/main" id="{207474FD-F843-4C16-9CF6-2E4B3241C1E3}"/>
+                <a16:creationId xmlns:a16="http://schemas.microsoft.com/office/drawing/2014/main" id="{1D1C782F-C428-4C79-8835-D33B8F3B3B7E}"/>
               </a:ext>
             </a:extLst>
           </p:cNvPr>
@@ -3962,7 +3962,7 @@
           <p:cNvPr id="12" name="">
             <a:extLst xmlns:a="http://schemas.openxmlformats.org/drawingml/2006/main">
               <a:ext uri="{FF2B5EF4-FFF2-40B4-BE49-F238E27FC236}">
-                <a16:creationId xmlns:a16="http://schemas.microsoft.com/office/drawing/2014/main" id="{83A5FE8C-9A52-409E-A36C-6B0B46C163E9}"/>
+                <a16:creationId xmlns:a16="http://schemas.microsoft.com/office/drawing/2014/main" id="{F27A4C66-B2B2-4402-A596-0876C1002F48}"/>
               </a:ext>
             </a:extLst>
           </p:cNvPr>
@@ -4011,7 +4011,7 @@
           <p:cNvPr id="13" name="">
             <a:extLst xmlns:a="http://schemas.openxmlformats.org/drawingml/2006/main">
               <a:ext uri="{FF2B5EF4-FFF2-40B4-BE49-F238E27FC236}">
-                <a16:creationId xmlns:a16="http://schemas.microsoft.com/office/drawing/2014/main" id="{74B03ADC-F9EE-43B3-AADE-010C02BC8ADB}"/>
+                <a16:creationId xmlns:a16="http://schemas.microsoft.com/office/drawing/2014/main" id="{BAA7A64B-C94F-413B-AE90-C56993B791C1}"/>
               </a:ext>
             </a:extLst>
           </p:cNvPr>
@@ -4060,7 +4060,7 @@
           <p:cNvPr id="14" name="">
             <a:extLst xmlns:a="http://schemas.openxmlformats.org/drawingml/2006/main">
               <a:ext uri="{FF2B5EF4-FFF2-40B4-BE49-F238E27FC236}">
-                <a16:creationId xmlns:a16="http://schemas.microsoft.com/office/drawing/2014/main" id="{6DDAAE15-09FE-48B4-8679-3AEB9CB99847}"/>
+                <a16:creationId xmlns:a16="http://schemas.microsoft.com/office/drawing/2014/main" id="{228022A7-2A58-4B6A-878B-BBA90B76D154}"/>
               </a:ext>
             </a:extLst>
           </p:cNvPr>
@@ -4109,7 +4109,7 @@
           <p:cNvPr id="15" name="">
             <a:extLst xmlns:a="http://schemas.openxmlformats.org/drawingml/2006/main">
               <a:ext uri="{FF2B5EF4-FFF2-40B4-BE49-F238E27FC236}">
-                <a16:creationId xmlns:a16="http://schemas.microsoft.com/office/drawing/2014/main" id="{52F5DAE1-9144-489A-BD7D-DFEA216081BB}"/>
+                <a16:creationId xmlns:a16="http://schemas.microsoft.com/office/drawing/2014/main" id="{F75F33D1-77D6-4014-BB2D-AD5B3D2BF51F}"/>
               </a:ext>
             </a:extLst>
           </p:cNvPr>
@@ -4158,7 +4158,7 @@
           <p:cNvPr id="16" name="">
             <a:extLst xmlns:a="http://schemas.openxmlformats.org/drawingml/2006/main">
               <a:ext uri="{FF2B5EF4-FFF2-40B4-BE49-F238E27FC236}">
-                <a16:creationId xmlns:a16="http://schemas.microsoft.com/office/drawing/2014/main" id="{5C42E8DB-0493-4083-9EA6-3A582BAFE040}"/>
+                <a16:creationId xmlns:a16="http://schemas.microsoft.com/office/drawing/2014/main" id="{162327EF-8AC4-4957-B0F6-9578E104F2AB}"/>
               </a:ext>
             </a:extLst>
           </p:cNvPr>
@@ -4207,7 +4207,7 @@
           <p:cNvPr id="17" name="">
             <a:extLst xmlns:a="http://schemas.openxmlformats.org/drawingml/2006/main">
               <a:ext uri="{FF2B5EF4-FFF2-40B4-BE49-F238E27FC236}">
-                <a16:creationId xmlns:a16="http://schemas.microsoft.com/office/drawing/2014/main" id="{52C0F6E0-62F0-4075-B9E0-27E1D72B606D}"/>
+                <a16:creationId xmlns:a16="http://schemas.microsoft.com/office/drawing/2014/main" id="{8767AB58-2AEF-495B-9C49-331270AB8C2F}"/>
               </a:ext>
             </a:extLst>
           </p:cNvPr>
@@ -4254,7 +4254,7 @@
     </p:spTree>
     <p:extLst>
       <p:ext uri="{BB962C8B-B14F-4D97-AF65-F5344CB8AC3E}">
-        <p14:creationId xmlns:p14="http://schemas.microsoft.com/office/powerpoint/2010/main" val="1519140529"/>
+        <p14:creationId xmlns:p14="http://schemas.microsoft.com/office/powerpoint/2010/main" val="481041649"/>
       </p:ext>
     </p:extLst>
   </p:cSld>
@@ -4285,7 +4285,7 @@
           <p:cNvPr id="13" name="">
             <a:extLst xmlns:a="http://schemas.openxmlformats.org/drawingml/2006/main">
               <a:ext uri="{FF2B5EF4-FFF2-40B4-BE49-F238E27FC236}">
-                <a16:creationId xmlns:a16="http://schemas.microsoft.com/office/drawing/2014/main" id="{5DB2ED2C-064A-4D8C-BDC7-0EACFC75BD24}"/>
+                <a16:creationId xmlns:a16="http://schemas.microsoft.com/office/drawing/2014/main" id="{DBFA0B51-B482-4245-BFB6-581C2E05F016}"/>
               </a:ext>
             </a:extLst>
           </p:cNvPr>
@@ -4334,7 +4334,7 @@
           <p:cNvPr id="2" name="">
             <a:extLst xmlns:a="http://schemas.openxmlformats.org/drawingml/2006/main">
               <a:ext uri="{FF2B5EF4-FFF2-40B4-BE49-F238E27FC236}">
-                <a16:creationId xmlns:a16="http://schemas.microsoft.com/office/drawing/2014/main" id="{D9315D7B-6CEA-4940-A53A-5A8A4D89F584}"/>
+                <a16:creationId xmlns:a16="http://schemas.microsoft.com/office/drawing/2014/main" id="{BC6F5864-929C-4852-B988-6E5FD973E718}"/>
               </a:ext>
             </a:extLst>
           </p:cNvPr>
@@ -4383,7 +4383,7 @@
           <p:cNvPr id="3" name="">
             <a:extLst xmlns:a="http://schemas.openxmlformats.org/drawingml/2006/main">
               <a:ext uri="{FF2B5EF4-FFF2-40B4-BE49-F238E27FC236}">
-                <a16:creationId xmlns:a16="http://schemas.microsoft.com/office/drawing/2014/main" id="{AA208D81-BCBC-4378-A864-344F728997FE}"/>
+                <a16:creationId xmlns:a16="http://schemas.microsoft.com/office/drawing/2014/main" id="{D344709A-CEBA-421E-8C0B-53461280F32B}"/>
               </a:ext>
             </a:extLst>
           </p:cNvPr>
@@ -4432,7 +4432,7 @@
           <p:cNvPr id="4" name="">
             <a:extLst xmlns:a="http://schemas.openxmlformats.org/drawingml/2006/main">
               <a:ext uri="{FF2B5EF4-FFF2-40B4-BE49-F238E27FC236}">
-                <a16:creationId xmlns:a16="http://schemas.microsoft.com/office/drawing/2014/main" id="{E79DB0F1-6BB6-4C03-97CC-22C69177561E}"/>
+                <a16:creationId xmlns:a16="http://schemas.microsoft.com/office/drawing/2014/main" id="{AF771620-B565-4E90-9A4D-3E29C24A7DF1}"/>
               </a:ext>
             </a:extLst>
           </p:cNvPr>
@@ -4481,7 +4481,7 @@
           <p:cNvPr id="5" name="">
             <a:extLst xmlns:a="http://schemas.openxmlformats.org/drawingml/2006/main">
               <a:ext uri="{FF2B5EF4-FFF2-40B4-BE49-F238E27FC236}">
-                <a16:creationId xmlns:a16="http://schemas.microsoft.com/office/drawing/2014/main" id="{61E154B7-3F25-4900-9A6B-F84846CF17B3}"/>
+                <a16:creationId xmlns:a16="http://schemas.microsoft.com/office/drawing/2014/main" id="{B4727020-CA58-439C-9636-EFEF31A402A1}"/>
               </a:ext>
             </a:extLst>
           </p:cNvPr>
@@ -4530,7 +4530,7 @@
           <p:cNvPr id="6" name="">
             <a:extLst xmlns:a="http://schemas.openxmlformats.org/drawingml/2006/main">
               <a:ext uri="{FF2B5EF4-FFF2-40B4-BE49-F238E27FC236}">
-                <a16:creationId xmlns:a16="http://schemas.microsoft.com/office/drawing/2014/main" id="{787DC558-324A-4218-9E7A-D9888EC4C99A}"/>
+                <a16:creationId xmlns:a16="http://schemas.microsoft.com/office/drawing/2014/main" id="{72EC9F56-8E6E-4615-93C4-A6BF9D5996B0}"/>
               </a:ext>
             </a:extLst>
           </p:cNvPr>
@@ -4579,7 +4579,7 @@
           <p:cNvPr id="7" name="">
             <a:extLst xmlns:a="http://schemas.openxmlformats.org/drawingml/2006/main">
               <a:ext uri="{FF2B5EF4-FFF2-40B4-BE49-F238E27FC236}">
-                <a16:creationId xmlns:a16="http://schemas.microsoft.com/office/drawing/2014/main" id="{C5354CBA-A974-40CF-A912-EF63EC978D80}"/>
+                <a16:creationId xmlns:a16="http://schemas.microsoft.com/office/drawing/2014/main" id="{21FB2613-7B1A-4C41-872F-1CB7B2C68B7D}"/>
               </a:ext>
             </a:extLst>
           </p:cNvPr>
@@ -4628,7 +4628,7 @@
           <p:cNvPr id="8" name="">
             <a:extLst xmlns:a="http://schemas.openxmlformats.org/drawingml/2006/main">
               <a:ext uri="{FF2B5EF4-FFF2-40B4-BE49-F238E27FC236}">
-                <a16:creationId xmlns:a16="http://schemas.microsoft.com/office/drawing/2014/main" id="{47834644-0AE1-4A50-A828-475ABEF0345C}"/>
+                <a16:creationId xmlns:a16="http://schemas.microsoft.com/office/drawing/2014/main" id="{EC0E3E7D-6825-4CDB-9BEB-9F9D3660CA82}"/>
               </a:ext>
             </a:extLst>
           </p:cNvPr>
@@ -4677,7 +4677,7 @@
           <p:cNvPr id="9" name="">
             <a:extLst xmlns:a="http://schemas.openxmlformats.org/drawingml/2006/main">
               <a:ext uri="{FF2B5EF4-FFF2-40B4-BE49-F238E27FC236}">
-                <a16:creationId xmlns:a16="http://schemas.microsoft.com/office/drawing/2014/main" id="{07BA5510-7D34-4188-8C92-B8A257F7567D}"/>
+                <a16:creationId xmlns:a16="http://schemas.microsoft.com/office/drawing/2014/main" id="{BD5B991A-E015-4785-9E1E-E75A021B5195}"/>
               </a:ext>
             </a:extLst>
           </p:cNvPr>
@@ -4726,7 +4726,7 @@
           <p:cNvPr id="10" name="">
             <a:extLst xmlns:a="http://schemas.openxmlformats.org/drawingml/2006/main">
               <a:ext uri="{FF2B5EF4-FFF2-40B4-BE49-F238E27FC236}">
-                <a16:creationId xmlns:a16="http://schemas.microsoft.com/office/drawing/2014/main" id="{D2C7ED40-148B-4256-AFF0-D17BE5E47B3D}"/>
+                <a16:creationId xmlns:a16="http://schemas.microsoft.com/office/drawing/2014/main" id="{B5FD56A4-5A00-4810-B34B-A7B02F5AFC41}"/>
               </a:ext>
             </a:extLst>
           </p:cNvPr>
@@ -4775,7 +4775,7 @@
           <p:cNvPr id="11" name="">
             <a:extLst xmlns:a="http://schemas.openxmlformats.org/drawingml/2006/main">
               <a:ext uri="{FF2B5EF4-FFF2-40B4-BE49-F238E27FC236}">
-                <a16:creationId xmlns:a16="http://schemas.microsoft.com/office/drawing/2014/main" id="{A1660A7A-05FE-42F9-95EA-78D0E0A3CC1A}"/>
+                <a16:creationId xmlns:a16="http://schemas.microsoft.com/office/drawing/2014/main" id="{611D020C-52D8-48E7-9861-92641430CE37}"/>
               </a:ext>
             </a:extLst>
           </p:cNvPr>
@@ -4824,7 +4824,7 @@
           <p:cNvPr id="12" name="">
             <a:extLst xmlns:a="http://schemas.openxmlformats.org/drawingml/2006/main">
               <a:ext uri="{FF2B5EF4-FFF2-40B4-BE49-F238E27FC236}">
-                <a16:creationId xmlns:a16="http://schemas.microsoft.com/office/drawing/2014/main" id="{A3A31241-3748-4C63-9DE0-F8415A771FD7}"/>
+                <a16:creationId xmlns:a16="http://schemas.microsoft.com/office/drawing/2014/main" id="{FC0F4215-51E3-4F31-90C8-A2CCA1155C37}"/>
               </a:ext>
             </a:extLst>
           </p:cNvPr>
@@ -4871,7 +4871,7 @@
     </p:spTree>
     <p:extLst>
       <p:ext uri="{BB962C8B-B14F-4D97-AF65-F5344CB8AC3E}">
-        <p14:creationId xmlns:p14="http://schemas.microsoft.com/office/powerpoint/2010/main" val="937994507"/>
+        <p14:creationId xmlns:p14="http://schemas.microsoft.com/office/powerpoint/2010/main" val="1147125696"/>
       </p:ext>
     </p:extLst>
   </p:cSld>
@@ -4902,7 +4902,7 @@
           <p:cNvPr id="15" name="">
             <a:extLst xmlns:a="http://schemas.openxmlformats.org/drawingml/2006/main">
               <a:ext uri="{FF2B5EF4-FFF2-40B4-BE49-F238E27FC236}">
-                <a16:creationId xmlns:a16="http://schemas.microsoft.com/office/drawing/2014/main" id="{E6E84E45-ADC7-4CB9-9C65-D14417FDA752}"/>
+                <a16:creationId xmlns:a16="http://schemas.microsoft.com/office/drawing/2014/main" id="{B582EA0D-62B2-49DF-90B3-849346578B7A}"/>
               </a:ext>
             </a:extLst>
           </p:cNvPr>
@@ -4951,7 +4951,7 @@
           <p:cNvPr id="2" name="">
             <a:extLst xmlns:a="http://schemas.openxmlformats.org/drawingml/2006/main">
               <a:ext uri="{FF2B5EF4-FFF2-40B4-BE49-F238E27FC236}">
-                <a16:creationId xmlns:a16="http://schemas.microsoft.com/office/drawing/2014/main" id="{199C2AC1-5D94-4B93-88E7-3DDAFFD6E960}"/>
+                <a16:creationId xmlns:a16="http://schemas.microsoft.com/office/drawing/2014/main" id="{28BCF7CE-D948-436C-9978-CA0CA945746F}"/>
               </a:ext>
             </a:extLst>
           </p:cNvPr>
@@ -5000,7 +5000,7 @@
           <p:cNvPr id="3" name="">
             <a:extLst xmlns:a="http://schemas.openxmlformats.org/drawingml/2006/main">
               <a:ext uri="{FF2B5EF4-FFF2-40B4-BE49-F238E27FC236}">
-                <a16:creationId xmlns:a16="http://schemas.microsoft.com/office/drawing/2014/main" id="{136E5F82-89CA-401C-BCC0-DF3E3E0DF630}"/>
+                <a16:creationId xmlns:a16="http://schemas.microsoft.com/office/drawing/2014/main" id="{83633B3D-5404-4785-A0FD-B76123BE5070}"/>
               </a:ext>
             </a:extLst>
           </p:cNvPr>
@@ -5049,7 +5049,7 @@
           <p:cNvPr id="4" name="">
             <a:extLst xmlns:a="http://schemas.openxmlformats.org/drawingml/2006/main">
               <a:ext uri="{FF2B5EF4-FFF2-40B4-BE49-F238E27FC236}">
-                <a16:creationId xmlns:a16="http://schemas.microsoft.com/office/drawing/2014/main" id="{98708FCC-8396-4225-8DF9-C4AAAD4EB6A4}"/>
+                <a16:creationId xmlns:a16="http://schemas.microsoft.com/office/drawing/2014/main" id="{430058BE-E6F1-4DFA-8011-DE72EB47E555}"/>
               </a:ext>
             </a:extLst>
           </p:cNvPr>
@@ -5098,7 +5098,7 @@
           <p:cNvPr id="5" name="">
             <a:extLst xmlns:a="http://schemas.openxmlformats.org/drawingml/2006/main">
               <a:ext uri="{FF2B5EF4-FFF2-40B4-BE49-F238E27FC236}">
-                <a16:creationId xmlns:a16="http://schemas.microsoft.com/office/drawing/2014/main" id="{8FA090E7-7C46-4657-B6E8-8A3B24A11CA1}"/>
+                <a16:creationId xmlns:a16="http://schemas.microsoft.com/office/drawing/2014/main" id="{8EE7283E-3031-4A2C-A1F6-17CAC2B46279}"/>
               </a:ext>
             </a:extLst>
           </p:cNvPr>
@@ -5147,7 +5147,7 @@
           <p:cNvPr id="6" name="">
             <a:extLst xmlns:a="http://schemas.openxmlformats.org/drawingml/2006/main">
               <a:ext uri="{FF2B5EF4-FFF2-40B4-BE49-F238E27FC236}">
-                <a16:creationId xmlns:a16="http://schemas.microsoft.com/office/drawing/2014/main" id="{77A1D182-D110-459D-A852-30E029DEEED0}"/>
+                <a16:creationId xmlns:a16="http://schemas.microsoft.com/office/drawing/2014/main" id="{6B5D7A44-85EC-425A-980A-D191F5E34BDB}"/>
               </a:ext>
             </a:extLst>
           </p:cNvPr>
@@ -5196,7 +5196,7 @@
           <p:cNvPr id="7" name="">
             <a:extLst xmlns:a="http://schemas.openxmlformats.org/drawingml/2006/main">
               <a:ext uri="{FF2B5EF4-FFF2-40B4-BE49-F238E27FC236}">
-                <a16:creationId xmlns:a16="http://schemas.microsoft.com/office/drawing/2014/main" id="{735AA4A1-04BC-4A0D-8B99-A9335CDF6A33}"/>
+                <a16:creationId xmlns:a16="http://schemas.microsoft.com/office/drawing/2014/main" id="{A8C02D5F-71E5-4E80-881B-8B7BBC4638D8}"/>
               </a:ext>
             </a:extLst>
           </p:cNvPr>
@@ -5245,7 +5245,7 @@
           <p:cNvPr id="8" name="">
             <a:extLst xmlns:a="http://schemas.openxmlformats.org/drawingml/2006/main">
               <a:ext uri="{FF2B5EF4-FFF2-40B4-BE49-F238E27FC236}">
-                <a16:creationId xmlns:a16="http://schemas.microsoft.com/office/drawing/2014/main" id="{6201F7F4-E4A9-4758-86EC-C74EFDAE3DA9}"/>
+                <a16:creationId xmlns:a16="http://schemas.microsoft.com/office/drawing/2014/main" id="{F7975EBD-8438-4D2C-8ADC-74E8034BDD93}"/>
               </a:ext>
             </a:extLst>
           </p:cNvPr>
@@ -5294,7 +5294,7 @@
           <p:cNvPr id="9" name="">
             <a:extLst xmlns:a="http://schemas.openxmlformats.org/drawingml/2006/main">
               <a:ext uri="{FF2B5EF4-FFF2-40B4-BE49-F238E27FC236}">
-                <a16:creationId xmlns:a16="http://schemas.microsoft.com/office/drawing/2014/main" id="{19DC4BE7-F813-45EE-A958-F30D1F4C914E}"/>
+                <a16:creationId xmlns:a16="http://schemas.microsoft.com/office/drawing/2014/main" id="{0943AB0E-3A5D-4F27-9949-63FD955650E0}"/>
               </a:ext>
             </a:extLst>
           </p:cNvPr>
@@ -5343,7 +5343,7 @@
           <p:cNvPr id="10" name="">
             <a:extLst xmlns:a="http://schemas.openxmlformats.org/drawingml/2006/main">
               <a:ext uri="{FF2B5EF4-FFF2-40B4-BE49-F238E27FC236}">
-                <a16:creationId xmlns:a16="http://schemas.microsoft.com/office/drawing/2014/main" id="{3C1511F3-DFDA-44FB-AC38-B7EE96F27A8B}"/>
+                <a16:creationId xmlns:a16="http://schemas.microsoft.com/office/drawing/2014/main" id="{AF2D8DA3-D263-4512-BA84-AD54B65CB983}"/>
               </a:ext>
             </a:extLst>
           </p:cNvPr>
@@ -5392,7 +5392,7 @@
           <p:cNvPr id="11" name="">
             <a:extLst xmlns:a="http://schemas.openxmlformats.org/drawingml/2006/main">
               <a:ext uri="{FF2B5EF4-FFF2-40B4-BE49-F238E27FC236}">
-                <a16:creationId xmlns:a16="http://schemas.microsoft.com/office/drawing/2014/main" id="{B7CDE3DD-EB72-4DDE-B295-0F65075113B2}"/>
+                <a16:creationId xmlns:a16="http://schemas.microsoft.com/office/drawing/2014/main" id="{10668BC6-5FB9-4507-9F11-AFEB3DE3AE48}"/>
               </a:ext>
             </a:extLst>
           </p:cNvPr>
@@ -5441,7 +5441,7 @@
           <p:cNvPr id="12" name="">
             <a:extLst xmlns:a="http://schemas.openxmlformats.org/drawingml/2006/main">
               <a:ext uri="{FF2B5EF4-FFF2-40B4-BE49-F238E27FC236}">
-                <a16:creationId xmlns:a16="http://schemas.microsoft.com/office/drawing/2014/main" id="{2F44B4CF-ED20-46C5-A28B-F778C7771DE5}"/>
+                <a16:creationId xmlns:a16="http://schemas.microsoft.com/office/drawing/2014/main" id="{F098DDF2-43DB-4D51-8D59-9890A783A6EA}"/>
               </a:ext>
             </a:extLst>
           </p:cNvPr>
@@ -5490,7 +5490,7 @@
           <p:cNvPr id="13" name="">
             <a:extLst xmlns:a="http://schemas.openxmlformats.org/drawingml/2006/main">
               <a:ext uri="{FF2B5EF4-FFF2-40B4-BE49-F238E27FC236}">
-                <a16:creationId xmlns:a16="http://schemas.microsoft.com/office/drawing/2014/main" id="{F9CB96C4-6536-489E-8B1A-A15725AA26C0}"/>
+                <a16:creationId xmlns:a16="http://schemas.microsoft.com/office/drawing/2014/main" id="{13A41D15-3C36-46A8-B976-769DE4D97C26}"/>
               </a:ext>
             </a:extLst>
           </p:cNvPr>
@@ -5539,7 +5539,7 @@
           <p:cNvPr id="14" name="">
             <a:extLst xmlns:a="http://schemas.openxmlformats.org/drawingml/2006/main">
               <a:ext uri="{FF2B5EF4-FFF2-40B4-BE49-F238E27FC236}">
-                <a16:creationId xmlns:a16="http://schemas.microsoft.com/office/drawing/2014/main" id="{BF26BA3C-9F6A-4D13-8E99-8C66E1EFE57F}"/>
+                <a16:creationId xmlns:a16="http://schemas.microsoft.com/office/drawing/2014/main" id="{C01B87A0-6966-4EBA-80E0-86EEA4DBB1C6}"/>
               </a:ext>
             </a:extLst>
           </p:cNvPr>
@@ -5586,7 +5586,7 @@
     </p:spTree>
     <p:extLst>
       <p:ext uri="{BB962C8B-B14F-4D97-AF65-F5344CB8AC3E}">
-        <p14:creationId xmlns:p14="http://schemas.microsoft.com/office/powerpoint/2010/main" val="1569024353"/>
+        <p14:creationId xmlns:p14="http://schemas.microsoft.com/office/powerpoint/2010/main" val="194825126"/>
       </p:ext>
     </p:extLst>
   </p:cSld>
@@ -5617,7 +5617,7 @@
           <p:cNvPr id="11" name="">
             <a:extLst xmlns:a="http://schemas.openxmlformats.org/drawingml/2006/main">
               <a:ext uri="{FF2B5EF4-FFF2-40B4-BE49-F238E27FC236}">
-                <a16:creationId xmlns:a16="http://schemas.microsoft.com/office/drawing/2014/main" id="{8FADBE6E-39DB-49AC-9CC3-6D9206B7AB39}"/>
+                <a16:creationId xmlns:a16="http://schemas.microsoft.com/office/drawing/2014/main" id="{2704A80B-17E9-48BB-97E4-569105D0B691}"/>
               </a:ext>
             </a:extLst>
           </p:cNvPr>
@@ -5666,7 +5666,7 @@
           <p:cNvPr id="2" name="">
             <a:extLst xmlns:a="http://schemas.openxmlformats.org/drawingml/2006/main">
               <a:ext uri="{FF2B5EF4-FFF2-40B4-BE49-F238E27FC236}">
-                <a16:creationId xmlns:a16="http://schemas.microsoft.com/office/drawing/2014/main" id="{2E8E77BB-E1A6-4D48-B162-E31F9DBF650A}"/>
+                <a16:creationId xmlns:a16="http://schemas.microsoft.com/office/drawing/2014/main" id="{973A2E1C-FC1A-420C-A10C-B8A65AAE5FB2}"/>
               </a:ext>
             </a:extLst>
           </p:cNvPr>
@@ -5715,7 +5715,7 @@
           <p:cNvPr id="3" name="">
             <a:extLst xmlns:a="http://schemas.openxmlformats.org/drawingml/2006/main">
               <a:ext uri="{FF2B5EF4-FFF2-40B4-BE49-F238E27FC236}">
-                <a16:creationId xmlns:a16="http://schemas.microsoft.com/office/drawing/2014/main" id="{B077168A-7839-420A-8389-D69A4797CD28}"/>
+                <a16:creationId xmlns:a16="http://schemas.microsoft.com/office/drawing/2014/main" id="{AC75AE3A-5F01-48B9-8ABD-F00AA09A616A}"/>
               </a:ext>
             </a:extLst>
           </p:cNvPr>
@@ -5764,7 +5764,7 @@
           <p:cNvPr id="4" name="">
             <a:extLst xmlns:a="http://schemas.openxmlformats.org/drawingml/2006/main">
               <a:ext uri="{FF2B5EF4-FFF2-40B4-BE49-F238E27FC236}">
-                <a16:creationId xmlns:a16="http://schemas.microsoft.com/office/drawing/2014/main" id="{185980E9-3EB4-40DE-86D6-328563E782EA}"/>
+                <a16:creationId xmlns:a16="http://schemas.microsoft.com/office/drawing/2014/main" id="{67F08BAB-FA52-43F9-892B-0CC8C9CB1379}"/>
               </a:ext>
             </a:extLst>
           </p:cNvPr>
@@ -5813,7 +5813,7 @@
           <p:cNvPr id="5" name="">
             <a:extLst xmlns:a="http://schemas.openxmlformats.org/drawingml/2006/main">
               <a:ext uri="{FF2B5EF4-FFF2-40B4-BE49-F238E27FC236}">
-                <a16:creationId xmlns:a16="http://schemas.microsoft.com/office/drawing/2014/main" id="{3D24CAFD-B548-460F-BAB9-541CDFD44AAA}"/>
+                <a16:creationId xmlns:a16="http://schemas.microsoft.com/office/drawing/2014/main" id="{7328FBF8-C43E-4979-A1BE-13AB5A8283D9}"/>
               </a:ext>
             </a:extLst>
           </p:cNvPr>
@@ -5862,7 +5862,7 @@
           <p:cNvPr id="6" name="">
             <a:extLst xmlns:a="http://schemas.openxmlformats.org/drawingml/2006/main">
               <a:ext uri="{FF2B5EF4-FFF2-40B4-BE49-F238E27FC236}">
-                <a16:creationId xmlns:a16="http://schemas.microsoft.com/office/drawing/2014/main" id="{D96719B8-D13B-4FDE-82BE-D87514FE7433}"/>
+                <a16:creationId xmlns:a16="http://schemas.microsoft.com/office/drawing/2014/main" id="{E2E75913-5F99-4EA0-996B-6FF39E7BDFA5}"/>
               </a:ext>
             </a:extLst>
           </p:cNvPr>
@@ -5911,7 +5911,7 @@
           <p:cNvPr id="7" name="">
             <a:extLst xmlns:a="http://schemas.openxmlformats.org/drawingml/2006/main">
               <a:ext uri="{FF2B5EF4-FFF2-40B4-BE49-F238E27FC236}">
-                <a16:creationId xmlns:a16="http://schemas.microsoft.com/office/drawing/2014/main" id="{ABD2D795-7F88-48F8-9584-39642AF16F39}"/>
+                <a16:creationId xmlns:a16="http://schemas.microsoft.com/office/drawing/2014/main" id="{E408F8E3-2C5A-4996-BBCA-858C21075A9D}"/>
               </a:ext>
             </a:extLst>
           </p:cNvPr>
@@ -5990,7 +5990,7 @@
           <p:cNvPr id="8" name="">
             <a:extLst xmlns:a="http://schemas.openxmlformats.org/drawingml/2006/main">
               <a:ext uri="{FF2B5EF4-FFF2-40B4-BE49-F238E27FC236}">
-                <a16:creationId xmlns:a16="http://schemas.microsoft.com/office/drawing/2014/main" id="{D130EB0C-BC99-43C0-A873-6C5A0C6139B4}"/>
+                <a16:creationId xmlns:a16="http://schemas.microsoft.com/office/drawing/2014/main" id="{15928F44-76A2-497D-8A89-E682776408AA}"/>
               </a:ext>
             </a:extLst>
           </p:cNvPr>
@@ -6039,7 +6039,7 @@
           <p:cNvPr id="9" name="">
             <a:extLst xmlns:a="http://schemas.openxmlformats.org/drawingml/2006/main">
               <a:ext uri="{FF2B5EF4-FFF2-40B4-BE49-F238E27FC236}">
-                <a16:creationId xmlns:a16="http://schemas.microsoft.com/office/drawing/2014/main" id="{F3CCFB39-E0C5-402C-B4FD-9D3A945D42BE}"/>
+                <a16:creationId xmlns:a16="http://schemas.microsoft.com/office/drawing/2014/main" id="{46BAEAB4-7741-41D8-9ED6-E1D23BC2A280}"/>
               </a:ext>
             </a:extLst>
           </p:cNvPr>
@@ -6118,7 +6118,7 @@
           <p:cNvPr id="10" name="">
             <a:extLst xmlns:a="http://schemas.openxmlformats.org/drawingml/2006/main">
               <a:ext uri="{FF2B5EF4-FFF2-40B4-BE49-F238E27FC236}">
-                <a16:creationId xmlns:a16="http://schemas.microsoft.com/office/drawing/2014/main" id="{B66EC38F-AABE-4732-93B4-5E882865FE61}"/>
+                <a16:creationId xmlns:a16="http://schemas.microsoft.com/office/drawing/2014/main" id="{5EE4777C-0A02-4AF3-8C10-B286BED2CEA2}"/>
               </a:ext>
             </a:extLst>
           </p:cNvPr>
@@ -6165,7 +6165,7 @@
     </p:spTree>
     <p:extLst>
       <p:ext uri="{BB962C8B-B14F-4D97-AF65-F5344CB8AC3E}">
-        <p14:creationId xmlns:p14="http://schemas.microsoft.com/office/powerpoint/2010/main" val="1567710317"/>
+        <p14:creationId xmlns:p14="http://schemas.microsoft.com/office/powerpoint/2010/main" val="802699711"/>
       </p:ext>
     </p:extLst>
   </p:cSld>
@@ -6196,7 +6196,7 @@
           <p:cNvPr id="13" name="">
             <a:extLst xmlns:a="http://schemas.openxmlformats.org/drawingml/2006/main">
               <a:ext uri="{FF2B5EF4-FFF2-40B4-BE49-F238E27FC236}">
-                <a16:creationId xmlns:a16="http://schemas.microsoft.com/office/drawing/2014/main" id="{8AAE542F-AC5B-4FD1-9CE6-EA2B7D4EA691}"/>
+                <a16:creationId xmlns:a16="http://schemas.microsoft.com/office/drawing/2014/main" id="{45B45CB2-7A66-430A-8D91-A55306A6B2EC}"/>
               </a:ext>
             </a:extLst>
           </p:cNvPr>
@@ -6245,7 +6245,7 @@
           <p:cNvPr id="2" name="">
             <a:extLst xmlns:a="http://schemas.openxmlformats.org/drawingml/2006/main">
               <a:ext uri="{FF2B5EF4-FFF2-40B4-BE49-F238E27FC236}">
-                <a16:creationId xmlns:a16="http://schemas.microsoft.com/office/drawing/2014/main" id="{61C9EFB1-24EC-44E8-BCB6-1400CB4F5EA9}"/>
+                <a16:creationId xmlns:a16="http://schemas.microsoft.com/office/drawing/2014/main" id="{21355D77-1B65-4AD5-9D05-947413AB2932}"/>
               </a:ext>
             </a:extLst>
           </p:cNvPr>
@@ -6294,7 +6294,7 @@
           <p:cNvPr id="3" name="">
             <a:extLst xmlns:a="http://schemas.openxmlformats.org/drawingml/2006/main">
               <a:ext uri="{FF2B5EF4-FFF2-40B4-BE49-F238E27FC236}">
-                <a16:creationId xmlns:a16="http://schemas.microsoft.com/office/drawing/2014/main" id="{9014FF10-91A7-4C75-AE72-2847347AC5AE}"/>
+                <a16:creationId xmlns:a16="http://schemas.microsoft.com/office/drawing/2014/main" id="{D124339D-CD61-4510-87C1-0DF6BDCF0779}"/>
               </a:ext>
             </a:extLst>
           </p:cNvPr>
@@ -6343,7 +6343,7 @@
           <p:cNvPr id="4" name="">
             <a:extLst xmlns:a="http://schemas.openxmlformats.org/drawingml/2006/main">
               <a:ext uri="{FF2B5EF4-FFF2-40B4-BE49-F238E27FC236}">
-                <a16:creationId xmlns:a16="http://schemas.microsoft.com/office/drawing/2014/main" id="{AA40FDCF-EB21-4650-89AF-5C794D1DE528}"/>
+                <a16:creationId xmlns:a16="http://schemas.microsoft.com/office/drawing/2014/main" id="{E3021B5B-8EC9-4261-9F46-98B2F8136F14}"/>
               </a:ext>
             </a:extLst>
           </p:cNvPr>
@@ -6392,7 +6392,7 @@
           <p:cNvPr id="5" name="">
             <a:extLst xmlns:a="http://schemas.openxmlformats.org/drawingml/2006/main">
               <a:ext uri="{FF2B5EF4-FFF2-40B4-BE49-F238E27FC236}">
-                <a16:creationId xmlns:a16="http://schemas.microsoft.com/office/drawing/2014/main" id="{BD2387FE-9E8E-40F1-AEDF-31BD3C377FA2}"/>
+                <a16:creationId xmlns:a16="http://schemas.microsoft.com/office/drawing/2014/main" id="{C6E1291F-33FB-4721-B804-07C50EF19851}"/>
               </a:ext>
             </a:extLst>
           </p:cNvPr>
@@ -6441,7 +6441,7 @@
           <p:cNvPr id="6" name="">
             <a:extLst xmlns:a="http://schemas.openxmlformats.org/drawingml/2006/main">
               <a:ext uri="{FF2B5EF4-FFF2-40B4-BE49-F238E27FC236}">
-                <a16:creationId xmlns:a16="http://schemas.microsoft.com/office/drawing/2014/main" id="{2826F98E-F0E9-4487-8853-015DD1EF8121}"/>
+                <a16:creationId xmlns:a16="http://schemas.microsoft.com/office/drawing/2014/main" id="{4360E3ED-D917-41E3-989E-10B23FEAF50A}"/>
               </a:ext>
             </a:extLst>
           </p:cNvPr>
@@ -6490,7 +6490,7 @@
           <p:cNvPr id="7" name="">
             <a:extLst xmlns:a="http://schemas.openxmlformats.org/drawingml/2006/main">
               <a:ext uri="{FF2B5EF4-FFF2-40B4-BE49-F238E27FC236}">
-                <a16:creationId xmlns:a16="http://schemas.microsoft.com/office/drawing/2014/main" id="{87D219FD-FF8E-4694-A0DF-A60401237CA6}"/>
+                <a16:creationId xmlns:a16="http://schemas.microsoft.com/office/drawing/2014/main" id="{7FB3CBEB-3B8A-4B13-9875-5E49D183925C}"/>
               </a:ext>
             </a:extLst>
           </p:cNvPr>
@@ -6539,7 +6539,7 @@
           <p:cNvPr id="8" name="">
             <a:extLst xmlns:a="http://schemas.openxmlformats.org/drawingml/2006/main">
               <a:ext uri="{FF2B5EF4-FFF2-40B4-BE49-F238E27FC236}">
-                <a16:creationId xmlns:a16="http://schemas.microsoft.com/office/drawing/2014/main" id="{0BD65A2A-A4FC-434B-8E33-4AAD75F0DDD4}"/>
+                <a16:creationId xmlns:a16="http://schemas.microsoft.com/office/drawing/2014/main" id="{F76A7D07-5855-46A7-B256-60AD7D98CCE1}"/>
               </a:ext>
             </a:extLst>
           </p:cNvPr>
@@ -6588,7 +6588,7 @@
           <p:cNvPr id="9" name="">
             <a:extLst xmlns:a="http://schemas.openxmlformats.org/drawingml/2006/main">
               <a:ext uri="{FF2B5EF4-FFF2-40B4-BE49-F238E27FC236}">
-                <a16:creationId xmlns:a16="http://schemas.microsoft.com/office/drawing/2014/main" id="{A92DD564-93BE-451C-87BE-EB37CA5D80A3}"/>
+                <a16:creationId xmlns:a16="http://schemas.microsoft.com/office/drawing/2014/main" id="{EC62EB98-1DBF-41F6-A37C-7B9F77EE402D}"/>
               </a:ext>
             </a:extLst>
           </p:cNvPr>
@@ -6637,7 +6637,7 @@
           <p:cNvPr id="10" name="">
             <a:extLst xmlns:a="http://schemas.openxmlformats.org/drawingml/2006/main">
               <a:ext uri="{FF2B5EF4-FFF2-40B4-BE49-F238E27FC236}">
-                <a16:creationId xmlns:a16="http://schemas.microsoft.com/office/drawing/2014/main" id="{FB1A1641-2D30-4B59-8FBA-105B306B7884}"/>
+                <a16:creationId xmlns:a16="http://schemas.microsoft.com/office/drawing/2014/main" id="{CF5B268D-868A-42DE-A799-56CD4B42F2B1}"/>
               </a:ext>
             </a:extLst>
           </p:cNvPr>
@@ -6686,7 +6686,7 @@
           <p:cNvPr id="11" name="">
             <a:extLst xmlns:a="http://schemas.openxmlformats.org/drawingml/2006/main">
               <a:ext uri="{FF2B5EF4-FFF2-40B4-BE49-F238E27FC236}">
-                <a16:creationId xmlns:a16="http://schemas.microsoft.com/office/drawing/2014/main" id="{5AB3FC2B-6258-46CD-8A7E-15958A4432E9}"/>
+                <a16:creationId xmlns:a16="http://schemas.microsoft.com/office/drawing/2014/main" id="{B602461F-1E9D-4FE6-9D5C-6A8039CB1EC9}"/>
               </a:ext>
             </a:extLst>
           </p:cNvPr>
@@ -6735,7 +6735,7 @@
           <p:cNvPr id="12" name="">
             <a:extLst xmlns:a="http://schemas.openxmlformats.org/drawingml/2006/main">
               <a:ext uri="{FF2B5EF4-FFF2-40B4-BE49-F238E27FC236}">
-                <a16:creationId xmlns:a16="http://schemas.microsoft.com/office/drawing/2014/main" id="{D4C25CC8-6CFB-42AF-861A-053F338FF4AD}"/>
+                <a16:creationId xmlns:a16="http://schemas.microsoft.com/office/drawing/2014/main" id="{B7716CDD-71BC-4B93-B8CD-595BE549A3AB}"/>
               </a:ext>
             </a:extLst>
           </p:cNvPr>
@@ -6782,7 +6782,7 @@
     </p:spTree>
     <p:extLst>
       <p:ext uri="{BB962C8B-B14F-4D97-AF65-F5344CB8AC3E}">
-        <p14:creationId xmlns:p14="http://schemas.microsoft.com/office/powerpoint/2010/main" val="29656834"/>
+        <p14:creationId xmlns:p14="http://schemas.microsoft.com/office/powerpoint/2010/main" val="793401877"/>
       </p:ext>
     </p:extLst>
   </p:cSld>
@@ -6813,7 +6813,7 @@
           <p:cNvPr id="17" name="">
             <a:extLst xmlns:a="http://schemas.openxmlformats.org/drawingml/2006/main">
               <a:ext uri="{FF2B5EF4-FFF2-40B4-BE49-F238E27FC236}">
-                <a16:creationId xmlns:a16="http://schemas.microsoft.com/office/drawing/2014/main" id="{60814971-006D-4CC4-8A82-FA540D6A0880}"/>
+                <a16:creationId xmlns:a16="http://schemas.microsoft.com/office/drawing/2014/main" id="{E837976F-DFD4-46A7-8C6D-BC3FDB143D81}"/>
               </a:ext>
             </a:extLst>
           </p:cNvPr>
@@ -6862,7 +6862,7 @@
           <p:cNvPr id="2" name="">
             <a:extLst xmlns:a="http://schemas.openxmlformats.org/drawingml/2006/main">
               <a:ext uri="{FF2B5EF4-FFF2-40B4-BE49-F238E27FC236}">
-                <a16:creationId xmlns:a16="http://schemas.microsoft.com/office/drawing/2014/main" id="{2229B3BD-0456-4AA3-B0AC-4F4F96FEED16}"/>
+                <a16:creationId xmlns:a16="http://schemas.microsoft.com/office/drawing/2014/main" id="{CA506B19-A09C-4D03-882D-362F3FDE7909}"/>
               </a:ext>
             </a:extLst>
           </p:cNvPr>
@@ -6911,7 +6911,7 @@
           <p:cNvPr id="3" name="">
             <a:extLst xmlns:a="http://schemas.openxmlformats.org/drawingml/2006/main">
               <a:ext uri="{FF2B5EF4-FFF2-40B4-BE49-F238E27FC236}">
-                <a16:creationId xmlns:a16="http://schemas.microsoft.com/office/drawing/2014/main" id="{80FC6EB8-B97A-44E0-9676-F9AFE8B4F50E}"/>
+                <a16:creationId xmlns:a16="http://schemas.microsoft.com/office/drawing/2014/main" id="{BBB6C73B-B390-4C73-932A-32FDC1106C76}"/>
               </a:ext>
             </a:extLst>
           </p:cNvPr>
@@ -6960,7 +6960,7 @@
           <p:cNvPr id="4" name="">
             <a:extLst xmlns:a="http://schemas.openxmlformats.org/drawingml/2006/main">
               <a:ext uri="{FF2B5EF4-FFF2-40B4-BE49-F238E27FC236}">
-                <a16:creationId xmlns:a16="http://schemas.microsoft.com/office/drawing/2014/main" id="{E8DC6809-2D7B-4B69-A41A-95CF8B294BC1}"/>
+                <a16:creationId xmlns:a16="http://schemas.microsoft.com/office/drawing/2014/main" id="{EC4EC9EE-553D-45EC-856A-FDA391016998}"/>
               </a:ext>
             </a:extLst>
           </p:cNvPr>
@@ -7009,7 +7009,7 @@
           <p:cNvPr id="5" name="">
             <a:extLst xmlns:a="http://schemas.openxmlformats.org/drawingml/2006/main">
               <a:ext uri="{FF2B5EF4-FFF2-40B4-BE49-F238E27FC236}">
-                <a16:creationId xmlns:a16="http://schemas.microsoft.com/office/drawing/2014/main" id="{05F4784C-5815-46CF-9896-33A10A7E314F}"/>
+                <a16:creationId xmlns:a16="http://schemas.microsoft.com/office/drawing/2014/main" id="{F62BA77A-170F-4F2A-8E5C-FFAF13FA6C6D}"/>
               </a:ext>
             </a:extLst>
           </p:cNvPr>
@@ -7058,7 +7058,7 @@
           <p:cNvPr id="6" name="">
             <a:extLst xmlns:a="http://schemas.openxmlformats.org/drawingml/2006/main">
               <a:ext uri="{FF2B5EF4-FFF2-40B4-BE49-F238E27FC236}">
-                <a16:creationId xmlns:a16="http://schemas.microsoft.com/office/drawing/2014/main" id="{AABDD147-39ED-46F7-B575-E2E3084EEA4B}"/>
+                <a16:creationId xmlns:a16="http://schemas.microsoft.com/office/drawing/2014/main" id="{4E3CCBE4-E592-4E93-AD04-4E56E66A0667}"/>
               </a:ext>
             </a:extLst>
           </p:cNvPr>
@@ -7107,7 +7107,7 @@
           <p:cNvPr id="7" name="">
             <a:extLst xmlns:a="http://schemas.openxmlformats.org/drawingml/2006/main">
               <a:ext uri="{FF2B5EF4-FFF2-40B4-BE49-F238E27FC236}">
-                <a16:creationId xmlns:a16="http://schemas.microsoft.com/office/drawing/2014/main" id="{D596C0CB-959B-412E-BA6E-3DD4B94ADDBE}"/>
+                <a16:creationId xmlns:a16="http://schemas.microsoft.com/office/drawing/2014/main" id="{5360B9B8-6F3C-4ECD-9EB9-00A4D4CCB480}"/>
               </a:ext>
             </a:extLst>
           </p:cNvPr>
@@ -7156,7 +7156,7 @@
           <p:cNvPr id="8" name="">
             <a:extLst xmlns:a="http://schemas.openxmlformats.org/drawingml/2006/main">
               <a:ext uri="{FF2B5EF4-FFF2-40B4-BE49-F238E27FC236}">
-                <a16:creationId xmlns:a16="http://schemas.microsoft.com/office/drawing/2014/main" id="{32A9B58C-D471-4CFE-AB52-E12B4A84C2CA}"/>
+                <a16:creationId xmlns:a16="http://schemas.microsoft.com/office/drawing/2014/main" id="{7F5AEDED-F0E1-4E17-9B01-60101A319667}"/>
               </a:ext>
             </a:extLst>
           </p:cNvPr>
@@ -7205,7 +7205,7 @@
           <p:cNvPr id="9" name="">
             <a:extLst xmlns:a="http://schemas.openxmlformats.org/drawingml/2006/main">
               <a:ext uri="{FF2B5EF4-FFF2-40B4-BE49-F238E27FC236}">
-                <a16:creationId xmlns:a16="http://schemas.microsoft.com/office/drawing/2014/main" id="{45538322-5C4B-4D92-9A73-2C690A4B58AA}"/>
+                <a16:creationId xmlns:a16="http://schemas.microsoft.com/office/drawing/2014/main" id="{E31BCF4C-C2EB-4972-8DC5-FE8119A506AC}"/>
               </a:ext>
             </a:extLst>
           </p:cNvPr>
@@ -7254,7 +7254,7 @@
           <p:cNvPr id="10" name="">
             <a:extLst xmlns:a="http://schemas.openxmlformats.org/drawingml/2006/main">
               <a:ext uri="{FF2B5EF4-FFF2-40B4-BE49-F238E27FC236}">
-                <a16:creationId xmlns:a16="http://schemas.microsoft.com/office/drawing/2014/main" id="{A5A47C87-6664-4880-A3F7-D2A63ACF73DF}"/>
+                <a16:creationId xmlns:a16="http://schemas.microsoft.com/office/drawing/2014/main" id="{E76B1C16-845F-4E68-993D-A29BDC86B2CC}"/>
               </a:ext>
             </a:extLst>
           </p:cNvPr>
@@ -7303,7 +7303,7 @@
           <p:cNvPr id="11" name="">
             <a:extLst xmlns:a="http://schemas.openxmlformats.org/drawingml/2006/main">
               <a:ext uri="{FF2B5EF4-FFF2-40B4-BE49-F238E27FC236}">
-                <a16:creationId xmlns:a16="http://schemas.microsoft.com/office/drawing/2014/main" id="{23B68B33-C61A-445F-8A66-7A0B5243D375}"/>
+                <a16:creationId xmlns:a16="http://schemas.microsoft.com/office/drawing/2014/main" id="{E92CD147-A96C-4DD4-BA3D-E6358F9AC039}"/>
               </a:ext>
             </a:extLst>
           </p:cNvPr>
@@ -7352,7 +7352,7 @@
           <p:cNvPr id="12" name="">
             <a:extLst xmlns:a="http://schemas.openxmlformats.org/drawingml/2006/main">
               <a:ext uri="{FF2B5EF4-FFF2-40B4-BE49-F238E27FC236}">
-                <a16:creationId xmlns:a16="http://schemas.microsoft.com/office/drawing/2014/main" id="{128911DA-08AA-4507-BAE5-C5B77C5AE012}"/>
+                <a16:creationId xmlns:a16="http://schemas.microsoft.com/office/drawing/2014/main" id="{6BA9529F-FAAA-42B3-B214-1DCB89B7B108}"/>
               </a:ext>
             </a:extLst>
           </p:cNvPr>
@@ -7401,7 +7401,7 @@
           <p:cNvPr id="13" name="">
             <a:extLst xmlns:a="http://schemas.openxmlformats.org/drawingml/2006/main">
               <a:ext uri="{FF2B5EF4-FFF2-40B4-BE49-F238E27FC236}">
-                <a16:creationId xmlns:a16="http://schemas.microsoft.com/office/drawing/2014/main" id="{EE7AB9BA-5E71-4010-98A3-7E5F8C738143}"/>
+                <a16:creationId xmlns:a16="http://schemas.microsoft.com/office/drawing/2014/main" id="{8E578EC0-B146-4BB3-8453-F69BDB5E2A96}"/>
               </a:ext>
             </a:extLst>
           </p:cNvPr>
@@ -7450,7 +7450,7 @@
           <p:cNvPr id="14" name="">
             <a:extLst xmlns:a="http://schemas.openxmlformats.org/drawingml/2006/main">
               <a:ext uri="{FF2B5EF4-FFF2-40B4-BE49-F238E27FC236}">
-                <a16:creationId xmlns:a16="http://schemas.microsoft.com/office/drawing/2014/main" id="{4DA7AC3D-0451-49AE-8264-49F076D0DF4E}"/>
+                <a16:creationId xmlns:a16="http://schemas.microsoft.com/office/drawing/2014/main" id="{B22EE90C-CDCD-4C65-8AC1-F0DDE04EC873}"/>
               </a:ext>
             </a:extLst>
           </p:cNvPr>
@@ -7499,7 +7499,7 @@
           <p:cNvPr id="15" name="">
             <a:extLst xmlns:a="http://schemas.openxmlformats.org/drawingml/2006/main">
               <a:ext uri="{FF2B5EF4-FFF2-40B4-BE49-F238E27FC236}">
-                <a16:creationId xmlns:a16="http://schemas.microsoft.com/office/drawing/2014/main" id="{8BCCEC76-FC05-410D-981C-0F3E844C33C0}"/>
+                <a16:creationId xmlns:a16="http://schemas.microsoft.com/office/drawing/2014/main" id="{E280BB4B-E9A0-4AD0-AD77-C4623C8515B3}"/>
               </a:ext>
             </a:extLst>
           </p:cNvPr>
@@ -7548,7 +7548,7 @@
           <p:cNvPr id="16" name="">
             <a:extLst xmlns:a="http://schemas.openxmlformats.org/drawingml/2006/main">
               <a:ext uri="{FF2B5EF4-FFF2-40B4-BE49-F238E27FC236}">
-                <a16:creationId xmlns:a16="http://schemas.microsoft.com/office/drawing/2014/main" id="{8AC8D2BC-C502-4C14-99E6-20CB10D9A4ED}"/>
+                <a16:creationId xmlns:a16="http://schemas.microsoft.com/office/drawing/2014/main" id="{52703072-0339-4C4A-9532-830B71F46A75}"/>
               </a:ext>
             </a:extLst>
           </p:cNvPr>
@@ -7595,7 +7595,7 @@
     </p:spTree>
     <p:extLst>
       <p:ext uri="{BB962C8B-B14F-4D97-AF65-F5344CB8AC3E}">
-        <p14:creationId xmlns:p14="http://schemas.microsoft.com/office/powerpoint/2010/main" val="206892672"/>
+        <p14:creationId xmlns:p14="http://schemas.microsoft.com/office/powerpoint/2010/main" val="1656667246"/>
       </p:ext>
     </p:extLst>
   </p:cSld>
@@ -7626,7 +7626,7 @@
           <p:cNvPr id="15" name="">
             <a:extLst xmlns:a="http://schemas.openxmlformats.org/drawingml/2006/main">
               <a:ext uri="{FF2B5EF4-FFF2-40B4-BE49-F238E27FC236}">
-                <a16:creationId xmlns:a16="http://schemas.microsoft.com/office/drawing/2014/main" id="{E253349A-B061-47C5-9065-C35F549069F5}"/>
+                <a16:creationId xmlns:a16="http://schemas.microsoft.com/office/drawing/2014/main" id="{B8D27034-29E0-4F4D-8ED7-7EFDBF39B858}"/>
               </a:ext>
             </a:extLst>
           </p:cNvPr>
@@ -7675,7 +7675,7 @@
           <p:cNvPr id="2" name="">
             <a:extLst xmlns:a="http://schemas.openxmlformats.org/drawingml/2006/main">
               <a:ext uri="{FF2B5EF4-FFF2-40B4-BE49-F238E27FC236}">
-                <a16:creationId xmlns:a16="http://schemas.microsoft.com/office/drawing/2014/main" id="{4244E1B0-3C48-479E-BBC5-15632CFA3F09}"/>
+                <a16:creationId xmlns:a16="http://schemas.microsoft.com/office/drawing/2014/main" id="{2336C919-1854-4EA1-9AF3-F64C5DB2CCF2}"/>
               </a:ext>
             </a:extLst>
           </p:cNvPr>
@@ -7724,7 +7724,7 @@
           <p:cNvPr id="3" name="">
             <a:extLst xmlns:a="http://schemas.openxmlformats.org/drawingml/2006/main">
               <a:ext uri="{FF2B5EF4-FFF2-40B4-BE49-F238E27FC236}">
-                <a16:creationId xmlns:a16="http://schemas.microsoft.com/office/drawing/2014/main" id="{311DDBCC-EFD6-42FE-8ABD-2D3D2F3A8ADA}"/>
+                <a16:creationId xmlns:a16="http://schemas.microsoft.com/office/drawing/2014/main" id="{880E0BA1-E0BA-4CC1-A69E-24F619CBEB3D}"/>
               </a:ext>
             </a:extLst>
           </p:cNvPr>
@@ -7773,7 +7773,7 @@
           <p:cNvPr id="4" name="">
             <a:extLst xmlns:a="http://schemas.openxmlformats.org/drawingml/2006/main">
               <a:ext uri="{FF2B5EF4-FFF2-40B4-BE49-F238E27FC236}">
-                <a16:creationId xmlns:a16="http://schemas.microsoft.com/office/drawing/2014/main" id="{F01BF8A9-A7BD-4A2A-BA52-8DF98B6C9F53}"/>
+                <a16:creationId xmlns:a16="http://schemas.microsoft.com/office/drawing/2014/main" id="{49F336DD-3691-40C8-973B-86A7D0097BCD}"/>
               </a:ext>
             </a:extLst>
           </p:cNvPr>
@@ -7822,7 +7822,7 @@
           <p:cNvPr id="5" name="">
             <a:extLst xmlns:a="http://schemas.openxmlformats.org/drawingml/2006/main">
               <a:ext uri="{FF2B5EF4-FFF2-40B4-BE49-F238E27FC236}">
-                <a16:creationId xmlns:a16="http://schemas.microsoft.com/office/drawing/2014/main" id="{E3A3A30A-936D-4C7C-A992-AFBD1A2991A0}"/>
+                <a16:creationId xmlns:a16="http://schemas.microsoft.com/office/drawing/2014/main" id="{27762F55-D04F-41C0-A5AC-F2B51B310ED8}"/>
               </a:ext>
             </a:extLst>
           </p:cNvPr>
@@ -7871,7 +7871,7 @@
           <p:cNvPr id="6" name="">
             <a:extLst xmlns:a="http://schemas.openxmlformats.org/drawingml/2006/main">
               <a:ext uri="{FF2B5EF4-FFF2-40B4-BE49-F238E27FC236}">
-                <a16:creationId xmlns:a16="http://schemas.microsoft.com/office/drawing/2014/main" id="{A7AF3DB4-16A3-474B-A4F8-FE8A001CFB93}"/>
+                <a16:creationId xmlns:a16="http://schemas.microsoft.com/office/drawing/2014/main" id="{0A7945DE-7C5F-4EC1-80F1-417DEED73A5F}"/>
               </a:ext>
             </a:extLst>
           </p:cNvPr>
@@ -7920,7 +7920,7 @@
           <p:cNvPr id="7" name="">
             <a:extLst xmlns:a="http://schemas.openxmlformats.org/drawingml/2006/main">
               <a:ext uri="{FF2B5EF4-FFF2-40B4-BE49-F238E27FC236}">
-                <a16:creationId xmlns:a16="http://schemas.microsoft.com/office/drawing/2014/main" id="{D90AFC4A-175A-49D2-9F65-DC72BCD43497}"/>
+                <a16:creationId xmlns:a16="http://schemas.microsoft.com/office/drawing/2014/main" id="{54F3A3C6-3111-43CC-9FB8-B550447A1A78}"/>
               </a:ext>
             </a:extLst>
           </p:cNvPr>
@@ -7969,7 +7969,7 @@
           <p:cNvPr id="8" name="">
             <a:extLst xmlns:a="http://schemas.openxmlformats.org/drawingml/2006/main">
               <a:ext uri="{FF2B5EF4-FFF2-40B4-BE49-F238E27FC236}">
-                <a16:creationId xmlns:a16="http://schemas.microsoft.com/office/drawing/2014/main" id="{614C20D3-3CE9-4E60-B3E3-612F01AE3E3A}"/>
+                <a16:creationId xmlns:a16="http://schemas.microsoft.com/office/drawing/2014/main" id="{535220A5-3D6B-4A26-9A9F-EF1667A8818E}"/>
               </a:ext>
             </a:extLst>
           </p:cNvPr>
@@ -8018,7 +8018,7 @@
           <p:cNvPr id="9" name="">
             <a:extLst xmlns:a="http://schemas.openxmlformats.org/drawingml/2006/main">
               <a:ext uri="{FF2B5EF4-FFF2-40B4-BE49-F238E27FC236}">
-                <a16:creationId xmlns:a16="http://schemas.microsoft.com/office/drawing/2014/main" id="{4445B70D-BE22-4B9E-A0D7-984C13F09EDC}"/>
+                <a16:creationId xmlns:a16="http://schemas.microsoft.com/office/drawing/2014/main" id="{711B07D9-1A30-48A2-ADB1-8E0EA881FCB6}"/>
               </a:ext>
             </a:extLst>
           </p:cNvPr>
@@ -8067,7 +8067,7 @@
           <p:cNvPr id="10" name="">
             <a:extLst xmlns:a="http://schemas.openxmlformats.org/drawingml/2006/main">
               <a:ext uri="{FF2B5EF4-FFF2-40B4-BE49-F238E27FC236}">
-                <a16:creationId xmlns:a16="http://schemas.microsoft.com/office/drawing/2014/main" id="{951A4E26-01DE-486A-8C5A-9D13BF8A0A21}"/>
+                <a16:creationId xmlns:a16="http://schemas.microsoft.com/office/drawing/2014/main" id="{8E26D7E6-959E-412B-9ABB-475BA9FB9A7C}"/>
               </a:ext>
             </a:extLst>
           </p:cNvPr>
@@ -8116,7 +8116,7 @@
           <p:cNvPr id="11" name="">
             <a:extLst xmlns:a="http://schemas.openxmlformats.org/drawingml/2006/main">
               <a:ext uri="{FF2B5EF4-FFF2-40B4-BE49-F238E27FC236}">
-                <a16:creationId xmlns:a16="http://schemas.microsoft.com/office/drawing/2014/main" id="{E6D9E8D7-782F-4623-8ED2-B1BE9DB45D1A}"/>
+                <a16:creationId xmlns:a16="http://schemas.microsoft.com/office/drawing/2014/main" id="{E05F3047-9A53-4A0C-9088-3B2507F1C9ED}"/>
               </a:ext>
             </a:extLst>
           </p:cNvPr>
@@ -8165,7 +8165,7 @@
           <p:cNvPr id="12" name="">
             <a:extLst xmlns:a="http://schemas.openxmlformats.org/drawingml/2006/main">
               <a:ext uri="{FF2B5EF4-FFF2-40B4-BE49-F238E27FC236}">
-                <a16:creationId xmlns:a16="http://schemas.microsoft.com/office/drawing/2014/main" id="{A7033181-938D-4C20-A551-ED520CFAB9C0}"/>
+                <a16:creationId xmlns:a16="http://schemas.microsoft.com/office/drawing/2014/main" id="{8E76981B-50C3-41D3-A4D2-C24282486C69}"/>
               </a:ext>
             </a:extLst>
           </p:cNvPr>
@@ -8214,7 +8214,7 @@
           <p:cNvPr id="13" name="">
             <a:extLst xmlns:a="http://schemas.openxmlformats.org/drawingml/2006/main">
               <a:ext uri="{FF2B5EF4-FFF2-40B4-BE49-F238E27FC236}">
-                <a16:creationId xmlns:a16="http://schemas.microsoft.com/office/drawing/2014/main" id="{C10F3495-7BA0-4FAF-B253-4B0D0ECDDC9E}"/>
+                <a16:creationId xmlns:a16="http://schemas.microsoft.com/office/drawing/2014/main" id="{8516B7C6-9273-4BF6-A997-B011203FD16A}"/>
               </a:ext>
             </a:extLst>
           </p:cNvPr>
@@ -8263,7 +8263,7 @@
           <p:cNvPr id="14" name="">
             <a:extLst xmlns:a="http://schemas.openxmlformats.org/drawingml/2006/main">
               <a:ext uri="{FF2B5EF4-FFF2-40B4-BE49-F238E27FC236}">
-                <a16:creationId xmlns:a16="http://schemas.microsoft.com/office/drawing/2014/main" id="{8B07FE41-4A7E-42A1-A233-0D3F807B1663}"/>
+                <a16:creationId xmlns:a16="http://schemas.microsoft.com/office/drawing/2014/main" id="{598261BD-15BD-4D9B-9CAC-5ABA2D7A0FAF}"/>
               </a:ext>
             </a:extLst>
           </p:cNvPr>
@@ -8310,7 +8310,7 @@
     </p:spTree>
     <p:extLst>
       <p:ext uri="{BB962C8B-B14F-4D97-AF65-F5344CB8AC3E}">
-        <p14:creationId xmlns:p14="http://schemas.microsoft.com/office/powerpoint/2010/main" val="2050154558"/>
+        <p14:creationId xmlns:p14="http://schemas.microsoft.com/office/powerpoint/2010/main" val="804362393"/>
       </p:ext>
     </p:extLst>
   </p:cSld>
@@ -8341,7 +8341,7 @@
           <p:cNvPr id="7" name="">
             <a:extLst xmlns:a="http://schemas.openxmlformats.org/drawingml/2006/main">
               <a:ext uri="{FF2B5EF4-FFF2-40B4-BE49-F238E27FC236}">
-                <a16:creationId xmlns:a16="http://schemas.microsoft.com/office/drawing/2014/main" id="{0EC3022F-6673-4B4E-9179-088957C037DC}"/>
+                <a16:creationId xmlns:a16="http://schemas.microsoft.com/office/drawing/2014/main" id="{6B7D8812-9C50-4D87-BD89-982EE187E77B}"/>
               </a:ext>
             </a:extLst>
           </p:cNvPr>
@@ -8390,7 +8390,7 @@
           <p:cNvPr id="2" name="">
             <a:extLst xmlns:a="http://schemas.openxmlformats.org/drawingml/2006/main">
               <a:ext uri="{FF2B5EF4-FFF2-40B4-BE49-F238E27FC236}">
-                <a16:creationId xmlns:a16="http://schemas.microsoft.com/office/drawing/2014/main" id="{669570D2-1B41-43E7-AF53-04BBAD0EEA32}"/>
+                <a16:creationId xmlns:a16="http://schemas.microsoft.com/office/drawing/2014/main" id="{AACBD0C9-649C-4981-AB66-4A3ABEDE4682}"/>
               </a:ext>
             </a:extLst>
           </p:cNvPr>
@@ -8439,7 +8439,7 @@
           <p:cNvPr id="3" name="">
             <a:extLst xmlns:a="http://schemas.openxmlformats.org/drawingml/2006/main">
               <a:ext uri="{FF2B5EF4-FFF2-40B4-BE49-F238E27FC236}">
-                <a16:creationId xmlns:a16="http://schemas.microsoft.com/office/drawing/2014/main" id="{3A3788DC-0F00-43F0-950B-0CA1A6947CFF}"/>
+                <a16:creationId xmlns:a16="http://schemas.microsoft.com/office/drawing/2014/main" id="{4FB7DC98-8C45-458A-A405-75707D1D1B47}"/>
               </a:ext>
             </a:extLst>
           </p:cNvPr>
@@ -8488,7 +8488,7 @@
           <p:cNvPr id="4" name="">
             <a:extLst xmlns:a="http://schemas.openxmlformats.org/drawingml/2006/main">
               <a:ext uri="{FF2B5EF4-FFF2-40B4-BE49-F238E27FC236}">
-                <a16:creationId xmlns:a16="http://schemas.microsoft.com/office/drawing/2014/main" id="{19B3C0A9-AE32-4527-92FC-460DB04A7D35}"/>
+                <a16:creationId xmlns:a16="http://schemas.microsoft.com/office/drawing/2014/main" id="{FECBD28D-889C-4278-B562-319C705F889E}"/>
               </a:ext>
             </a:extLst>
           </p:cNvPr>
@@ -8537,7 +8537,7 @@
           <p:cNvPr id="5" name="">
             <a:extLst xmlns:a="http://schemas.openxmlformats.org/drawingml/2006/main">
               <a:ext uri="{FF2B5EF4-FFF2-40B4-BE49-F238E27FC236}">
-                <a16:creationId xmlns:a16="http://schemas.microsoft.com/office/drawing/2014/main" id="{1FCC4A0D-53A0-4E3D-A659-C0D495D662E1}"/>
+                <a16:creationId xmlns:a16="http://schemas.microsoft.com/office/drawing/2014/main" id="{8EE938A1-3F27-4902-B892-2A9C7419621D}"/>
               </a:ext>
             </a:extLst>
           </p:cNvPr>
@@ -8586,7 +8586,7 @@
           <p:cNvPr id="6" name="">
             <a:extLst xmlns:a="http://schemas.openxmlformats.org/drawingml/2006/main">
               <a:ext uri="{FF2B5EF4-FFF2-40B4-BE49-F238E27FC236}">
-                <a16:creationId xmlns:a16="http://schemas.microsoft.com/office/drawing/2014/main" id="{B6115822-F483-43F2-890A-EDF69CA1764B}"/>
+                <a16:creationId xmlns:a16="http://schemas.microsoft.com/office/drawing/2014/main" id="{A2BBA5F4-C19C-4BFF-8791-AFE9C56E2273}"/>
               </a:ext>
             </a:extLst>
           </p:cNvPr>
@@ -8633,7 +8633,7 @@
     </p:spTree>
     <p:extLst>
       <p:ext uri="{BB962C8B-B14F-4D97-AF65-F5344CB8AC3E}">
-        <p14:creationId xmlns:p14="http://schemas.microsoft.com/office/powerpoint/2010/main" val="1894688012"/>
+        <p14:creationId xmlns:p14="http://schemas.microsoft.com/office/powerpoint/2010/main" val="1091703320"/>
       </p:ext>
     </p:extLst>
   </p:cSld>
@@ -8664,7 +8664,7 @@
           <p:cNvPr id="16" name="">
             <a:extLst xmlns:a="http://schemas.openxmlformats.org/drawingml/2006/main">
               <a:ext uri="{FF2B5EF4-FFF2-40B4-BE49-F238E27FC236}">
-                <a16:creationId xmlns:a16="http://schemas.microsoft.com/office/drawing/2014/main" id="{B2F7D32D-9541-4BA4-B8CB-F851E38F258F}"/>
+                <a16:creationId xmlns:a16="http://schemas.microsoft.com/office/drawing/2014/main" id="{A24F0AD3-92BB-4C21-A3C1-157EA47DE0B5}"/>
               </a:ext>
             </a:extLst>
           </p:cNvPr>
@@ -8713,7 +8713,7 @@
           <p:cNvPr id="2" name="">
             <a:extLst xmlns:a="http://schemas.openxmlformats.org/drawingml/2006/main">
               <a:ext uri="{FF2B5EF4-FFF2-40B4-BE49-F238E27FC236}">
-                <a16:creationId xmlns:a16="http://schemas.microsoft.com/office/drawing/2014/main" id="{2805A417-3499-4403-8820-98AD28C8AD71}"/>
+                <a16:creationId xmlns:a16="http://schemas.microsoft.com/office/drawing/2014/main" id="{EE24D1CB-8AA0-4A99-93EB-E61A5B637740}"/>
               </a:ext>
             </a:extLst>
           </p:cNvPr>
@@ -8752,7 +8752,7 @@
               </a:defRPr>
             </a:pPr>
             <a:r>
-              <a:t>200 万目标：首年、净额与年化</a:t>
+              <a:t>追加 20 岗：累计 43 岗压力测试</a:t>
             </a:r>
           </a:p>
         </p:txBody>
@@ -8762,7 +8762,7 @@
           <p:cNvPr id="3" name="">
             <a:extLst xmlns:a="http://schemas.openxmlformats.org/drawingml/2006/main">
               <a:ext uri="{FF2B5EF4-FFF2-40B4-BE49-F238E27FC236}">
-                <a16:creationId xmlns:a16="http://schemas.microsoft.com/office/drawing/2014/main" id="{12668D99-A97E-46F2-AAEF-EACF50E7A8C7}"/>
+                <a16:creationId xmlns:a16="http://schemas.microsoft.com/office/drawing/2014/main" id="{E16BCAD1-745E-426A-8FE4-B8493A8B85B3}"/>
               </a:ext>
             </a:extLst>
           </p:cNvPr>
@@ -8811,7 +8811,7 @@
           <p:cNvPr id="4" name="">
             <a:extLst xmlns:a="http://schemas.openxmlformats.org/drawingml/2006/main">
               <a:ext uri="{FF2B5EF4-FFF2-40B4-BE49-F238E27FC236}">
-                <a16:creationId xmlns:a16="http://schemas.microsoft.com/office/drawing/2014/main" id="{FAB18060-E254-4334-A39B-CBAA30F0E672}"/>
+                <a16:creationId xmlns:a16="http://schemas.microsoft.com/office/drawing/2014/main" id="{F1DAA62F-DF1C-469A-B8B7-605DEEEBC0A6}"/>
               </a:ext>
             </a:extLst>
           </p:cNvPr>
@@ -8860,7 +8860,7 @@
           <p:cNvPr id="5" name="">
             <a:extLst xmlns:a="http://schemas.openxmlformats.org/drawingml/2006/main">
               <a:ext uri="{FF2B5EF4-FFF2-40B4-BE49-F238E27FC236}">
-                <a16:creationId xmlns:a16="http://schemas.microsoft.com/office/drawing/2014/main" id="{40E44B9E-EE29-41C4-8665-7C73BC74BFBE}"/>
+                <a16:creationId xmlns:a16="http://schemas.microsoft.com/office/drawing/2014/main" id="{16399947-58F1-4E76-A7EE-81DC83870B43}"/>
               </a:ext>
             </a:extLst>
           </p:cNvPr>
@@ -8909,7 +8909,7 @@
           <p:cNvPr id="6" name="">
             <a:extLst xmlns:a="http://schemas.openxmlformats.org/drawingml/2006/main">
               <a:ext uri="{FF2B5EF4-FFF2-40B4-BE49-F238E27FC236}">
-                <a16:creationId xmlns:a16="http://schemas.microsoft.com/office/drawing/2014/main" id="{655EDB17-7C6C-452A-98D2-82C7BFCDE4EC}"/>
+                <a16:creationId xmlns:a16="http://schemas.microsoft.com/office/drawing/2014/main" id="{693CC80C-2906-4620-92E3-06F97DA2D4EE}"/>
               </a:ext>
             </a:extLst>
           </p:cNvPr>
@@ -8948,7 +8948,7 @@
               </a:defRPr>
             </a:pPr>
             <a:r>
-              <a:t>23 岗</a:t>
+              <a:t>43 岗</a:t>
             </a:r>
           </a:p>
         </p:txBody>
@@ -8958,7 +8958,7 @@
           <p:cNvPr id="7" name="">
             <a:extLst xmlns:a="http://schemas.openxmlformats.org/drawingml/2006/main">
               <a:ext uri="{FF2B5EF4-FFF2-40B4-BE49-F238E27FC236}">
-                <a16:creationId xmlns:a16="http://schemas.microsoft.com/office/drawing/2014/main" id="{34A3C826-E6D7-4E3D-BD0D-7815837A335E}"/>
+                <a16:creationId xmlns:a16="http://schemas.microsoft.com/office/drawing/2014/main" id="{C4341113-A52B-41CA-A1A3-3968B9F31769}"/>
               </a:ext>
             </a:extLst>
           </p:cNvPr>
@@ -8997,7 +8997,7 @@
               </a:defRPr>
             </a:pPr>
             <a:r>
-              <a:t>首年人力成本减少</a:t>
+              <a:t>累计压减岗位情景</a:t>
             </a:r>
           </a:p>
         </p:txBody>
@@ -9007,7 +9007,7 @@
           <p:cNvPr id="8" name="">
             <a:extLst xmlns:a="http://schemas.openxmlformats.org/drawingml/2006/main">
               <a:ext uri="{FF2B5EF4-FFF2-40B4-BE49-F238E27FC236}">
-                <a16:creationId xmlns:a16="http://schemas.microsoft.com/office/drawing/2014/main" id="{B801C4E2-8A87-4F32-9A13-8BA7749CABC2}"/>
+                <a16:creationId xmlns:a16="http://schemas.microsoft.com/office/drawing/2014/main" id="{2321F4B0-341C-4BF2-9730-F2BAE20B9DAC}"/>
               </a:ext>
             </a:extLst>
           </p:cNvPr>
@@ -9046,7 +9046,7 @@
               </a:defRPr>
             </a:pPr>
             <a:r>
-              <a:t>23 × 12 万 × 9/12</a:t>
+              <a:t>原 23 岗门槛</a:t>
             </a:r>
           </a:p>
           <a:p xmlns:a="http://schemas.openxmlformats.org/drawingml/2006/main">
@@ -9061,7 +9061,7 @@
               </a:defRPr>
             </a:pPr>
             <a:r>
-              <a:t>= 207 万元</a:t>
+              <a:t>再追加 20 岗</a:t>
             </a:r>
           </a:p>
           <a:p xmlns:a="http://schemas.openxmlformats.org/drawingml/2006/main">
@@ -9076,7 +9076,7 @@
               </a:defRPr>
             </a:pPr>
             <a:r>
-              <a:t>扣除费用后净额 147 万</a:t>
+              <a:t>期末编制约 257 人</a:t>
             </a:r>
           </a:p>
         </p:txBody>
@@ -9086,7 +9086,7 @@
           <p:cNvPr id="9" name="">
             <a:extLst xmlns:a="http://schemas.openxmlformats.org/drawingml/2006/main">
               <a:ext uri="{FF2B5EF4-FFF2-40B4-BE49-F238E27FC236}">
-                <a16:creationId xmlns:a16="http://schemas.microsoft.com/office/drawing/2014/main" id="{04A874F7-99A0-477B-A7DC-12C73646A4BA}"/>
+                <a16:creationId xmlns:a16="http://schemas.microsoft.com/office/drawing/2014/main" id="{4D68070B-F63C-4DE2-9188-34379A224D02}"/>
               </a:ext>
             </a:extLst>
           </p:cNvPr>
@@ -9115,7 +9115,7 @@
           <a:lstStyle xmlns:a="http://schemas.openxmlformats.org/drawingml/2006/main"/>
           <a:p xmlns:a="http://schemas.openxmlformats.org/drawingml/2006/main">
             <a:pPr>
-              <a:defRPr sz="5100" b="1">
+              <a:defRPr sz="4500" b="1">
                 <a:solidFill>
                   <a:srgbClr val="B78653"/>
                 </a:solidFill>
@@ -9125,7 +9125,7 @@
               </a:defRPr>
             </a:pPr>
             <a:r>
-              <a:t>29 岗</a:t>
+              <a:t>387 万</a:t>
             </a:r>
           </a:p>
         </p:txBody>
@@ -9135,7 +9135,7 @@
           <p:cNvPr id="10" name="">
             <a:extLst xmlns:a="http://schemas.openxmlformats.org/drawingml/2006/main">
               <a:ext uri="{FF2B5EF4-FFF2-40B4-BE49-F238E27FC236}">
-                <a16:creationId xmlns:a16="http://schemas.microsoft.com/office/drawing/2014/main" id="{557DBD63-6755-4F19-9965-08BA642D36D9}"/>
+                <a16:creationId xmlns:a16="http://schemas.microsoft.com/office/drawing/2014/main" id="{41531666-9C34-4303-87DE-1CB16DC7512F}"/>
               </a:ext>
             </a:extLst>
           </p:cNvPr>
@@ -9174,7 +9174,7 @@
               </a:defRPr>
             </a:pPr>
             <a:r>
-              <a:t>首年净现金节约</a:t>
+              <a:t>首年人力成本减少</a:t>
             </a:r>
           </a:p>
         </p:txBody>
@@ -9184,7 +9184,7 @@
           <p:cNvPr id="11" name="">
             <a:extLst xmlns:a="http://schemas.openxmlformats.org/drawingml/2006/main">
               <a:ext uri="{FF2B5EF4-FFF2-40B4-BE49-F238E27FC236}">
-                <a16:creationId xmlns:a16="http://schemas.microsoft.com/office/drawing/2014/main" id="{3155CD0F-4EFA-48FD-968D-22813C13026A}"/>
+                <a16:creationId xmlns:a16="http://schemas.microsoft.com/office/drawing/2014/main" id="{F697A41F-268A-41CB-A017-FAEA5725045F}"/>
               </a:ext>
             </a:extLst>
           </p:cNvPr>
@@ -9223,7 +9223,7 @@
               </a:defRPr>
             </a:pPr>
             <a:r>
-              <a:t>29 × 12 万 × 9/12</a:t>
+              <a:t>43 × 12 万 × 9/12</a:t>
             </a:r>
           </a:p>
           <a:p xmlns:a="http://schemas.openxmlformats.org/drawingml/2006/main">
@@ -9238,7 +9238,7 @@
               </a:defRPr>
             </a:pPr>
             <a:r>
-              <a:t>− 35 万 − 25 万</a:t>
+              <a:t>= 387 万元</a:t>
             </a:r>
           </a:p>
           <a:p xmlns:a="http://schemas.openxmlformats.org/drawingml/2006/main">
@@ -9253,7 +9253,7 @@
               </a:defRPr>
             </a:pPr>
             <a:r>
-              <a:t>= 201 万元</a:t>
+              <a:t>扣除费用后净额 327 万</a:t>
             </a:r>
           </a:p>
         </p:txBody>
@@ -9263,7 +9263,7 @@
           <p:cNvPr id="12" name="">
             <a:extLst xmlns:a="http://schemas.openxmlformats.org/drawingml/2006/main">
               <a:ext uri="{FF2B5EF4-FFF2-40B4-BE49-F238E27FC236}">
-                <a16:creationId xmlns:a16="http://schemas.microsoft.com/office/drawing/2014/main" id="{60CD7C75-47F3-4F9A-A063-AC66CE029E96}"/>
+                <a16:creationId xmlns:a16="http://schemas.microsoft.com/office/drawing/2014/main" id="{EC6F39BC-CB78-476D-89E4-78780EE086F9}"/>
               </a:ext>
             </a:extLst>
           </p:cNvPr>
@@ -9292,7 +9292,7 @@
           <a:lstStyle xmlns:a="http://schemas.openxmlformats.org/drawingml/2006/main"/>
           <a:p xmlns:a="http://schemas.openxmlformats.org/drawingml/2006/main">
             <a:pPr>
-              <a:defRPr sz="5100" b="1">
+              <a:defRPr sz="4500" b="1">
                 <a:solidFill>
                   <a:srgbClr val="B78653"/>
                 </a:solidFill>
@@ -9302,7 +9302,7 @@
               </a:defRPr>
             </a:pPr>
             <a:r>
-              <a:t>17 岗</a:t>
+              <a:t>516 万</a:t>
             </a:r>
           </a:p>
         </p:txBody>
@@ -9312,7 +9312,7 @@
           <p:cNvPr id="13" name="">
             <a:extLst xmlns:a="http://schemas.openxmlformats.org/drawingml/2006/main">
               <a:ext uri="{FF2B5EF4-FFF2-40B4-BE49-F238E27FC236}">
-                <a16:creationId xmlns:a16="http://schemas.microsoft.com/office/drawing/2014/main" id="{B465C50F-8188-40A6-9109-A16CA6B52402}"/>
+                <a16:creationId xmlns:a16="http://schemas.microsoft.com/office/drawing/2014/main" id="{C02DC9DA-AE5D-409C-B26B-C0343018ED66}"/>
               </a:ext>
             </a:extLst>
           </p:cNvPr>
@@ -9361,7 +9361,7 @@
           <p:cNvPr id="14" name="">
             <a:extLst xmlns:a="http://schemas.openxmlformats.org/drawingml/2006/main">
               <a:ext uri="{FF2B5EF4-FFF2-40B4-BE49-F238E27FC236}">
-                <a16:creationId xmlns:a16="http://schemas.microsoft.com/office/drawing/2014/main" id="{734F799C-DB6F-42AF-9C1F-3BD4BD2BD801}"/>
+                <a16:creationId xmlns:a16="http://schemas.microsoft.com/office/drawing/2014/main" id="{159BA56B-075F-4403-9E5B-09AABF57C78F}"/>
               </a:ext>
             </a:extLst>
           </p:cNvPr>
@@ -9400,7 +9400,7 @@
               </a:defRPr>
             </a:pPr>
             <a:r>
-              <a:t>17 × 12 万</a:t>
+              <a:t>43 × 12 万</a:t>
             </a:r>
           </a:p>
           <a:p xmlns:a="http://schemas.openxmlformats.org/drawingml/2006/main">
@@ -9415,7 +9415,7 @@
               </a:defRPr>
             </a:pPr>
             <a:r>
-              <a:t>= 204 万元/完整年度</a:t>
+              <a:t>= 516 万元/完整年度</a:t>
             </a:r>
           </a:p>
           <a:p xmlns:a="http://schemas.openxmlformats.org/drawingml/2006/main">
@@ -9430,7 +9430,7 @@
               </a:defRPr>
             </a:pPr>
             <a:r>
-              <a:t>不代表首年已实现</a:t>
+              <a:t>占约 300 人的 14.3%</a:t>
             </a:r>
           </a:p>
         </p:txBody>
@@ -9440,7 +9440,7 @@
           <p:cNvPr id="15" name="">
             <a:extLst xmlns:a="http://schemas.openxmlformats.org/drawingml/2006/main">
               <a:ext uri="{FF2B5EF4-FFF2-40B4-BE49-F238E27FC236}">
-                <a16:creationId xmlns:a16="http://schemas.microsoft.com/office/drawing/2014/main" id="{8D41C54A-ED0B-40DB-A042-A12372C47B62}"/>
+                <a16:creationId xmlns:a16="http://schemas.microsoft.com/office/drawing/2014/main" id="{D43EAD67-DF62-4B67-9290-941A8600F894}"/>
               </a:ext>
             </a:extLst>
           </p:cNvPr>
@@ -9479,7 +9479,7 @@
               </a:defRPr>
             </a:pPr>
             <a:r>
-              <a:t>主要目标：首 12 个月累计人力成本减少 ≥200 万；上述岗位数均须由集团真实数据核验。</a:t>
+              <a:t>43 岗是董事长压力测试。第 90 天前须逐岗证明任务取消、流程合并、服务覆盖和合法用工路径。</a:t>
             </a:r>
           </a:p>
         </p:txBody>
@@ -9487,7 +9487,7 @@
     </p:spTree>
     <p:extLst>
       <p:ext uri="{BB962C8B-B14F-4D97-AF65-F5344CB8AC3E}">
-        <p14:creationId xmlns:p14="http://schemas.microsoft.com/office/powerpoint/2010/main" val="82168092"/>
+        <p14:creationId xmlns:p14="http://schemas.microsoft.com/office/powerpoint/2010/main" val="1394658170"/>
       </p:ext>
     </p:extLst>
   </p:cSld>
@@ -9518,7 +9518,7 @@
           <p:cNvPr id="18" name="">
             <a:extLst xmlns:a="http://schemas.openxmlformats.org/drawingml/2006/main">
               <a:ext uri="{FF2B5EF4-FFF2-40B4-BE49-F238E27FC236}">
-                <a16:creationId xmlns:a16="http://schemas.microsoft.com/office/drawing/2014/main" id="{BDAB609E-3DC6-42E3-BAC1-BB1CAB6E0F30}"/>
+                <a16:creationId xmlns:a16="http://schemas.microsoft.com/office/drawing/2014/main" id="{A19A1AAD-D177-4D16-827B-AAD68DCF482F}"/>
               </a:ext>
             </a:extLst>
           </p:cNvPr>
@@ -9567,7 +9567,7 @@
           <p:cNvPr id="2" name="">
             <a:extLst xmlns:a="http://schemas.openxmlformats.org/drawingml/2006/main">
               <a:ext uri="{FF2B5EF4-FFF2-40B4-BE49-F238E27FC236}">
-                <a16:creationId xmlns:a16="http://schemas.microsoft.com/office/drawing/2014/main" id="{D5CF1821-6306-431B-BB60-E8AC22DA2C22}"/>
+                <a16:creationId xmlns:a16="http://schemas.microsoft.com/office/drawing/2014/main" id="{783EF42E-1555-4F75-841E-BF406541FE25}"/>
               </a:ext>
             </a:extLst>
           </p:cNvPr>
@@ -9616,7 +9616,7 @@
           <p:cNvPr id="3" name="">
             <a:extLst xmlns:a="http://schemas.openxmlformats.org/drawingml/2006/main">
               <a:ext uri="{FF2B5EF4-FFF2-40B4-BE49-F238E27FC236}">
-                <a16:creationId xmlns:a16="http://schemas.microsoft.com/office/drawing/2014/main" id="{5F6A511D-52A9-471B-83A7-C6BE3790F068}"/>
+                <a16:creationId xmlns:a16="http://schemas.microsoft.com/office/drawing/2014/main" id="{28346F91-10B3-4DF1-A41C-D19213795EF3}"/>
               </a:ext>
             </a:extLst>
           </p:cNvPr>
@@ -9665,7 +9665,7 @@
           <p:cNvPr id="4" name="">
             <a:extLst xmlns:a="http://schemas.openxmlformats.org/drawingml/2006/main">
               <a:ext uri="{FF2B5EF4-FFF2-40B4-BE49-F238E27FC236}">
-                <a16:creationId xmlns:a16="http://schemas.microsoft.com/office/drawing/2014/main" id="{CA5C0318-EAE1-44A1-8B13-DE7001E90598}"/>
+                <a16:creationId xmlns:a16="http://schemas.microsoft.com/office/drawing/2014/main" id="{C4125A47-B6C1-42F1-92E3-2C0E1A2EC16A}"/>
               </a:ext>
             </a:extLst>
           </p:cNvPr>
@@ -9714,7 +9714,7 @@
           <p:cNvPr id="5" name="">
             <a:extLst xmlns:a="http://schemas.openxmlformats.org/drawingml/2006/main">
               <a:ext uri="{FF2B5EF4-FFF2-40B4-BE49-F238E27FC236}">
-                <a16:creationId xmlns:a16="http://schemas.microsoft.com/office/drawing/2014/main" id="{175C8C74-24E2-4CBB-A0E2-743D1F38F945}"/>
+                <a16:creationId xmlns:a16="http://schemas.microsoft.com/office/drawing/2014/main" id="{C78214F4-C44D-48A8-8D1B-60F13C17DBB3}"/>
               </a:ext>
             </a:extLst>
           </p:cNvPr>
@@ -9763,7 +9763,7 @@
           <p:cNvPr id="6" name="">
             <a:extLst xmlns:a="http://schemas.openxmlformats.org/drawingml/2006/main">
               <a:ext uri="{FF2B5EF4-FFF2-40B4-BE49-F238E27FC236}">
-                <a16:creationId xmlns:a16="http://schemas.microsoft.com/office/drawing/2014/main" id="{9AE5D2A4-D0F7-46CE-966E-604D16B84990}"/>
+                <a16:creationId xmlns:a16="http://schemas.microsoft.com/office/drawing/2014/main" id="{C95CC091-6D91-48C1-AA4B-AD11641CB3B5}"/>
               </a:ext>
             </a:extLst>
           </p:cNvPr>
@@ -9812,7 +9812,7 @@
           <p:cNvPr id="7" name="">
             <a:extLst xmlns:a="http://schemas.openxmlformats.org/drawingml/2006/main">
               <a:ext uri="{FF2B5EF4-FFF2-40B4-BE49-F238E27FC236}">
-                <a16:creationId xmlns:a16="http://schemas.microsoft.com/office/drawing/2014/main" id="{BBB71765-AAC0-4A05-BEE4-F95CB5E484FB}"/>
+                <a16:creationId xmlns:a16="http://schemas.microsoft.com/office/drawing/2014/main" id="{B4351564-502A-485A-96CC-810B1E61B61A}"/>
               </a:ext>
             </a:extLst>
           </p:cNvPr>
@@ -9861,7 +9861,7 @@
           <p:cNvPr id="8" name="">
             <a:extLst xmlns:a="http://schemas.openxmlformats.org/drawingml/2006/main">
               <a:ext uri="{FF2B5EF4-FFF2-40B4-BE49-F238E27FC236}">
-                <a16:creationId xmlns:a16="http://schemas.microsoft.com/office/drawing/2014/main" id="{ADEE65B9-7B79-48D0-9E44-C8717FEDC4BA}"/>
+                <a16:creationId xmlns:a16="http://schemas.microsoft.com/office/drawing/2014/main" id="{D6F45677-C374-45E6-9015-8CF3972AD8F5}"/>
               </a:ext>
             </a:extLst>
           </p:cNvPr>
@@ -9910,7 +9910,7 @@
           <p:cNvPr id="9" name="">
             <a:extLst xmlns:a="http://schemas.openxmlformats.org/drawingml/2006/main">
               <a:ext uri="{FF2B5EF4-FFF2-40B4-BE49-F238E27FC236}">
-                <a16:creationId xmlns:a16="http://schemas.microsoft.com/office/drawing/2014/main" id="{5933B176-74C8-462A-A9A5-1EAC52307F20}"/>
+                <a16:creationId xmlns:a16="http://schemas.microsoft.com/office/drawing/2014/main" id="{6392329B-2A5F-4ABF-96B0-44DEDDD1BF28}"/>
               </a:ext>
             </a:extLst>
           </p:cNvPr>
@@ -9959,7 +9959,7 @@
           <p:cNvPr id="10" name="">
             <a:extLst xmlns:a="http://schemas.openxmlformats.org/drawingml/2006/main">
               <a:ext uri="{FF2B5EF4-FFF2-40B4-BE49-F238E27FC236}">
-                <a16:creationId xmlns:a16="http://schemas.microsoft.com/office/drawing/2014/main" id="{274D5501-DFBF-4AAF-8AE7-DB28A827369B}"/>
+                <a16:creationId xmlns:a16="http://schemas.microsoft.com/office/drawing/2014/main" id="{440CD26C-478F-4684-8BB6-4672FECA7279}"/>
               </a:ext>
             </a:extLst>
           </p:cNvPr>
@@ -10008,7 +10008,7 @@
           <p:cNvPr id="11" name="">
             <a:extLst xmlns:a="http://schemas.openxmlformats.org/drawingml/2006/main">
               <a:ext uri="{FF2B5EF4-FFF2-40B4-BE49-F238E27FC236}">
-                <a16:creationId xmlns:a16="http://schemas.microsoft.com/office/drawing/2014/main" id="{12724BB9-E261-49CB-8CCC-6538C9412BC9}"/>
+                <a16:creationId xmlns:a16="http://schemas.microsoft.com/office/drawing/2014/main" id="{44CBE947-202F-49B1-854F-878E3ADFFDE6}"/>
               </a:ext>
             </a:extLst>
           </p:cNvPr>
@@ -10057,7 +10057,7 @@
           <p:cNvPr id="12" name="">
             <a:extLst xmlns:a="http://schemas.openxmlformats.org/drawingml/2006/main">
               <a:ext uri="{FF2B5EF4-FFF2-40B4-BE49-F238E27FC236}">
-                <a16:creationId xmlns:a16="http://schemas.microsoft.com/office/drawing/2014/main" id="{0427E8E4-D120-4D29-94E1-3782512806D9}"/>
+                <a16:creationId xmlns:a16="http://schemas.microsoft.com/office/drawing/2014/main" id="{0FFA445C-D01F-4E36-9BB1-A3A816007A80}"/>
               </a:ext>
             </a:extLst>
           </p:cNvPr>
@@ -10106,7 +10106,7 @@
           <p:cNvPr id="13" name="">
             <a:extLst xmlns:a="http://schemas.openxmlformats.org/drawingml/2006/main">
               <a:ext uri="{FF2B5EF4-FFF2-40B4-BE49-F238E27FC236}">
-                <a16:creationId xmlns:a16="http://schemas.microsoft.com/office/drawing/2014/main" id="{49D40671-A642-4A98-9167-E7D66CC3FCD0}"/>
+                <a16:creationId xmlns:a16="http://schemas.microsoft.com/office/drawing/2014/main" id="{A51FE120-BB4B-45F0-829D-405CB675C50C}"/>
               </a:ext>
             </a:extLst>
           </p:cNvPr>
@@ -10155,7 +10155,7 @@
           <p:cNvPr id="14" name="">
             <a:extLst xmlns:a="http://schemas.openxmlformats.org/drawingml/2006/main">
               <a:ext uri="{FF2B5EF4-FFF2-40B4-BE49-F238E27FC236}">
-                <a16:creationId xmlns:a16="http://schemas.microsoft.com/office/drawing/2014/main" id="{610BD318-B4CB-4FD0-B065-DF86104276CD}"/>
+                <a16:creationId xmlns:a16="http://schemas.microsoft.com/office/drawing/2014/main" id="{F29DB7CE-1676-4F68-BD2E-D1C268A7E4BA}"/>
               </a:ext>
             </a:extLst>
           </p:cNvPr>
@@ -10204,7 +10204,7 @@
           <p:cNvPr id="15" name="">
             <a:extLst xmlns:a="http://schemas.openxmlformats.org/drawingml/2006/main">
               <a:ext uri="{FF2B5EF4-FFF2-40B4-BE49-F238E27FC236}">
-                <a16:creationId xmlns:a16="http://schemas.microsoft.com/office/drawing/2014/main" id="{D1309ED2-BC71-4757-9470-47CA657D505A}"/>
+                <a16:creationId xmlns:a16="http://schemas.microsoft.com/office/drawing/2014/main" id="{24F23542-533C-4C45-92A2-308DE04AD828}"/>
               </a:ext>
             </a:extLst>
           </p:cNvPr>
@@ -10253,7 +10253,7 @@
           <p:cNvPr id="16" name="">
             <a:extLst xmlns:a="http://schemas.openxmlformats.org/drawingml/2006/main">
               <a:ext uri="{FF2B5EF4-FFF2-40B4-BE49-F238E27FC236}">
-                <a16:creationId xmlns:a16="http://schemas.microsoft.com/office/drawing/2014/main" id="{2C668156-83EA-4539-826D-680A799D09D2}"/>
+                <a16:creationId xmlns:a16="http://schemas.microsoft.com/office/drawing/2014/main" id="{C06B73C4-5227-40B0-86C7-75DFB88F4AAD}"/>
               </a:ext>
             </a:extLst>
           </p:cNvPr>
@@ -10302,7 +10302,7 @@
           <p:cNvPr id="17" name="">
             <a:extLst xmlns:a="http://schemas.openxmlformats.org/drawingml/2006/main">
               <a:ext uri="{FF2B5EF4-FFF2-40B4-BE49-F238E27FC236}">
-                <a16:creationId xmlns:a16="http://schemas.microsoft.com/office/drawing/2014/main" id="{67FA13A1-A332-4927-BD60-2EB90451B894}"/>
+                <a16:creationId xmlns:a16="http://schemas.microsoft.com/office/drawing/2014/main" id="{00E6F1B6-D50D-4378-94AD-00A54469442C}"/>
               </a:ext>
             </a:extLst>
           </p:cNvPr>
@@ -10349,7 +10349,7 @@
     </p:spTree>
     <p:extLst>
       <p:ext uri="{BB962C8B-B14F-4D97-AF65-F5344CB8AC3E}">
-        <p14:creationId xmlns:p14="http://schemas.microsoft.com/office/powerpoint/2010/main" val="1750366640"/>
+        <p14:creationId xmlns:p14="http://schemas.microsoft.com/office/powerpoint/2010/main" val="56315801"/>
       </p:ext>
     </p:extLst>
   </p:cSld>
@@ -10380,7 +10380,7 @@
           <p:cNvPr id="11" name="">
             <a:extLst xmlns:a="http://schemas.openxmlformats.org/drawingml/2006/main">
               <a:ext uri="{FF2B5EF4-FFF2-40B4-BE49-F238E27FC236}">
-                <a16:creationId xmlns:a16="http://schemas.microsoft.com/office/drawing/2014/main" id="{A862225B-9B16-4F80-B3F5-C49C6A02DF99}"/>
+                <a16:creationId xmlns:a16="http://schemas.microsoft.com/office/drawing/2014/main" id="{48C57477-08FF-4D76-BE3B-9C9A07B4B0AE}"/>
               </a:ext>
             </a:extLst>
           </p:cNvPr>
@@ -10429,7 +10429,7 @@
           <p:cNvPr id="2" name="">
             <a:extLst xmlns:a="http://schemas.openxmlformats.org/drawingml/2006/main">
               <a:ext uri="{FF2B5EF4-FFF2-40B4-BE49-F238E27FC236}">
-                <a16:creationId xmlns:a16="http://schemas.microsoft.com/office/drawing/2014/main" id="{E74A6458-3B1C-49AD-9ACA-2A179D2FC4A6}"/>
+                <a16:creationId xmlns:a16="http://schemas.microsoft.com/office/drawing/2014/main" id="{522FB7D7-8667-4557-80CB-C54225F0E3E5}"/>
               </a:ext>
             </a:extLst>
           </p:cNvPr>
@@ -10468,7 +10468,7 @@
               </a:defRPr>
             </a:pPr>
             <a:r>
-              <a:t>29 岗意味着 52,200 小时容量门槛</a:t>
+              <a:t>43 岗意味着 77,400 小时容量门槛</a:t>
             </a:r>
           </a:p>
         </p:txBody>
@@ -10478,7 +10478,7 @@
           <p:cNvPr id="3" name="">
             <a:extLst xmlns:a="http://schemas.openxmlformats.org/drawingml/2006/main">
               <a:ext uri="{FF2B5EF4-FFF2-40B4-BE49-F238E27FC236}">
-                <a16:creationId xmlns:a16="http://schemas.microsoft.com/office/drawing/2014/main" id="{F716A8B9-A94F-4730-A785-FDEA634322DA}"/>
+                <a16:creationId xmlns:a16="http://schemas.microsoft.com/office/drawing/2014/main" id="{B77F0780-F8BE-4E06-A577-A4BE6535EA80}"/>
               </a:ext>
             </a:extLst>
           </p:cNvPr>
@@ -10517,7 +10517,7 @@
               </a:defRPr>
             </a:pPr>
             <a:r>
-              <a:t>此前统一节省 1.5 小时/周的演示不够支撑这个目标</a:t>
+              <a:t>此前统一节省 1.5 小时/周的演示远不够支撑追加目标</a:t>
             </a:r>
           </a:p>
         </p:txBody>
@@ -10527,7 +10527,7 @@
           <p:cNvPr id="4" name="">
             <a:extLst xmlns:a="http://schemas.openxmlformats.org/drawingml/2006/main">
               <a:ext uri="{FF2B5EF4-FFF2-40B4-BE49-F238E27FC236}">
-                <a16:creationId xmlns:a16="http://schemas.microsoft.com/office/drawing/2014/main" id="{9F128FE6-6739-4746-8576-0146109CE48D}"/>
+                <a16:creationId xmlns:a16="http://schemas.microsoft.com/office/drawing/2014/main" id="{B435DE7F-501D-465E-B76B-46C3AE73B807}"/>
               </a:ext>
             </a:extLst>
           </p:cNvPr>
@@ -10576,7 +10576,7 @@
           <p:cNvPr id="5" name="">
             <a:extLst xmlns:a="http://schemas.openxmlformats.org/drawingml/2006/main">
               <a:ext uri="{FF2B5EF4-FFF2-40B4-BE49-F238E27FC236}">
-                <a16:creationId xmlns:a16="http://schemas.microsoft.com/office/drawing/2014/main" id="{E49E108C-C697-4286-8802-319641913962}"/>
+                <a16:creationId xmlns:a16="http://schemas.microsoft.com/office/drawing/2014/main" id="{A6E40795-5EA8-4A31-B0E8-47870390916B}"/>
               </a:ext>
             </a:extLst>
           </p:cNvPr>
@@ -10625,7 +10625,7 @@
           <p:cNvPr id="6" name="">
             <a:extLst xmlns:a="http://schemas.openxmlformats.org/drawingml/2006/main">
               <a:ext uri="{FF2B5EF4-FFF2-40B4-BE49-F238E27FC236}">
-                <a16:creationId xmlns:a16="http://schemas.microsoft.com/office/drawing/2014/main" id="{E4251A03-3238-49AD-B2BF-34D7969293CE}"/>
+                <a16:creationId xmlns:a16="http://schemas.microsoft.com/office/drawing/2014/main" id="{1D0025FB-E6F9-482E-8A50-662386AAB87D}"/>
               </a:ext>
             </a:extLst>
           </p:cNvPr>
@@ -10664,7 +10664,7 @@
               </a:defRPr>
             </a:pPr>
             <a:r>
-              <a:t>52,200</a:t>
+              <a:t>77,400</a:t>
             </a:r>
           </a:p>
         </p:txBody>
@@ -10674,7 +10674,7 @@
           <p:cNvPr id="7" name="">
             <a:extLst xmlns:a="http://schemas.openxmlformats.org/drawingml/2006/main">
               <a:ext uri="{FF2B5EF4-FFF2-40B4-BE49-F238E27FC236}">
-                <a16:creationId xmlns:a16="http://schemas.microsoft.com/office/drawing/2014/main" id="{D1ADB60A-4C93-4FC4-9D2A-243DD1F56331}"/>
+                <a16:creationId xmlns:a16="http://schemas.microsoft.com/office/drawing/2014/main" id="{714572F7-ED42-4923-B6BC-AA6712DA6679}"/>
               </a:ext>
             </a:extLst>
           </p:cNvPr>
@@ -10713,7 +10713,7 @@
               </a:defRPr>
             </a:pPr>
             <a:r>
-              <a:t>29 岗 × 1,800 小时/岗</a:t>
+              <a:t>43 岗 × 1,800 小时/岗</a:t>
             </a:r>
           </a:p>
         </p:txBody>
@@ -10723,7 +10723,7 @@
           <p:cNvPr id="8" name="">
             <a:extLst xmlns:a="http://schemas.openxmlformats.org/drawingml/2006/main">
               <a:ext uri="{FF2B5EF4-FFF2-40B4-BE49-F238E27FC236}">
-                <a16:creationId xmlns:a16="http://schemas.microsoft.com/office/drawing/2014/main" id="{993E681D-C83E-485B-985B-3C74A2FAF2F5}"/>
+                <a16:creationId xmlns:a16="http://schemas.microsoft.com/office/drawing/2014/main" id="{05EF7733-EADD-4068-980B-AD6D9A9D4045}"/>
               </a:ext>
             </a:extLst>
           </p:cNvPr>
@@ -10772,7 +10772,7 @@
           <p:cNvPr id="9" name="">
             <a:extLst xmlns:a="http://schemas.openxmlformats.org/drawingml/2006/main">
               <a:ext uri="{FF2B5EF4-FFF2-40B4-BE49-F238E27FC236}">
-                <a16:creationId xmlns:a16="http://schemas.microsoft.com/office/drawing/2014/main" id="{D37F0936-7B21-4AD7-8E89-19D89356ADEE}"/>
+                <a16:creationId xmlns:a16="http://schemas.microsoft.com/office/drawing/2014/main" id="{262C410C-2990-44F5-9F89-356A99194DC8}"/>
               </a:ext>
             </a:extLst>
           </p:cNvPr>
@@ -10821,7 +10821,7 @@
           <p:cNvPr id="10" name="">
             <a:extLst xmlns:a="http://schemas.openxmlformats.org/drawingml/2006/main">
               <a:ext uri="{FF2B5EF4-FFF2-40B4-BE49-F238E27FC236}">
-                <a16:creationId xmlns:a16="http://schemas.microsoft.com/office/drawing/2014/main" id="{942ECC7D-8387-482C-B9CE-2B967CC8D952}"/>
+                <a16:creationId xmlns:a16="http://schemas.microsoft.com/office/drawing/2014/main" id="{F4D9CCD6-03CA-494A-95C5-F29E87CB77F0}"/>
               </a:ext>
             </a:extLst>
           </p:cNvPr>
@@ -10860,7 +10860,7 @@
               </a:defRPr>
             </a:pPr>
             <a:r>
-              <a:t>差额 31,500 小时；平均到 300 人需约 3.78 小时/周，且必须能在同岗位、同排班中合并。</a:t>
+              <a:t>差额 56,700 小时；平均到 300 人需约 5.61 小时/周，且必须能在同岗位、同排班中合并。</a:t>
             </a:r>
           </a:p>
         </p:txBody>
@@ -10868,7 +10868,7 @@
     </p:spTree>
     <p:extLst>
       <p:ext uri="{BB962C8B-B14F-4D97-AF65-F5344CB8AC3E}">
-        <p14:creationId xmlns:p14="http://schemas.microsoft.com/office/powerpoint/2010/main" val="815567752"/>
+        <p14:creationId xmlns:p14="http://schemas.microsoft.com/office/powerpoint/2010/main" val="756847742"/>
       </p:ext>
     </p:extLst>
   </p:cSld>
@@ -10899,7 +10899,7 @@
           <p:cNvPr id="15" name="">
             <a:extLst xmlns:a="http://schemas.openxmlformats.org/drawingml/2006/main">
               <a:ext uri="{FF2B5EF4-FFF2-40B4-BE49-F238E27FC236}">
-                <a16:creationId xmlns:a16="http://schemas.microsoft.com/office/drawing/2014/main" id="{2684032B-F23E-42E3-BCF8-8FEE45F5A2CD}"/>
+                <a16:creationId xmlns:a16="http://schemas.microsoft.com/office/drawing/2014/main" id="{E1905A6C-ABE7-4F17-92D9-82AECB1A71D9}"/>
               </a:ext>
             </a:extLst>
           </p:cNvPr>
@@ -10948,7 +10948,7 @@
           <p:cNvPr id="2" name="">
             <a:extLst xmlns:a="http://schemas.openxmlformats.org/drawingml/2006/main">
               <a:ext uri="{FF2B5EF4-FFF2-40B4-BE49-F238E27FC236}">
-                <a16:creationId xmlns:a16="http://schemas.microsoft.com/office/drawing/2014/main" id="{927EEED7-C204-461A-B05A-C76E02E8F04F}"/>
+                <a16:creationId xmlns:a16="http://schemas.microsoft.com/office/drawing/2014/main" id="{45DB2489-A5D4-44D2-A820-B0A9A5F63E9E}"/>
               </a:ext>
             </a:extLst>
           </p:cNvPr>
@@ -10997,7 +10997,7 @@
           <p:cNvPr id="3" name="">
             <a:extLst xmlns:a="http://schemas.openxmlformats.org/drawingml/2006/main">
               <a:ext uri="{FF2B5EF4-FFF2-40B4-BE49-F238E27FC236}">
-                <a16:creationId xmlns:a16="http://schemas.microsoft.com/office/drawing/2014/main" id="{69A02B0F-134A-4FFA-9122-E2FD8DA20B67}"/>
+                <a16:creationId xmlns:a16="http://schemas.microsoft.com/office/drawing/2014/main" id="{1BD90E87-BF39-4263-BDEA-4CE9721BB040}"/>
               </a:ext>
             </a:extLst>
           </p:cNvPr>
@@ -11046,7 +11046,7 @@
           <p:cNvPr id="4" name="">
             <a:extLst xmlns:a="http://schemas.openxmlformats.org/drawingml/2006/main">
               <a:ext uri="{FF2B5EF4-FFF2-40B4-BE49-F238E27FC236}">
-                <a16:creationId xmlns:a16="http://schemas.microsoft.com/office/drawing/2014/main" id="{A486B6C6-5A11-40AB-856A-45203CE58B59}"/>
+                <a16:creationId xmlns:a16="http://schemas.microsoft.com/office/drawing/2014/main" id="{D5CDD4D8-B306-4053-A4D9-167DC7DCE4A5}"/>
               </a:ext>
             </a:extLst>
           </p:cNvPr>
@@ -11095,7 +11095,7 @@
           <p:cNvPr id="5" name="">
             <a:extLst xmlns:a="http://schemas.openxmlformats.org/drawingml/2006/main">
               <a:ext uri="{FF2B5EF4-FFF2-40B4-BE49-F238E27FC236}">
-                <a16:creationId xmlns:a16="http://schemas.microsoft.com/office/drawing/2014/main" id="{809ECBF5-377A-4776-A218-8AA17547A799}"/>
+                <a16:creationId xmlns:a16="http://schemas.microsoft.com/office/drawing/2014/main" id="{0EC042FC-3172-462A-B3B5-AF23F1B228AA}"/>
               </a:ext>
             </a:extLst>
           </p:cNvPr>
@@ -11144,7 +11144,7 @@
           <p:cNvPr id="6" name="">
             <a:extLst xmlns:a="http://schemas.openxmlformats.org/drawingml/2006/main">
               <a:ext uri="{FF2B5EF4-FFF2-40B4-BE49-F238E27FC236}">
-                <a16:creationId xmlns:a16="http://schemas.microsoft.com/office/drawing/2014/main" id="{898083A1-86DE-456B-A08A-1D0C2F86F13C}"/>
+                <a16:creationId xmlns:a16="http://schemas.microsoft.com/office/drawing/2014/main" id="{DEDEAC09-630A-4B54-973A-D906B91D0B38}"/>
               </a:ext>
             </a:extLst>
           </p:cNvPr>
@@ -11193,7 +11193,7 @@
           <p:cNvPr id="7" name="">
             <a:extLst xmlns:a="http://schemas.openxmlformats.org/drawingml/2006/main">
               <a:ext uri="{FF2B5EF4-FFF2-40B4-BE49-F238E27FC236}">
-                <a16:creationId xmlns:a16="http://schemas.microsoft.com/office/drawing/2014/main" id="{A86395A1-A16B-4192-ADBE-74EC7F4697A2}"/>
+                <a16:creationId xmlns:a16="http://schemas.microsoft.com/office/drawing/2014/main" id="{0FB60847-9611-472A-8254-E15F88FA3A17}"/>
               </a:ext>
             </a:extLst>
           </p:cNvPr>
@@ -11242,7 +11242,7 @@
           <p:cNvPr id="8" name="">
             <a:extLst xmlns:a="http://schemas.openxmlformats.org/drawingml/2006/main">
               <a:ext uri="{FF2B5EF4-FFF2-40B4-BE49-F238E27FC236}">
-                <a16:creationId xmlns:a16="http://schemas.microsoft.com/office/drawing/2014/main" id="{E00F9DF0-3B06-4017-9EC5-1E3EE0B04B4B}"/>
+                <a16:creationId xmlns:a16="http://schemas.microsoft.com/office/drawing/2014/main" id="{C01B4888-DB11-4907-94DF-5A5728466B42}"/>
               </a:ext>
             </a:extLst>
           </p:cNvPr>
@@ -11291,7 +11291,7 @@
           <p:cNvPr id="9" name="">
             <a:extLst xmlns:a="http://schemas.openxmlformats.org/drawingml/2006/main">
               <a:ext uri="{FF2B5EF4-FFF2-40B4-BE49-F238E27FC236}">
-                <a16:creationId xmlns:a16="http://schemas.microsoft.com/office/drawing/2014/main" id="{2CFC0E62-53D9-4DA4-A79C-9521C930BE55}"/>
+                <a16:creationId xmlns:a16="http://schemas.microsoft.com/office/drawing/2014/main" id="{37EFEF53-CCC9-40E1-B235-84501EC92748}"/>
               </a:ext>
             </a:extLst>
           </p:cNvPr>
@@ -11340,7 +11340,7 @@
           <p:cNvPr id="10" name="">
             <a:extLst xmlns:a="http://schemas.openxmlformats.org/drawingml/2006/main">
               <a:ext uri="{FF2B5EF4-FFF2-40B4-BE49-F238E27FC236}">
-                <a16:creationId xmlns:a16="http://schemas.microsoft.com/office/drawing/2014/main" id="{7ED715FE-4BA6-4641-9F90-05050B763898}"/>
+                <a16:creationId xmlns:a16="http://schemas.microsoft.com/office/drawing/2014/main" id="{53F12452-5742-4AF8-A4A6-E5A0A5BFE923}"/>
               </a:ext>
             </a:extLst>
           </p:cNvPr>
@@ -11389,7 +11389,7 @@
           <p:cNvPr id="11" name="">
             <a:extLst xmlns:a="http://schemas.openxmlformats.org/drawingml/2006/main">
               <a:ext uri="{FF2B5EF4-FFF2-40B4-BE49-F238E27FC236}">
-                <a16:creationId xmlns:a16="http://schemas.microsoft.com/office/drawing/2014/main" id="{B380AC86-D273-45EA-965A-BBC38C1700F1}"/>
+                <a16:creationId xmlns:a16="http://schemas.microsoft.com/office/drawing/2014/main" id="{4A41B8FA-D3C2-4000-90AE-A22CAC03829F}"/>
               </a:ext>
             </a:extLst>
           </p:cNvPr>
@@ -11438,7 +11438,7 @@
           <p:cNvPr id="12" name="">
             <a:extLst xmlns:a="http://schemas.openxmlformats.org/drawingml/2006/main">
               <a:ext uri="{FF2B5EF4-FFF2-40B4-BE49-F238E27FC236}">
-                <a16:creationId xmlns:a16="http://schemas.microsoft.com/office/drawing/2014/main" id="{672649D5-F40C-400E-BE17-F727655DA0A2}"/>
+                <a16:creationId xmlns:a16="http://schemas.microsoft.com/office/drawing/2014/main" id="{3D7946A5-916E-4D46-8943-0106E7DCF12B}"/>
               </a:ext>
             </a:extLst>
           </p:cNvPr>
@@ -11487,7 +11487,7 @@
           <p:cNvPr id="13" name="">
             <a:extLst xmlns:a="http://schemas.openxmlformats.org/drawingml/2006/main">
               <a:ext uri="{FF2B5EF4-FFF2-40B4-BE49-F238E27FC236}">
-                <a16:creationId xmlns:a16="http://schemas.microsoft.com/office/drawing/2014/main" id="{F54BBBCA-3A17-40E8-B002-36A24948413C}"/>
+                <a16:creationId xmlns:a16="http://schemas.microsoft.com/office/drawing/2014/main" id="{101E0670-1E06-48A8-8F8E-ACE99EC64D2A}"/>
               </a:ext>
             </a:extLst>
           </p:cNvPr>
@@ -11536,7 +11536,7 @@
           <p:cNvPr id="14" name="">
             <a:extLst xmlns:a="http://schemas.openxmlformats.org/drawingml/2006/main">
               <a:ext uri="{FF2B5EF4-FFF2-40B4-BE49-F238E27FC236}">
-                <a16:creationId xmlns:a16="http://schemas.microsoft.com/office/drawing/2014/main" id="{6A7B46B9-B494-4479-B1DE-E3B3BD703A39}"/>
+                <a16:creationId xmlns:a16="http://schemas.microsoft.com/office/drawing/2014/main" id="{BEC59E0B-67E1-4D97-B4C8-272B38E1AFD3}"/>
               </a:ext>
             </a:extLst>
           </p:cNvPr>
@@ -11583,7 +11583,7 @@
     </p:spTree>
     <p:extLst>
       <p:ext uri="{BB962C8B-B14F-4D97-AF65-F5344CB8AC3E}">
-        <p14:creationId xmlns:p14="http://schemas.microsoft.com/office/powerpoint/2010/main" val="84014946"/>
+        <p14:creationId xmlns:p14="http://schemas.microsoft.com/office/powerpoint/2010/main" val="1642308670"/>
       </p:ext>
     </p:extLst>
   </p:cSld>
@@ -11614,7 +11614,7 @@
           <p:cNvPr id="13" name="">
             <a:extLst xmlns:a="http://schemas.openxmlformats.org/drawingml/2006/main">
               <a:ext uri="{FF2B5EF4-FFF2-40B4-BE49-F238E27FC236}">
-                <a16:creationId xmlns:a16="http://schemas.microsoft.com/office/drawing/2014/main" id="{5786BBF1-AC0A-48A1-B2A3-8448AAF41D19}"/>
+                <a16:creationId xmlns:a16="http://schemas.microsoft.com/office/drawing/2014/main" id="{141BE62C-0963-42CB-BE3F-7C663033547A}"/>
               </a:ext>
             </a:extLst>
           </p:cNvPr>
@@ -11663,7 +11663,7 @@
           <p:cNvPr id="2" name="">
             <a:extLst xmlns:a="http://schemas.openxmlformats.org/drawingml/2006/main">
               <a:ext uri="{FF2B5EF4-FFF2-40B4-BE49-F238E27FC236}">
-                <a16:creationId xmlns:a16="http://schemas.microsoft.com/office/drawing/2014/main" id="{0D226D98-F221-4690-9482-45CA7ED59D26}"/>
+                <a16:creationId xmlns:a16="http://schemas.microsoft.com/office/drawing/2014/main" id="{FFEA45F3-37D4-4CD2-842A-9DC44FA8270C}"/>
               </a:ext>
             </a:extLst>
           </p:cNvPr>
@@ -11712,7 +11712,7 @@
           <p:cNvPr id="3" name="">
             <a:extLst xmlns:a="http://schemas.openxmlformats.org/drawingml/2006/main">
               <a:ext uri="{FF2B5EF4-FFF2-40B4-BE49-F238E27FC236}">
-                <a16:creationId xmlns:a16="http://schemas.microsoft.com/office/drawing/2014/main" id="{F89CB1FD-1F2D-4832-82B2-3BDD3CCE1DAD}"/>
+                <a16:creationId xmlns:a16="http://schemas.microsoft.com/office/drawing/2014/main" id="{FA29BA3E-FFC5-4CBA-BBC5-86CE500DEB77}"/>
               </a:ext>
             </a:extLst>
           </p:cNvPr>
@@ -11761,7 +11761,7 @@
           <p:cNvPr id="4" name="">
             <a:extLst xmlns:a="http://schemas.openxmlformats.org/drawingml/2006/main">
               <a:ext uri="{FF2B5EF4-FFF2-40B4-BE49-F238E27FC236}">
-                <a16:creationId xmlns:a16="http://schemas.microsoft.com/office/drawing/2014/main" id="{64B96A7D-E63A-4AFB-B3A1-8A4667B2C7AE}"/>
+                <a16:creationId xmlns:a16="http://schemas.microsoft.com/office/drawing/2014/main" id="{8976D366-50FC-4BC0-95B5-4845B5D4E8A9}"/>
               </a:ext>
             </a:extLst>
           </p:cNvPr>
@@ -11810,7 +11810,7 @@
           <p:cNvPr id="5" name="">
             <a:extLst xmlns:a="http://schemas.openxmlformats.org/drawingml/2006/main">
               <a:ext uri="{FF2B5EF4-FFF2-40B4-BE49-F238E27FC236}">
-                <a16:creationId xmlns:a16="http://schemas.microsoft.com/office/drawing/2014/main" id="{71DC7F46-6047-4565-A9AB-277B8C4179F2}"/>
+                <a16:creationId xmlns:a16="http://schemas.microsoft.com/office/drawing/2014/main" id="{C1287EDF-6128-4BCF-BA44-05944C1F2C08}"/>
               </a:ext>
             </a:extLst>
           </p:cNvPr>
@@ -11859,7 +11859,7 @@
           <p:cNvPr id="6" name="">
             <a:extLst xmlns:a="http://schemas.openxmlformats.org/drawingml/2006/main">
               <a:ext uri="{FF2B5EF4-FFF2-40B4-BE49-F238E27FC236}">
-                <a16:creationId xmlns:a16="http://schemas.microsoft.com/office/drawing/2014/main" id="{AC27CBEA-522E-4C26-A986-955DDA48DAD8}"/>
+                <a16:creationId xmlns:a16="http://schemas.microsoft.com/office/drawing/2014/main" id="{CC07FD06-B592-49F5-86DA-3FD915CEA383}"/>
               </a:ext>
             </a:extLst>
           </p:cNvPr>
@@ -11908,7 +11908,7 @@
           <p:cNvPr id="7" name="">
             <a:extLst xmlns:a="http://schemas.openxmlformats.org/drawingml/2006/main">
               <a:ext uri="{FF2B5EF4-FFF2-40B4-BE49-F238E27FC236}">
-                <a16:creationId xmlns:a16="http://schemas.microsoft.com/office/drawing/2014/main" id="{5A87F04A-1910-4B38-BEE4-621429AD8057}"/>
+                <a16:creationId xmlns:a16="http://schemas.microsoft.com/office/drawing/2014/main" id="{F096A7AA-05D4-4047-A8E7-7DF053673154}"/>
               </a:ext>
             </a:extLst>
           </p:cNvPr>
@@ -11957,7 +11957,7 @@
           <p:cNvPr id="8" name="">
             <a:extLst xmlns:a="http://schemas.openxmlformats.org/drawingml/2006/main">
               <a:ext uri="{FF2B5EF4-FFF2-40B4-BE49-F238E27FC236}">
-                <a16:creationId xmlns:a16="http://schemas.microsoft.com/office/drawing/2014/main" id="{A6944C02-4982-4D25-B71F-06E6A938D05B}"/>
+                <a16:creationId xmlns:a16="http://schemas.microsoft.com/office/drawing/2014/main" id="{5EA79493-D0B1-4FB8-BD88-387A29DE4C78}"/>
               </a:ext>
             </a:extLst>
           </p:cNvPr>
@@ -12006,7 +12006,7 @@
           <p:cNvPr id="9" name="">
             <a:extLst xmlns:a="http://schemas.openxmlformats.org/drawingml/2006/main">
               <a:ext uri="{FF2B5EF4-FFF2-40B4-BE49-F238E27FC236}">
-                <a16:creationId xmlns:a16="http://schemas.microsoft.com/office/drawing/2014/main" id="{E335402B-E577-43C0-B717-DAC6211976A4}"/>
+                <a16:creationId xmlns:a16="http://schemas.microsoft.com/office/drawing/2014/main" id="{96F8B38D-F7C4-4EF7-B0F4-705786A3170E}"/>
               </a:ext>
             </a:extLst>
           </p:cNvPr>
@@ -12055,7 +12055,7 @@
           <p:cNvPr id="10" name="">
             <a:extLst xmlns:a="http://schemas.openxmlformats.org/drawingml/2006/main">
               <a:ext uri="{FF2B5EF4-FFF2-40B4-BE49-F238E27FC236}">
-                <a16:creationId xmlns:a16="http://schemas.microsoft.com/office/drawing/2014/main" id="{F137D33F-9346-4C93-A388-12950EF0E483}"/>
+                <a16:creationId xmlns:a16="http://schemas.microsoft.com/office/drawing/2014/main" id="{000AA798-CA6C-4E33-8273-F462308EDCB8}"/>
               </a:ext>
             </a:extLst>
           </p:cNvPr>
@@ -12104,7 +12104,7 @@
           <p:cNvPr id="11" name="">
             <a:extLst xmlns:a="http://schemas.openxmlformats.org/drawingml/2006/main">
               <a:ext uri="{FF2B5EF4-FFF2-40B4-BE49-F238E27FC236}">
-                <a16:creationId xmlns:a16="http://schemas.microsoft.com/office/drawing/2014/main" id="{0A22A5BC-03C2-4301-A63A-8B5ADCF4DA56}"/>
+                <a16:creationId xmlns:a16="http://schemas.microsoft.com/office/drawing/2014/main" id="{68D79EFC-E4A2-4EE0-BBE3-91517E864406}"/>
               </a:ext>
             </a:extLst>
           </p:cNvPr>
@@ -12153,7 +12153,7 @@
           <p:cNvPr id="12" name="">
             <a:extLst xmlns:a="http://schemas.openxmlformats.org/drawingml/2006/main">
               <a:ext uri="{FF2B5EF4-FFF2-40B4-BE49-F238E27FC236}">
-                <a16:creationId xmlns:a16="http://schemas.microsoft.com/office/drawing/2014/main" id="{7FB999E2-29A4-4323-A715-A334298E7050}"/>
+                <a16:creationId xmlns:a16="http://schemas.microsoft.com/office/drawing/2014/main" id="{DD70FF55-955B-421A-B0BE-18124227DA32}"/>
               </a:ext>
             </a:extLst>
           </p:cNvPr>
@@ -12200,7 +12200,7 @@
     </p:spTree>
     <p:extLst>
       <p:ext uri="{BB962C8B-B14F-4D97-AF65-F5344CB8AC3E}">
-        <p14:creationId xmlns:p14="http://schemas.microsoft.com/office/powerpoint/2010/main" val="2020178842"/>
+        <p14:creationId xmlns:p14="http://schemas.microsoft.com/office/powerpoint/2010/main" val="1106938649"/>
       </p:ext>
     </p:extLst>
   </p:cSld>
@@ -12231,7 +12231,7 @@
           <p:cNvPr id="28" name="">
             <a:extLst xmlns:a="http://schemas.openxmlformats.org/drawingml/2006/main">
               <a:ext uri="{FF2B5EF4-FFF2-40B4-BE49-F238E27FC236}">
-                <a16:creationId xmlns:a16="http://schemas.microsoft.com/office/drawing/2014/main" id="{458D48C6-80EF-4D4F-A087-B1219B1CCA6C}"/>
+                <a16:creationId xmlns:a16="http://schemas.microsoft.com/office/drawing/2014/main" id="{6C52277F-BD03-403D-A324-922CFB379874}"/>
               </a:ext>
             </a:extLst>
           </p:cNvPr>
@@ -12280,7 +12280,7 @@
           <p:cNvPr id="2" name="">
             <a:extLst xmlns:a="http://schemas.openxmlformats.org/drawingml/2006/main">
               <a:ext uri="{FF2B5EF4-FFF2-40B4-BE49-F238E27FC236}">
-                <a16:creationId xmlns:a16="http://schemas.microsoft.com/office/drawing/2014/main" id="{CD78DA0B-8D52-4720-BB81-D78F6BB2A280}"/>
+                <a16:creationId xmlns:a16="http://schemas.microsoft.com/office/drawing/2014/main" id="{C4810B6B-C91B-4BEC-910F-74F77699AE4B}"/>
               </a:ext>
             </a:extLst>
           </p:cNvPr>
@@ -12329,7 +12329,7 @@
           <p:cNvPr id="3" name="">
             <a:extLst xmlns:a="http://schemas.openxmlformats.org/drawingml/2006/main">
               <a:ext uri="{FF2B5EF4-FFF2-40B4-BE49-F238E27FC236}">
-                <a16:creationId xmlns:a16="http://schemas.microsoft.com/office/drawing/2014/main" id="{26770DD8-3C07-4F80-A410-424AAF29CC70}"/>
+                <a16:creationId xmlns:a16="http://schemas.microsoft.com/office/drawing/2014/main" id="{5A4AA09B-1B8D-4C51-B913-EA9B8540A631}"/>
               </a:ext>
             </a:extLst>
           </p:cNvPr>
@@ -12378,7 +12378,7 @@
           <p:cNvPr id="4" name="">
             <a:extLst xmlns:a="http://schemas.openxmlformats.org/drawingml/2006/main">
               <a:ext uri="{FF2B5EF4-FFF2-40B4-BE49-F238E27FC236}">
-                <a16:creationId xmlns:a16="http://schemas.microsoft.com/office/drawing/2014/main" id="{50E8FBBD-83BA-43BE-8E40-7A3812828D23}"/>
+                <a16:creationId xmlns:a16="http://schemas.microsoft.com/office/drawing/2014/main" id="{D647F978-6D55-4A6C-8268-D21C3EBE88F2}"/>
               </a:ext>
             </a:extLst>
           </p:cNvPr>
@@ -12427,7 +12427,7 @@
           <p:cNvPr id="5" name="">
             <a:extLst xmlns:a="http://schemas.openxmlformats.org/drawingml/2006/main">
               <a:ext uri="{FF2B5EF4-FFF2-40B4-BE49-F238E27FC236}">
-                <a16:creationId xmlns:a16="http://schemas.microsoft.com/office/drawing/2014/main" id="{75982B5D-D252-40C9-9C8E-C7743D66DB49}"/>
+                <a16:creationId xmlns:a16="http://schemas.microsoft.com/office/drawing/2014/main" id="{861863EE-122C-4FBF-BC92-6FB485CAF6CE}"/>
               </a:ext>
             </a:extLst>
           </p:cNvPr>
@@ -12476,7 +12476,7 @@
           <p:cNvPr id="6" name="">
             <a:extLst xmlns:a="http://schemas.openxmlformats.org/drawingml/2006/main">
               <a:ext uri="{FF2B5EF4-FFF2-40B4-BE49-F238E27FC236}">
-                <a16:creationId xmlns:a16="http://schemas.microsoft.com/office/drawing/2014/main" id="{A769B60B-5DB3-4769-90FD-2098CFE14609}"/>
+                <a16:creationId xmlns:a16="http://schemas.microsoft.com/office/drawing/2014/main" id="{6DE84822-1FE1-4689-B066-1433742675A9}"/>
               </a:ext>
             </a:extLst>
           </p:cNvPr>
@@ -12525,7 +12525,7 @@
           <p:cNvPr id="7" name="">
             <a:extLst xmlns:a="http://schemas.openxmlformats.org/drawingml/2006/main">
               <a:ext uri="{FF2B5EF4-FFF2-40B4-BE49-F238E27FC236}">
-                <a16:creationId xmlns:a16="http://schemas.microsoft.com/office/drawing/2014/main" id="{E23D54B3-A0EC-4B86-8707-58FBA5185F45}"/>
+                <a16:creationId xmlns:a16="http://schemas.microsoft.com/office/drawing/2014/main" id="{3C756B79-842A-4A22-91F4-DA9A180FDBA7}"/>
               </a:ext>
             </a:extLst>
           </p:cNvPr>
@@ -12574,7 +12574,7 @@
           <p:cNvPr id="8" name="">
             <a:extLst xmlns:a="http://schemas.openxmlformats.org/drawingml/2006/main">
               <a:ext uri="{FF2B5EF4-FFF2-40B4-BE49-F238E27FC236}">
-                <a16:creationId xmlns:a16="http://schemas.microsoft.com/office/drawing/2014/main" id="{19712DD7-6DD4-45B2-B14B-5D7647BFC55B}"/>
+                <a16:creationId xmlns:a16="http://schemas.microsoft.com/office/drawing/2014/main" id="{CA54B467-F51A-4CD3-B4DD-01AC99A7532D}"/>
               </a:ext>
             </a:extLst>
           </p:cNvPr>
@@ -12623,7 +12623,7 @@
           <p:cNvPr id="9" name="">
             <a:extLst xmlns:a="http://schemas.openxmlformats.org/drawingml/2006/main">
               <a:ext uri="{FF2B5EF4-FFF2-40B4-BE49-F238E27FC236}">
-                <a16:creationId xmlns:a16="http://schemas.microsoft.com/office/drawing/2014/main" id="{39485D09-458C-44CE-B091-33522F4759CE}"/>
+                <a16:creationId xmlns:a16="http://schemas.microsoft.com/office/drawing/2014/main" id="{5433427C-22FD-43BA-B824-BA5DBA41B29A}"/>
               </a:ext>
             </a:extLst>
           </p:cNvPr>
@@ -12672,7 +12672,7 @@
           <p:cNvPr id="10" name="">
             <a:extLst xmlns:a="http://schemas.openxmlformats.org/drawingml/2006/main">
               <a:ext uri="{FF2B5EF4-FFF2-40B4-BE49-F238E27FC236}">
-                <a16:creationId xmlns:a16="http://schemas.microsoft.com/office/drawing/2014/main" id="{4A78F7DE-D54B-4407-A332-61B5CCE1FD3F}"/>
+                <a16:creationId xmlns:a16="http://schemas.microsoft.com/office/drawing/2014/main" id="{8D67266D-77B3-4921-A654-4C5FD8F6750F}"/>
               </a:ext>
             </a:extLst>
           </p:cNvPr>
@@ -12721,7 +12721,7 @@
           <p:cNvPr id="11" name="">
             <a:extLst xmlns:a="http://schemas.openxmlformats.org/drawingml/2006/main">
               <a:ext uri="{FF2B5EF4-FFF2-40B4-BE49-F238E27FC236}">
-                <a16:creationId xmlns:a16="http://schemas.microsoft.com/office/drawing/2014/main" id="{BDCE64D4-0A82-4184-8959-831B2F7F1AFD}"/>
+                <a16:creationId xmlns:a16="http://schemas.microsoft.com/office/drawing/2014/main" id="{A0DA417E-F948-412C-8F34-84F5629A6304}"/>
               </a:ext>
             </a:extLst>
           </p:cNvPr>
@@ -12770,7 +12770,7 @@
           <p:cNvPr id="12" name="">
             <a:extLst xmlns:a="http://schemas.openxmlformats.org/drawingml/2006/main">
               <a:ext uri="{FF2B5EF4-FFF2-40B4-BE49-F238E27FC236}">
-                <a16:creationId xmlns:a16="http://schemas.microsoft.com/office/drawing/2014/main" id="{4C2965BD-2511-4334-85B8-09D0A9EBE699}"/>
+                <a16:creationId xmlns:a16="http://schemas.microsoft.com/office/drawing/2014/main" id="{C1C84EEB-1D92-46BA-B5F8-5E6B34EC3EC8}"/>
               </a:ext>
             </a:extLst>
           </p:cNvPr>
@@ -12819,7 +12819,7 @@
           <p:cNvPr id="13" name="">
             <a:extLst xmlns:a="http://schemas.openxmlformats.org/drawingml/2006/main">
               <a:ext uri="{FF2B5EF4-FFF2-40B4-BE49-F238E27FC236}">
-                <a16:creationId xmlns:a16="http://schemas.microsoft.com/office/drawing/2014/main" id="{7EA9152F-3FE5-4115-A818-8F1BFE73B6E9}"/>
+                <a16:creationId xmlns:a16="http://schemas.microsoft.com/office/drawing/2014/main" id="{981F0603-FB09-45E9-981C-0A8D6FC55E09}"/>
               </a:ext>
             </a:extLst>
           </p:cNvPr>
@@ -12868,7 +12868,7 @@
           <p:cNvPr id="14" name="">
             <a:extLst xmlns:a="http://schemas.openxmlformats.org/drawingml/2006/main">
               <a:ext uri="{FF2B5EF4-FFF2-40B4-BE49-F238E27FC236}">
-                <a16:creationId xmlns:a16="http://schemas.microsoft.com/office/drawing/2014/main" id="{67558E21-4572-4A4C-8121-61AB037CB0FA}"/>
+                <a16:creationId xmlns:a16="http://schemas.microsoft.com/office/drawing/2014/main" id="{8461C2F6-E6CA-4896-8A9F-D4D83A5CE28D}"/>
               </a:ext>
             </a:extLst>
           </p:cNvPr>
@@ -12917,7 +12917,7 @@
           <p:cNvPr id="15" name="">
             <a:extLst xmlns:a="http://schemas.openxmlformats.org/drawingml/2006/main">
               <a:ext uri="{FF2B5EF4-FFF2-40B4-BE49-F238E27FC236}">
-                <a16:creationId xmlns:a16="http://schemas.microsoft.com/office/drawing/2014/main" id="{93A7D850-B16E-4DE3-9276-1B14FDF0204F}"/>
+                <a16:creationId xmlns:a16="http://schemas.microsoft.com/office/drawing/2014/main" id="{2E0D1098-78E7-4683-A56B-2A0AB08C3788}"/>
               </a:ext>
             </a:extLst>
           </p:cNvPr>
@@ -12966,7 +12966,7 @@
           <p:cNvPr id="16" name="">
             <a:extLst xmlns:a="http://schemas.openxmlformats.org/drawingml/2006/main">
               <a:ext uri="{FF2B5EF4-FFF2-40B4-BE49-F238E27FC236}">
-                <a16:creationId xmlns:a16="http://schemas.microsoft.com/office/drawing/2014/main" id="{569F4CE4-5A05-4849-9CDD-5CC87C58ECCD}"/>
+                <a16:creationId xmlns:a16="http://schemas.microsoft.com/office/drawing/2014/main" id="{D86656F7-E8DB-4B1D-902B-5BCF12D6EBC6}"/>
               </a:ext>
             </a:extLst>
           </p:cNvPr>
@@ -13015,7 +13015,7 @@
           <p:cNvPr id="17" name="">
             <a:extLst xmlns:a="http://schemas.openxmlformats.org/drawingml/2006/main">
               <a:ext uri="{FF2B5EF4-FFF2-40B4-BE49-F238E27FC236}">
-                <a16:creationId xmlns:a16="http://schemas.microsoft.com/office/drawing/2014/main" id="{16E132A9-65F0-4EFB-9C7E-5CA3FAF8CA0B}"/>
+                <a16:creationId xmlns:a16="http://schemas.microsoft.com/office/drawing/2014/main" id="{647C35D9-7E58-40B8-8C3C-B4F63279FE53}"/>
               </a:ext>
             </a:extLst>
           </p:cNvPr>
@@ -13064,7 +13064,7 @@
           <p:cNvPr id="18" name="">
             <a:extLst xmlns:a="http://schemas.openxmlformats.org/drawingml/2006/main">
               <a:ext uri="{FF2B5EF4-FFF2-40B4-BE49-F238E27FC236}">
-                <a16:creationId xmlns:a16="http://schemas.microsoft.com/office/drawing/2014/main" id="{E1145217-6908-486A-8E89-051B4421AD24}"/>
+                <a16:creationId xmlns:a16="http://schemas.microsoft.com/office/drawing/2014/main" id="{3F669B01-437D-47B8-85EA-B9BC7FD28002}"/>
               </a:ext>
             </a:extLst>
           </p:cNvPr>
@@ -13113,7 +13113,7 @@
           <p:cNvPr id="19" name="">
             <a:extLst xmlns:a="http://schemas.openxmlformats.org/drawingml/2006/main">
               <a:ext uri="{FF2B5EF4-FFF2-40B4-BE49-F238E27FC236}">
-                <a16:creationId xmlns:a16="http://schemas.microsoft.com/office/drawing/2014/main" id="{7C1C6B42-16F7-4CC5-84A2-EE32C632BCA2}"/>
+                <a16:creationId xmlns:a16="http://schemas.microsoft.com/office/drawing/2014/main" id="{EAB624E3-CC3C-4592-AD0D-1801338B315F}"/>
               </a:ext>
             </a:extLst>
           </p:cNvPr>
@@ -13162,7 +13162,7 @@
           <p:cNvPr id="20" name="">
             <a:extLst xmlns:a="http://schemas.openxmlformats.org/drawingml/2006/main">
               <a:ext uri="{FF2B5EF4-FFF2-40B4-BE49-F238E27FC236}">
-                <a16:creationId xmlns:a16="http://schemas.microsoft.com/office/drawing/2014/main" id="{A3DAC59B-ADFD-43EB-BCF1-9963590E5C94}"/>
+                <a16:creationId xmlns:a16="http://schemas.microsoft.com/office/drawing/2014/main" id="{01FA6C5F-F5E2-476C-843E-7AE2B9C823E5}"/>
               </a:ext>
             </a:extLst>
           </p:cNvPr>
@@ -13211,7 +13211,7 @@
           <p:cNvPr id="21" name="">
             <a:extLst xmlns:a="http://schemas.openxmlformats.org/drawingml/2006/main">
               <a:ext uri="{FF2B5EF4-FFF2-40B4-BE49-F238E27FC236}">
-                <a16:creationId xmlns:a16="http://schemas.microsoft.com/office/drawing/2014/main" id="{23C888EA-ED5B-4AD6-A612-FDAC5B8CF175}"/>
+                <a16:creationId xmlns:a16="http://schemas.microsoft.com/office/drawing/2014/main" id="{EEE86B8A-2FDF-49F5-BA80-F4FD3AFFB078}"/>
               </a:ext>
             </a:extLst>
           </p:cNvPr>
@@ -13260,7 +13260,7 @@
           <p:cNvPr id="22" name="">
             <a:extLst xmlns:a="http://schemas.openxmlformats.org/drawingml/2006/main">
               <a:ext uri="{FF2B5EF4-FFF2-40B4-BE49-F238E27FC236}">
-                <a16:creationId xmlns:a16="http://schemas.microsoft.com/office/drawing/2014/main" id="{C3AB0DC4-D47C-4388-A4BE-6D4435BB691D}"/>
+                <a16:creationId xmlns:a16="http://schemas.microsoft.com/office/drawing/2014/main" id="{82D82E3C-EFC7-4350-B1E0-A0876C010EAC}"/>
               </a:ext>
             </a:extLst>
           </p:cNvPr>
@@ -13309,7 +13309,7 @@
           <p:cNvPr id="23" name="">
             <a:extLst xmlns:a="http://schemas.openxmlformats.org/drawingml/2006/main">
               <a:ext uri="{FF2B5EF4-FFF2-40B4-BE49-F238E27FC236}">
-                <a16:creationId xmlns:a16="http://schemas.microsoft.com/office/drawing/2014/main" id="{BF797DEA-A024-4500-95F2-B078E67C0A1D}"/>
+                <a16:creationId xmlns:a16="http://schemas.microsoft.com/office/drawing/2014/main" id="{B646D042-ACA9-4E01-93EE-310832945BF5}"/>
               </a:ext>
             </a:extLst>
           </p:cNvPr>
@@ -13358,7 +13358,7 @@
           <p:cNvPr id="24" name="">
             <a:extLst xmlns:a="http://schemas.openxmlformats.org/drawingml/2006/main">
               <a:ext uri="{FF2B5EF4-FFF2-40B4-BE49-F238E27FC236}">
-                <a16:creationId xmlns:a16="http://schemas.microsoft.com/office/drawing/2014/main" id="{3F7924F2-4F5C-499E-9662-6E5AE839D01A}"/>
+                <a16:creationId xmlns:a16="http://schemas.microsoft.com/office/drawing/2014/main" id="{FF4D3B72-021E-4CCE-95C0-2485074C09E4}"/>
               </a:ext>
             </a:extLst>
           </p:cNvPr>
@@ -13407,7 +13407,7 @@
           <p:cNvPr id="25" name="">
             <a:extLst xmlns:a="http://schemas.openxmlformats.org/drawingml/2006/main">
               <a:ext uri="{FF2B5EF4-FFF2-40B4-BE49-F238E27FC236}">
-                <a16:creationId xmlns:a16="http://schemas.microsoft.com/office/drawing/2014/main" id="{6AB745FA-E3E6-4744-BB05-FB5A8932C0FA}"/>
+                <a16:creationId xmlns:a16="http://schemas.microsoft.com/office/drawing/2014/main" id="{00AD9628-988E-41A0-89D7-ACB8328CD97E}"/>
               </a:ext>
             </a:extLst>
           </p:cNvPr>
@@ -13456,7 +13456,7 @@
           <p:cNvPr id="26" name="">
             <a:extLst xmlns:a="http://schemas.openxmlformats.org/drawingml/2006/main">
               <a:ext uri="{FF2B5EF4-FFF2-40B4-BE49-F238E27FC236}">
-                <a16:creationId xmlns:a16="http://schemas.microsoft.com/office/drawing/2014/main" id="{2667B090-4C8A-43BA-86C9-3A2E50B4F653}"/>
+                <a16:creationId xmlns:a16="http://schemas.microsoft.com/office/drawing/2014/main" id="{D1A16CD6-DF9A-46A0-A3F6-9A3FAE30BDBF}"/>
               </a:ext>
             </a:extLst>
           </p:cNvPr>
@@ -13505,7 +13505,7 @@
           <p:cNvPr id="27" name="">
             <a:extLst xmlns:a="http://schemas.openxmlformats.org/drawingml/2006/main">
               <a:ext uri="{FF2B5EF4-FFF2-40B4-BE49-F238E27FC236}">
-                <a16:creationId xmlns:a16="http://schemas.microsoft.com/office/drawing/2014/main" id="{051D06DC-F0CA-43D2-8BCC-B45DE435D4C7}"/>
+                <a16:creationId xmlns:a16="http://schemas.microsoft.com/office/drawing/2014/main" id="{1333EB2F-E790-4508-9E55-B429B6495B64}"/>
               </a:ext>
             </a:extLst>
           </p:cNvPr>
@@ -13552,7 +13552,7 @@
     </p:spTree>
     <p:extLst>
       <p:ext uri="{BB962C8B-B14F-4D97-AF65-F5344CB8AC3E}">
-        <p14:creationId xmlns:p14="http://schemas.microsoft.com/office/powerpoint/2010/main" val="977853325"/>
+        <p14:creationId xmlns:p14="http://schemas.microsoft.com/office/powerpoint/2010/main" val="774265116"/>
       </p:ext>
     </p:extLst>
   </p:cSld>
@@ -13583,7 +13583,7 @@
           <p:cNvPr id="13" name="">
             <a:extLst xmlns:a="http://schemas.openxmlformats.org/drawingml/2006/main">
               <a:ext uri="{FF2B5EF4-FFF2-40B4-BE49-F238E27FC236}">
-                <a16:creationId xmlns:a16="http://schemas.microsoft.com/office/drawing/2014/main" id="{90222BC9-C572-4B4D-B8F7-53AB7D3D436D}"/>
+                <a16:creationId xmlns:a16="http://schemas.microsoft.com/office/drawing/2014/main" id="{2D2F4CFE-BF5B-4D30-9CD7-7C7ABBDA4326}"/>
               </a:ext>
             </a:extLst>
           </p:cNvPr>
@@ -13632,7 +13632,7 @@
           <p:cNvPr id="2" name="">
             <a:extLst xmlns:a="http://schemas.openxmlformats.org/drawingml/2006/main">
               <a:ext uri="{FF2B5EF4-FFF2-40B4-BE49-F238E27FC236}">
-                <a16:creationId xmlns:a16="http://schemas.microsoft.com/office/drawing/2014/main" id="{7149AD50-48FF-4966-A01B-1CD5033F80B4}"/>
+                <a16:creationId xmlns:a16="http://schemas.microsoft.com/office/drawing/2014/main" id="{3241C87A-2011-4DC4-909C-256FF0298199}"/>
               </a:ext>
             </a:extLst>
           </p:cNvPr>
@@ -13681,7 +13681,7 @@
           <p:cNvPr id="3" name="">
             <a:extLst xmlns:a="http://schemas.openxmlformats.org/drawingml/2006/main">
               <a:ext uri="{FF2B5EF4-FFF2-40B4-BE49-F238E27FC236}">
-                <a16:creationId xmlns:a16="http://schemas.microsoft.com/office/drawing/2014/main" id="{78B3B46B-6AEA-41F8-9442-A7999D3B16DC}"/>
+                <a16:creationId xmlns:a16="http://schemas.microsoft.com/office/drawing/2014/main" id="{22A3F1A9-CC73-426A-8452-AEDE0BDB440B}"/>
               </a:ext>
             </a:extLst>
           </p:cNvPr>
@@ -13730,7 +13730,7 @@
           <p:cNvPr id="4" name="">
             <a:extLst xmlns:a="http://schemas.openxmlformats.org/drawingml/2006/main">
               <a:ext uri="{FF2B5EF4-FFF2-40B4-BE49-F238E27FC236}">
-                <a16:creationId xmlns:a16="http://schemas.microsoft.com/office/drawing/2014/main" id="{B029122F-EBD4-40AE-BB59-081848115A08}"/>
+                <a16:creationId xmlns:a16="http://schemas.microsoft.com/office/drawing/2014/main" id="{0F4B5B2B-9180-4648-871B-A0241775947B}"/>
               </a:ext>
             </a:extLst>
           </p:cNvPr>
@@ -13779,7 +13779,7 @@
           <p:cNvPr id="5" name="">
             <a:extLst xmlns:a="http://schemas.openxmlformats.org/drawingml/2006/main">
               <a:ext uri="{FF2B5EF4-FFF2-40B4-BE49-F238E27FC236}">
-                <a16:creationId xmlns:a16="http://schemas.microsoft.com/office/drawing/2014/main" id="{A721C891-9851-48BC-B133-A7F0AE10EA5A}"/>
+                <a16:creationId xmlns:a16="http://schemas.microsoft.com/office/drawing/2014/main" id="{290AD38E-847C-4D9D-A2CB-0FB80556ACC9}"/>
               </a:ext>
             </a:extLst>
           </p:cNvPr>
@@ -13828,7 +13828,7 @@
           <p:cNvPr id="6" name="">
             <a:extLst xmlns:a="http://schemas.openxmlformats.org/drawingml/2006/main">
               <a:ext uri="{FF2B5EF4-FFF2-40B4-BE49-F238E27FC236}">
-                <a16:creationId xmlns:a16="http://schemas.microsoft.com/office/drawing/2014/main" id="{8F19E0B5-A48C-4E8E-B58C-3A47C02DC9C9}"/>
+                <a16:creationId xmlns:a16="http://schemas.microsoft.com/office/drawing/2014/main" id="{EEF70657-E5E9-4787-8D97-ADF737ED25E0}"/>
               </a:ext>
             </a:extLst>
           </p:cNvPr>
@@ -13877,7 +13877,7 @@
           <p:cNvPr id="7" name="">
             <a:extLst xmlns:a="http://schemas.openxmlformats.org/drawingml/2006/main">
               <a:ext uri="{FF2B5EF4-FFF2-40B4-BE49-F238E27FC236}">
-                <a16:creationId xmlns:a16="http://schemas.microsoft.com/office/drawing/2014/main" id="{4906E997-F6BE-44C4-A70A-D07117DD3568}"/>
+                <a16:creationId xmlns:a16="http://schemas.microsoft.com/office/drawing/2014/main" id="{527DA6D9-71B6-4028-904A-A3A0F598DE30}"/>
               </a:ext>
             </a:extLst>
           </p:cNvPr>
@@ -13926,7 +13926,7 @@
           <p:cNvPr id="8" name="">
             <a:extLst xmlns:a="http://schemas.openxmlformats.org/drawingml/2006/main">
               <a:ext uri="{FF2B5EF4-FFF2-40B4-BE49-F238E27FC236}">
-                <a16:creationId xmlns:a16="http://schemas.microsoft.com/office/drawing/2014/main" id="{596DC16A-C896-4FDF-B3F1-96BA6577CBAE}"/>
+                <a16:creationId xmlns:a16="http://schemas.microsoft.com/office/drawing/2014/main" id="{BC096EEA-E129-4C1D-BC91-8FB4BD00C6D3}"/>
               </a:ext>
             </a:extLst>
           </p:cNvPr>
@@ -13975,7 +13975,7 @@
           <p:cNvPr id="9" name="">
             <a:extLst xmlns:a="http://schemas.openxmlformats.org/drawingml/2006/main">
               <a:ext uri="{FF2B5EF4-FFF2-40B4-BE49-F238E27FC236}">
-                <a16:creationId xmlns:a16="http://schemas.microsoft.com/office/drawing/2014/main" id="{C867B9BE-FBD8-429E-8509-C4F873F2BF1F}"/>
+                <a16:creationId xmlns:a16="http://schemas.microsoft.com/office/drawing/2014/main" id="{0B8A9314-7097-438F-B34B-BDCFA1139636}"/>
               </a:ext>
             </a:extLst>
           </p:cNvPr>
@@ -14024,7 +14024,7 @@
           <p:cNvPr id="10" name="">
             <a:extLst xmlns:a="http://schemas.openxmlformats.org/drawingml/2006/main">
               <a:ext uri="{FF2B5EF4-FFF2-40B4-BE49-F238E27FC236}">
-                <a16:creationId xmlns:a16="http://schemas.microsoft.com/office/drawing/2014/main" id="{2772EBB7-7E30-4671-8837-A71C4A5ECA5D}"/>
+                <a16:creationId xmlns:a16="http://schemas.microsoft.com/office/drawing/2014/main" id="{4148C060-4BA9-4B6B-8394-37728EB4A183}"/>
               </a:ext>
             </a:extLst>
           </p:cNvPr>
@@ -14073,7 +14073,7 @@
           <p:cNvPr id="11" name="">
             <a:extLst xmlns:a="http://schemas.openxmlformats.org/drawingml/2006/main">
               <a:ext uri="{FF2B5EF4-FFF2-40B4-BE49-F238E27FC236}">
-                <a16:creationId xmlns:a16="http://schemas.microsoft.com/office/drawing/2014/main" id="{5BCAD635-9722-4B54-8D59-C4DDC44814E3}"/>
+                <a16:creationId xmlns:a16="http://schemas.microsoft.com/office/drawing/2014/main" id="{CED65884-5643-4132-BF8A-12D2C3D1F4E1}"/>
               </a:ext>
             </a:extLst>
           </p:cNvPr>
@@ -14122,7 +14122,7 @@
           <p:cNvPr id="12" name="">
             <a:extLst xmlns:a="http://schemas.openxmlformats.org/drawingml/2006/main">
               <a:ext uri="{FF2B5EF4-FFF2-40B4-BE49-F238E27FC236}">
-                <a16:creationId xmlns:a16="http://schemas.microsoft.com/office/drawing/2014/main" id="{9E469757-38B3-4BC3-964D-6BEB6AFEB147}"/>
+                <a16:creationId xmlns:a16="http://schemas.microsoft.com/office/drawing/2014/main" id="{4FBF1086-8C20-44E8-A2FB-45583118464E}"/>
               </a:ext>
             </a:extLst>
           </p:cNvPr>
@@ -14169,7 +14169,7 @@
     </p:spTree>
     <p:extLst>
       <p:ext uri="{BB962C8B-B14F-4D97-AF65-F5344CB8AC3E}">
-        <p14:creationId xmlns:p14="http://schemas.microsoft.com/office/powerpoint/2010/main" val="954280617"/>
+        <p14:creationId xmlns:p14="http://schemas.microsoft.com/office/powerpoint/2010/main" val="2014761744"/>
       </p:ext>
     </p:extLst>
   </p:cSld>
@@ -14200,7 +14200,7 @@
           <p:cNvPr id="13" name="">
             <a:extLst xmlns:a="http://schemas.openxmlformats.org/drawingml/2006/main">
               <a:ext uri="{FF2B5EF4-FFF2-40B4-BE49-F238E27FC236}">
-                <a16:creationId xmlns:a16="http://schemas.microsoft.com/office/drawing/2014/main" id="{204595EF-FDEB-4168-8F58-4ABC3B9F18C7}"/>
+                <a16:creationId xmlns:a16="http://schemas.microsoft.com/office/drawing/2014/main" id="{801B8E86-9224-4495-B8B7-17F763544E91}"/>
               </a:ext>
             </a:extLst>
           </p:cNvPr>
@@ -14249,7 +14249,7 @@
           <p:cNvPr id="2" name="">
             <a:extLst xmlns:a="http://schemas.openxmlformats.org/drawingml/2006/main">
               <a:ext uri="{FF2B5EF4-FFF2-40B4-BE49-F238E27FC236}">
-                <a16:creationId xmlns:a16="http://schemas.microsoft.com/office/drawing/2014/main" id="{2895F804-A549-411E-8FDD-F9FB43CBD2EA}"/>
+                <a16:creationId xmlns:a16="http://schemas.microsoft.com/office/drawing/2014/main" id="{5E4850E3-8832-4D01-88D1-75D5A8EBA6DB}"/>
               </a:ext>
             </a:extLst>
           </p:cNvPr>
@@ -14298,7 +14298,7 @@
           <p:cNvPr id="3" name="">
             <a:extLst xmlns:a="http://schemas.openxmlformats.org/drawingml/2006/main">
               <a:ext uri="{FF2B5EF4-FFF2-40B4-BE49-F238E27FC236}">
-                <a16:creationId xmlns:a16="http://schemas.microsoft.com/office/drawing/2014/main" id="{85D91C80-84FE-4DF4-8633-3C61015E751B}"/>
+                <a16:creationId xmlns:a16="http://schemas.microsoft.com/office/drawing/2014/main" id="{2BBD2EA4-6727-4945-A7BF-7255D33F1047}"/>
               </a:ext>
             </a:extLst>
           </p:cNvPr>
@@ -14347,7 +14347,7 @@
           <p:cNvPr id="4" name="">
             <a:extLst xmlns:a="http://schemas.openxmlformats.org/drawingml/2006/main">
               <a:ext uri="{FF2B5EF4-FFF2-40B4-BE49-F238E27FC236}">
-                <a16:creationId xmlns:a16="http://schemas.microsoft.com/office/drawing/2014/main" id="{235C957A-A81D-4892-A6A3-0FDB15EFCDBB}"/>
+                <a16:creationId xmlns:a16="http://schemas.microsoft.com/office/drawing/2014/main" id="{0908D103-3C39-4D2C-939B-1925A351CDE6}"/>
               </a:ext>
             </a:extLst>
           </p:cNvPr>
@@ -14396,7 +14396,7 @@
           <p:cNvPr id="5" name="">
             <a:extLst xmlns:a="http://schemas.openxmlformats.org/drawingml/2006/main">
               <a:ext uri="{FF2B5EF4-FFF2-40B4-BE49-F238E27FC236}">
-                <a16:creationId xmlns:a16="http://schemas.microsoft.com/office/drawing/2014/main" id="{68EDC12A-98BB-4446-BEBF-4FB8B1B9F1AA}"/>
+                <a16:creationId xmlns:a16="http://schemas.microsoft.com/office/drawing/2014/main" id="{4DB850B4-1EC8-401B-ADC9-A5185C546B8F}"/>
               </a:ext>
             </a:extLst>
           </p:cNvPr>
@@ -14445,7 +14445,7 @@
           <p:cNvPr id="6" name="">
             <a:extLst xmlns:a="http://schemas.openxmlformats.org/drawingml/2006/main">
               <a:ext uri="{FF2B5EF4-FFF2-40B4-BE49-F238E27FC236}">
-                <a16:creationId xmlns:a16="http://schemas.microsoft.com/office/drawing/2014/main" id="{F96D98B5-1582-4D21-9820-DDD8CF4EC6D3}"/>
+                <a16:creationId xmlns:a16="http://schemas.microsoft.com/office/drawing/2014/main" id="{E8511F0E-0512-40C5-9671-1BF713DF58E6}"/>
               </a:ext>
             </a:extLst>
           </p:cNvPr>
@@ -14494,7 +14494,7 @@
           <p:cNvPr id="7" name="">
             <a:extLst xmlns:a="http://schemas.openxmlformats.org/drawingml/2006/main">
               <a:ext uri="{FF2B5EF4-FFF2-40B4-BE49-F238E27FC236}">
-                <a16:creationId xmlns:a16="http://schemas.microsoft.com/office/drawing/2014/main" id="{A8D8C164-A956-4F7B-9B45-23209663244C}"/>
+                <a16:creationId xmlns:a16="http://schemas.microsoft.com/office/drawing/2014/main" id="{F4A7DB8E-BF2E-4635-879A-B5939976AD34}"/>
               </a:ext>
             </a:extLst>
           </p:cNvPr>
@@ -14573,7 +14573,7 @@
           <p:cNvPr id="8" name="">
             <a:extLst xmlns:a="http://schemas.openxmlformats.org/drawingml/2006/main">
               <a:ext uri="{FF2B5EF4-FFF2-40B4-BE49-F238E27FC236}">
-                <a16:creationId xmlns:a16="http://schemas.microsoft.com/office/drawing/2014/main" id="{95D97CE5-D2CD-4BA1-8FB8-E78ABC06E0E6}"/>
+                <a16:creationId xmlns:a16="http://schemas.microsoft.com/office/drawing/2014/main" id="{199931C9-2ADB-4A54-B950-FF3CBBDB8034}"/>
               </a:ext>
             </a:extLst>
           </p:cNvPr>
@@ -14622,7 +14622,7 @@
           <p:cNvPr id="9" name="">
             <a:extLst xmlns:a="http://schemas.openxmlformats.org/drawingml/2006/main">
               <a:ext uri="{FF2B5EF4-FFF2-40B4-BE49-F238E27FC236}">
-                <a16:creationId xmlns:a16="http://schemas.microsoft.com/office/drawing/2014/main" id="{9EE901B0-675F-4194-B8E6-72F1C1BE1B48}"/>
+                <a16:creationId xmlns:a16="http://schemas.microsoft.com/office/drawing/2014/main" id="{00B336E2-06D5-4967-8570-BF16EE4600E7}"/>
               </a:ext>
             </a:extLst>
           </p:cNvPr>
@@ -14701,7 +14701,7 @@
           <p:cNvPr id="10" name="">
             <a:extLst xmlns:a="http://schemas.openxmlformats.org/drawingml/2006/main">
               <a:ext uri="{FF2B5EF4-FFF2-40B4-BE49-F238E27FC236}">
-                <a16:creationId xmlns:a16="http://schemas.microsoft.com/office/drawing/2014/main" id="{D49C392C-E281-49EF-8D12-30476B05ABCF}"/>
+                <a16:creationId xmlns:a16="http://schemas.microsoft.com/office/drawing/2014/main" id="{0092AE4F-6A0C-4A95-947D-5A82A4D9BABE}"/>
               </a:ext>
             </a:extLst>
           </p:cNvPr>
@@ -14750,7 +14750,7 @@
           <p:cNvPr id="11" name="">
             <a:extLst xmlns:a="http://schemas.openxmlformats.org/drawingml/2006/main">
               <a:ext uri="{FF2B5EF4-FFF2-40B4-BE49-F238E27FC236}">
-                <a16:creationId xmlns:a16="http://schemas.microsoft.com/office/drawing/2014/main" id="{56554C42-C1E4-4ABD-B86C-473ECD379EBC}"/>
+                <a16:creationId xmlns:a16="http://schemas.microsoft.com/office/drawing/2014/main" id="{3D82C7A5-D73B-4166-BD91-BA83C45A1A9B}"/>
               </a:ext>
             </a:extLst>
           </p:cNvPr>
@@ -14829,7 +14829,7 @@
           <p:cNvPr id="12" name="">
             <a:extLst xmlns:a="http://schemas.openxmlformats.org/drawingml/2006/main">
               <a:ext uri="{FF2B5EF4-FFF2-40B4-BE49-F238E27FC236}">
-                <a16:creationId xmlns:a16="http://schemas.microsoft.com/office/drawing/2014/main" id="{B1BFF639-3CC0-4908-BCD6-2A78046927DD}"/>
+                <a16:creationId xmlns:a16="http://schemas.microsoft.com/office/drawing/2014/main" id="{F1AE58F3-10DE-4F9F-A301-2386FE6BA09B}"/>
               </a:ext>
             </a:extLst>
           </p:cNvPr>
@@ -14876,7 +14876,7 @@
     </p:spTree>
     <p:extLst>
       <p:ext uri="{BB962C8B-B14F-4D97-AF65-F5344CB8AC3E}">
-        <p14:creationId xmlns:p14="http://schemas.microsoft.com/office/powerpoint/2010/main" val="700685554"/>
+        <p14:creationId xmlns:p14="http://schemas.microsoft.com/office/powerpoint/2010/main" val="1384750674"/>
       </p:ext>
     </p:extLst>
   </p:cSld>
@@ -14907,7 +14907,7 @@
           <p:cNvPr id="16" name="">
             <a:extLst xmlns:a="http://schemas.openxmlformats.org/drawingml/2006/main">
               <a:ext uri="{FF2B5EF4-FFF2-40B4-BE49-F238E27FC236}">
-                <a16:creationId xmlns:a16="http://schemas.microsoft.com/office/drawing/2014/main" id="{83320120-EB40-42B1-8717-DD81E55A3558}"/>
+                <a16:creationId xmlns:a16="http://schemas.microsoft.com/office/drawing/2014/main" id="{A84A2E98-4669-48FF-943F-4A63E17D8722}"/>
               </a:ext>
             </a:extLst>
           </p:cNvPr>
@@ -14956,7 +14956,7 @@
           <p:cNvPr id="2" name="">
             <a:extLst xmlns:a="http://schemas.openxmlformats.org/drawingml/2006/main">
               <a:ext uri="{FF2B5EF4-FFF2-40B4-BE49-F238E27FC236}">
-                <a16:creationId xmlns:a16="http://schemas.microsoft.com/office/drawing/2014/main" id="{8CC65F1C-4BD1-4410-B5E7-16C697BB26C5}"/>
+                <a16:creationId xmlns:a16="http://schemas.microsoft.com/office/drawing/2014/main" id="{8FD0A4B7-DA5F-4E16-9BCE-06FFD612603C}"/>
               </a:ext>
             </a:extLst>
           </p:cNvPr>
@@ -15005,7 +15005,7 @@
           <p:cNvPr id="3" name="">
             <a:extLst xmlns:a="http://schemas.openxmlformats.org/drawingml/2006/main">
               <a:ext uri="{FF2B5EF4-FFF2-40B4-BE49-F238E27FC236}">
-                <a16:creationId xmlns:a16="http://schemas.microsoft.com/office/drawing/2014/main" id="{9BDF837B-C8DD-4217-AC9F-4B5A357BC13F}"/>
+                <a16:creationId xmlns:a16="http://schemas.microsoft.com/office/drawing/2014/main" id="{97948BEC-1EBD-4544-9CAC-43A00E3975B3}"/>
               </a:ext>
             </a:extLst>
           </p:cNvPr>
@@ -15054,7 +15054,7 @@
           <p:cNvPr id="4" name="">
             <a:extLst xmlns:a="http://schemas.openxmlformats.org/drawingml/2006/main">
               <a:ext uri="{FF2B5EF4-FFF2-40B4-BE49-F238E27FC236}">
-                <a16:creationId xmlns:a16="http://schemas.microsoft.com/office/drawing/2014/main" id="{336C6D72-6F7E-4A40-99C2-80A266F2C1F3}"/>
+                <a16:creationId xmlns:a16="http://schemas.microsoft.com/office/drawing/2014/main" id="{0C769192-59C5-4863-BD0B-563D29623CE2}"/>
               </a:ext>
             </a:extLst>
           </p:cNvPr>
@@ -15103,7 +15103,7 @@
           <p:cNvPr id="5" name="">
             <a:extLst xmlns:a="http://schemas.openxmlformats.org/drawingml/2006/main">
               <a:ext uri="{FF2B5EF4-FFF2-40B4-BE49-F238E27FC236}">
-                <a16:creationId xmlns:a16="http://schemas.microsoft.com/office/drawing/2014/main" id="{18F66604-9CAF-4752-9918-5E30BB1C20E2}"/>
+                <a16:creationId xmlns:a16="http://schemas.microsoft.com/office/drawing/2014/main" id="{87838F31-13CC-4129-995E-5FB54AD32AC9}"/>
               </a:ext>
             </a:extLst>
           </p:cNvPr>
@@ -15152,7 +15152,7 @@
           <p:cNvPr id="6" name="">
             <a:extLst xmlns:a="http://schemas.openxmlformats.org/drawingml/2006/main">
               <a:ext uri="{FF2B5EF4-FFF2-40B4-BE49-F238E27FC236}">
-                <a16:creationId xmlns:a16="http://schemas.microsoft.com/office/drawing/2014/main" id="{57A49CEF-35D5-45F2-8017-2F3437182893}"/>
+                <a16:creationId xmlns:a16="http://schemas.microsoft.com/office/drawing/2014/main" id="{03A2A3B2-ED4D-4A4C-90C5-A6BA845230D2}"/>
               </a:ext>
             </a:extLst>
           </p:cNvPr>
@@ -15201,7 +15201,7 @@
           <p:cNvPr id="7" name="">
             <a:extLst xmlns:a="http://schemas.openxmlformats.org/drawingml/2006/main">
               <a:ext uri="{FF2B5EF4-FFF2-40B4-BE49-F238E27FC236}">
-                <a16:creationId xmlns:a16="http://schemas.microsoft.com/office/drawing/2014/main" id="{01E646AF-E669-4083-9618-769AB51A1314}"/>
+                <a16:creationId xmlns:a16="http://schemas.microsoft.com/office/drawing/2014/main" id="{561AEA13-A555-4879-ACC9-72442E712915}"/>
               </a:ext>
             </a:extLst>
           </p:cNvPr>
@@ -15250,7 +15250,7 @@
           <p:cNvPr id="8" name="">
             <a:extLst xmlns:a="http://schemas.openxmlformats.org/drawingml/2006/main">
               <a:ext uri="{FF2B5EF4-FFF2-40B4-BE49-F238E27FC236}">
-                <a16:creationId xmlns:a16="http://schemas.microsoft.com/office/drawing/2014/main" id="{2E802587-6D6C-46A2-9E5A-5D2FEC85220E}"/>
+                <a16:creationId xmlns:a16="http://schemas.microsoft.com/office/drawing/2014/main" id="{C3B4BC9C-DBCF-4AD0-ADF4-0D6C992996D6}"/>
               </a:ext>
             </a:extLst>
           </p:cNvPr>
@@ -15299,7 +15299,7 @@
           <p:cNvPr id="9" name="">
             <a:extLst xmlns:a="http://schemas.openxmlformats.org/drawingml/2006/main">
               <a:ext uri="{FF2B5EF4-FFF2-40B4-BE49-F238E27FC236}">
-                <a16:creationId xmlns:a16="http://schemas.microsoft.com/office/drawing/2014/main" id="{C21FA418-CC57-4FEC-9E8D-E1B2533943D6}"/>
+                <a16:creationId xmlns:a16="http://schemas.microsoft.com/office/drawing/2014/main" id="{249EA0E7-BB85-4BDA-8E51-61E392F15232}"/>
               </a:ext>
             </a:extLst>
           </p:cNvPr>
@@ -15348,7 +15348,7 @@
           <p:cNvPr id="10" name="">
             <a:extLst xmlns:a="http://schemas.openxmlformats.org/drawingml/2006/main">
               <a:ext uri="{FF2B5EF4-FFF2-40B4-BE49-F238E27FC236}">
-                <a16:creationId xmlns:a16="http://schemas.microsoft.com/office/drawing/2014/main" id="{D32ECAC5-5367-4C1E-9EFE-F627070ED42A}"/>
+                <a16:creationId xmlns:a16="http://schemas.microsoft.com/office/drawing/2014/main" id="{622DC96F-494F-4AE6-900F-29BDDF8990E5}"/>
               </a:ext>
             </a:extLst>
           </p:cNvPr>
@@ -15397,7 +15397,7 @@
           <p:cNvPr id="11" name="">
             <a:extLst xmlns:a="http://schemas.openxmlformats.org/drawingml/2006/main">
               <a:ext uri="{FF2B5EF4-FFF2-40B4-BE49-F238E27FC236}">
-                <a16:creationId xmlns:a16="http://schemas.microsoft.com/office/drawing/2014/main" id="{990D9AF4-692F-43C5-80F1-0A7D26A7BC70}"/>
+                <a16:creationId xmlns:a16="http://schemas.microsoft.com/office/drawing/2014/main" id="{216D41D9-07E3-43FA-8714-6847981E5DC6}"/>
               </a:ext>
             </a:extLst>
           </p:cNvPr>
@@ -15446,7 +15446,7 @@
           <p:cNvPr id="12" name="">
             <a:extLst xmlns:a="http://schemas.openxmlformats.org/drawingml/2006/main">
               <a:ext uri="{FF2B5EF4-FFF2-40B4-BE49-F238E27FC236}">
-                <a16:creationId xmlns:a16="http://schemas.microsoft.com/office/drawing/2014/main" id="{504DE52F-A24A-4BB4-A172-D7A2A49401DA}"/>
+                <a16:creationId xmlns:a16="http://schemas.microsoft.com/office/drawing/2014/main" id="{BF6E8769-083C-4C64-B475-11E77020A6D1}"/>
               </a:ext>
             </a:extLst>
           </p:cNvPr>
@@ -15495,7 +15495,7 @@
           <p:cNvPr id="13" name="">
             <a:extLst xmlns:a="http://schemas.openxmlformats.org/drawingml/2006/main">
               <a:ext uri="{FF2B5EF4-FFF2-40B4-BE49-F238E27FC236}">
-                <a16:creationId xmlns:a16="http://schemas.microsoft.com/office/drawing/2014/main" id="{289B3D1F-B97D-4DC1-BD89-5859CE2CE390}"/>
+                <a16:creationId xmlns:a16="http://schemas.microsoft.com/office/drawing/2014/main" id="{477D2FCB-DEBF-4573-A96A-73183557C88F}"/>
               </a:ext>
             </a:extLst>
           </p:cNvPr>
@@ -15544,7 +15544,7 @@
           <p:cNvPr id="14" name="">
             <a:extLst xmlns:a="http://schemas.openxmlformats.org/drawingml/2006/main">
               <a:ext uri="{FF2B5EF4-FFF2-40B4-BE49-F238E27FC236}">
-                <a16:creationId xmlns:a16="http://schemas.microsoft.com/office/drawing/2014/main" id="{36655F8A-EF2D-4649-BCDB-C3B4938DC42A}"/>
+                <a16:creationId xmlns:a16="http://schemas.microsoft.com/office/drawing/2014/main" id="{3D486965-7DA5-4DF4-AF28-2B01ECD8430A}"/>
               </a:ext>
             </a:extLst>
           </p:cNvPr>
@@ -15593,7 +15593,7 @@
           <p:cNvPr id="15" name="">
             <a:extLst xmlns:a="http://schemas.openxmlformats.org/drawingml/2006/main">
               <a:ext uri="{FF2B5EF4-FFF2-40B4-BE49-F238E27FC236}">
-                <a16:creationId xmlns:a16="http://schemas.microsoft.com/office/drawing/2014/main" id="{71F0FD03-622F-4228-BABE-CDC658187E47}"/>
+                <a16:creationId xmlns:a16="http://schemas.microsoft.com/office/drawing/2014/main" id="{ADB87C05-D60F-419E-B478-363BA8781A21}"/>
               </a:ext>
             </a:extLst>
           </p:cNvPr>
@@ -15640,7 +15640,7 @@
     </p:spTree>
     <p:extLst>
       <p:ext uri="{BB962C8B-B14F-4D97-AF65-F5344CB8AC3E}">
-        <p14:creationId xmlns:p14="http://schemas.microsoft.com/office/powerpoint/2010/main" val="1721388270"/>
+        <p14:creationId xmlns:p14="http://schemas.microsoft.com/office/powerpoint/2010/main" val="647454743"/>
       </p:ext>
     </p:extLst>
   </p:cSld>
@@ -15671,7 +15671,7 @@
           <p:cNvPr id="13" name="">
             <a:extLst xmlns:a="http://schemas.openxmlformats.org/drawingml/2006/main">
               <a:ext uri="{FF2B5EF4-FFF2-40B4-BE49-F238E27FC236}">
-                <a16:creationId xmlns:a16="http://schemas.microsoft.com/office/drawing/2014/main" id="{4857E710-DC8A-4493-B18C-C5D3D15C8AED}"/>
+                <a16:creationId xmlns:a16="http://schemas.microsoft.com/office/drawing/2014/main" id="{68574EBF-F3DF-4352-B52F-3C50B0AD6926}"/>
               </a:ext>
             </a:extLst>
           </p:cNvPr>
@@ -15720,7 +15720,7 @@
           <p:cNvPr id="2" name="">
             <a:extLst xmlns:a="http://schemas.openxmlformats.org/drawingml/2006/main">
               <a:ext uri="{FF2B5EF4-FFF2-40B4-BE49-F238E27FC236}">
-                <a16:creationId xmlns:a16="http://schemas.microsoft.com/office/drawing/2014/main" id="{5B1E242C-CF3F-4E3F-8C9C-1C1975179C03}"/>
+                <a16:creationId xmlns:a16="http://schemas.microsoft.com/office/drawing/2014/main" id="{CC0A7969-B42E-4486-8BC9-40736B3449A6}"/>
               </a:ext>
             </a:extLst>
           </p:cNvPr>
@@ -15769,7 +15769,7 @@
           <p:cNvPr id="3" name="">
             <a:extLst xmlns:a="http://schemas.openxmlformats.org/drawingml/2006/main">
               <a:ext uri="{FF2B5EF4-FFF2-40B4-BE49-F238E27FC236}">
-                <a16:creationId xmlns:a16="http://schemas.microsoft.com/office/drawing/2014/main" id="{21227FF2-07B7-402E-9AE8-3F412AAC22B6}"/>
+                <a16:creationId xmlns:a16="http://schemas.microsoft.com/office/drawing/2014/main" id="{609F572C-6F38-491B-9C80-0B204D0D77D3}"/>
               </a:ext>
             </a:extLst>
           </p:cNvPr>
@@ -15818,7 +15818,7 @@
           <p:cNvPr id="4" name="">
             <a:extLst xmlns:a="http://schemas.openxmlformats.org/drawingml/2006/main">
               <a:ext uri="{FF2B5EF4-FFF2-40B4-BE49-F238E27FC236}">
-                <a16:creationId xmlns:a16="http://schemas.microsoft.com/office/drawing/2014/main" id="{7E0BFF58-34F6-479C-9855-96075417D4D5}"/>
+                <a16:creationId xmlns:a16="http://schemas.microsoft.com/office/drawing/2014/main" id="{3BC1B209-9B91-49FA-95B0-1E77532743CA}"/>
               </a:ext>
             </a:extLst>
           </p:cNvPr>
@@ -15867,7 +15867,7 @@
           <p:cNvPr id="5" name="">
             <a:extLst xmlns:a="http://schemas.openxmlformats.org/drawingml/2006/main">
               <a:ext uri="{FF2B5EF4-FFF2-40B4-BE49-F238E27FC236}">
-                <a16:creationId xmlns:a16="http://schemas.microsoft.com/office/drawing/2014/main" id="{41E9C780-E85F-4DF3-89DD-5725C8B99E7E}"/>
+                <a16:creationId xmlns:a16="http://schemas.microsoft.com/office/drawing/2014/main" id="{6325405A-59F9-4141-B5D2-071098AE7106}"/>
               </a:ext>
             </a:extLst>
           </p:cNvPr>
@@ -15916,7 +15916,7 @@
           <p:cNvPr id="6" name="">
             <a:extLst xmlns:a="http://schemas.openxmlformats.org/drawingml/2006/main">
               <a:ext uri="{FF2B5EF4-FFF2-40B4-BE49-F238E27FC236}">
-                <a16:creationId xmlns:a16="http://schemas.microsoft.com/office/drawing/2014/main" id="{042DA4EB-CC97-4272-A846-2397408E3DA0}"/>
+                <a16:creationId xmlns:a16="http://schemas.microsoft.com/office/drawing/2014/main" id="{7EE88A22-9A12-4AAB-A89B-3CB0E9101186}"/>
               </a:ext>
             </a:extLst>
           </p:cNvPr>
@@ -15965,7 +15965,7 @@
           <p:cNvPr id="7" name="">
             <a:extLst xmlns:a="http://schemas.openxmlformats.org/drawingml/2006/main">
               <a:ext uri="{FF2B5EF4-FFF2-40B4-BE49-F238E27FC236}">
-                <a16:creationId xmlns:a16="http://schemas.microsoft.com/office/drawing/2014/main" id="{EB210A8E-F288-40AC-9B71-C1F7288ED376}"/>
+                <a16:creationId xmlns:a16="http://schemas.microsoft.com/office/drawing/2014/main" id="{5842DA93-C53A-4E10-AA07-EEB549C0BAFB}"/>
               </a:ext>
             </a:extLst>
           </p:cNvPr>
@@ -16014,7 +16014,7 @@
           <p:cNvPr id="8" name="">
             <a:extLst xmlns:a="http://schemas.openxmlformats.org/drawingml/2006/main">
               <a:ext uri="{FF2B5EF4-FFF2-40B4-BE49-F238E27FC236}">
-                <a16:creationId xmlns:a16="http://schemas.microsoft.com/office/drawing/2014/main" id="{9FBAE342-616C-4DC6-AC62-CCDACBD822D5}"/>
+                <a16:creationId xmlns:a16="http://schemas.microsoft.com/office/drawing/2014/main" id="{58C6115D-7BC9-4A14-BDFB-B5E5BFD9CE0D}"/>
               </a:ext>
             </a:extLst>
           </p:cNvPr>
@@ -16063,7 +16063,7 @@
           <p:cNvPr id="9" name="">
             <a:extLst xmlns:a="http://schemas.openxmlformats.org/drawingml/2006/main">
               <a:ext uri="{FF2B5EF4-FFF2-40B4-BE49-F238E27FC236}">
-                <a16:creationId xmlns:a16="http://schemas.microsoft.com/office/drawing/2014/main" id="{F7AA0C65-7DF2-4F62-9A75-B689C527EC23}"/>
+                <a16:creationId xmlns:a16="http://schemas.microsoft.com/office/drawing/2014/main" id="{55B02B67-BB36-47F1-9B93-7DDDD027BB97}"/>
               </a:ext>
             </a:extLst>
           </p:cNvPr>
@@ -16112,7 +16112,7 @@
           <p:cNvPr id="10" name="">
             <a:extLst xmlns:a="http://schemas.openxmlformats.org/drawingml/2006/main">
               <a:ext uri="{FF2B5EF4-FFF2-40B4-BE49-F238E27FC236}">
-                <a16:creationId xmlns:a16="http://schemas.microsoft.com/office/drawing/2014/main" id="{00F0CF5C-271D-4D54-A890-07003E8DB52A}"/>
+                <a16:creationId xmlns:a16="http://schemas.microsoft.com/office/drawing/2014/main" id="{E19D5347-4361-44BF-B90B-3C244507BDE3}"/>
               </a:ext>
             </a:extLst>
           </p:cNvPr>
@@ -16161,7 +16161,7 @@
           <p:cNvPr id="11" name="">
             <a:extLst xmlns:a="http://schemas.openxmlformats.org/drawingml/2006/main">
               <a:ext uri="{FF2B5EF4-FFF2-40B4-BE49-F238E27FC236}">
-                <a16:creationId xmlns:a16="http://schemas.microsoft.com/office/drawing/2014/main" id="{AD7210E0-4503-48EE-905B-EB9622001AC1}"/>
+                <a16:creationId xmlns:a16="http://schemas.microsoft.com/office/drawing/2014/main" id="{0075CE9E-2D25-45E9-988E-1D4D73A6CEC7}"/>
               </a:ext>
             </a:extLst>
           </p:cNvPr>
@@ -16210,7 +16210,7 @@
           <p:cNvPr id="12" name="">
             <a:extLst xmlns:a="http://schemas.openxmlformats.org/drawingml/2006/main">
               <a:ext uri="{FF2B5EF4-FFF2-40B4-BE49-F238E27FC236}">
-                <a16:creationId xmlns:a16="http://schemas.microsoft.com/office/drawing/2014/main" id="{4A6F194A-28F0-4D98-9DC1-BAD3A0918050}"/>
+                <a16:creationId xmlns:a16="http://schemas.microsoft.com/office/drawing/2014/main" id="{B2CDF667-6788-41DB-9F51-8A844EEDB93C}"/>
               </a:ext>
             </a:extLst>
           </p:cNvPr>
@@ -16257,7 +16257,7 @@
     </p:spTree>
     <p:extLst>
       <p:ext uri="{BB962C8B-B14F-4D97-AF65-F5344CB8AC3E}">
-        <p14:creationId xmlns:p14="http://schemas.microsoft.com/office/powerpoint/2010/main" val="85107092"/>
+        <p14:creationId xmlns:p14="http://schemas.microsoft.com/office/powerpoint/2010/main" val="1236483194"/>
       </p:ext>
     </p:extLst>
   </p:cSld>
@@ -16288,7 +16288,7 @@
           <p:cNvPr id="18" name="">
             <a:extLst xmlns:a="http://schemas.openxmlformats.org/drawingml/2006/main">
               <a:ext uri="{FF2B5EF4-FFF2-40B4-BE49-F238E27FC236}">
-                <a16:creationId xmlns:a16="http://schemas.microsoft.com/office/drawing/2014/main" id="{3B6F7319-C4E7-4B09-9AA8-0D7DE1C4CB2B}"/>
+                <a16:creationId xmlns:a16="http://schemas.microsoft.com/office/drawing/2014/main" id="{2CF12736-B208-4551-92F6-55F46FC036E1}"/>
               </a:ext>
             </a:extLst>
           </p:cNvPr>
@@ -16337,7 +16337,7 @@
           <p:cNvPr id="2" name="">
             <a:extLst xmlns:a="http://schemas.openxmlformats.org/drawingml/2006/main">
               <a:ext uri="{FF2B5EF4-FFF2-40B4-BE49-F238E27FC236}">
-                <a16:creationId xmlns:a16="http://schemas.microsoft.com/office/drawing/2014/main" id="{1116639B-7E88-4E5A-BB71-C685AF957143}"/>
+                <a16:creationId xmlns:a16="http://schemas.microsoft.com/office/drawing/2014/main" id="{AB5DE37A-41BD-4B86-A087-EDAD382BD9E8}"/>
               </a:ext>
             </a:extLst>
           </p:cNvPr>
@@ -16386,7 +16386,7 @@
           <p:cNvPr id="3" name="">
             <a:extLst xmlns:a="http://schemas.openxmlformats.org/drawingml/2006/main">
               <a:ext uri="{FF2B5EF4-FFF2-40B4-BE49-F238E27FC236}">
-                <a16:creationId xmlns:a16="http://schemas.microsoft.com/office/drawing/2014/main" id="{9080401A-FF7F-459F-970F-6FC96391EC78}"/>
+                <a16:creationId xmlns:a16="http://schemas.microsoft.com/office/drawing/2014/main" id="{6C8E8627-5526-41F2-8D01-8160C3C49356}"/>
               </a:ext>
             </a:extLst>
           </p:cNvPr>
@@ -16435,7 +16435,7 @@
           <p:cNvPr id="4" name="">
             <a:extLst xmlns:a="http://schemas.openxmlformats.org/drawingml/2006/main">
               <a:ext uri="{FF2B5EF4-FFF2-40B4-BE49-F238E27FC236}">
-                <a16:creationId xmlns:a16="http://schemas.microsoft.com/office/drawing/2014/main" id="{1C76FEF4-6E2E-44CE-9560-C86A82E3BB9A}"/>
+                <a16:creationId xmlns:a16="http://schemas.microsoft.com/office/drawing/2014/main" id="{4BC6229D-E2AF-4D38-BAFF-2288C055C738}"/>
               </a:ext>
             </a:extLst>
           </p:cNvPr>
@@ -16484,7 +16484,7 @@
           <p:cNvPr id="5" name="">
             <a:extLst xmlns:a="http://schemas.openxmlformats.org/drawingml/2006/main">
               <a:ext uri="{FF2B5EF4-FFF2-40B4-BE49-F238E27FC236}">
-                <a16:creationId xmlns:a16="http://schemas.microsoft.com/office/drawing/2014/main" id="{62A3999F-775E-4570-BA7F-8859A0B6671C}"/>
+                <a16:creationId xmlns:a16="http://schemas.microsoft.com/office/drawing/2014/main" id="{B2B03952-BE51-4E6E-A743-98A00295B79B}"/>
               </a:ext>
             </a:extLst>
           </p:cNvPr>
@@ -16533,7 +16533,7 @@
           <p:cNvPr id="6" name="">
             <a:extLst xmlns:a="http://schemas.openxmlformats.org/drawingml/2006/main">
               <a:ext uri="{FF2B5EF4-FFF2-40B4-BE49-F238E27FC236}">
-                <a16:creationId xmlns:a16="http://schemas.microsoft.com/office/drawing/2014/main" id="{529087A6-2B6C-4079-9058-C6CEB6444F3F}"/>
+                <a16:creationId xmlns:a16="http://schemas.microsoft.com/office/drawing/2014/main" id="{68F7F5D3-8EC5-444F-A7F0-E76C4D3F11E3}"/>
               </a:ext>
             </a:extLst>
           </p:cNvPr>
@@ -16582,7 +16582,7 @@
           <p:cNvPr id="7" name="">
             <a:extLst xmlns:a="http://schemas.openxmlformats.org/drawingml/2006/main">
               <a:ext uri="{FF2B5EF4-FFF2-40B4-BE49-F238E27FC236}">
-                <a16:creationId xmlns:a16="http://schemas.microsoft.com/office/drawing/2014/main" id="{A3FD7B61-4DB9-44FA-AB80-09EE40C35689}"/>
+                <a16:creationId xmlns:a16="http://schemas.microsoft.com/office/drawing/2014/main" id="{13C035CE-8F57-46DC-A6FE-D7B7034C6E5C}"/>
               </a:ext>
             </a:extLst>
           </p:cNvPr>
@@ -16631,7 +16631,7 @@
           <p:cNvPr id="8" name="">
             <a:extLst xmlns:a="http://schemas.openxmlformats.org/drawingml/2006/main">
               <a:ext uri="{FF2B5EF4-FFF2-40B4-BE49-F238E27FC236}">
-                <a16:creationId xmlns:a16="http://schemas.microsoft.com/office/drawing/2014/main" id="{5011C476-4CF2-4C78-A4D4-0DE8E99EFC8F}"/>
+                <a16:creationId xmlns:a16="http://schemas.microsoft.com/office/drawing/2014/main" id="{17E0657E-4DBF-4432-ACBC-AC0FAEDD0A2D}"/>
               </a:ext>
             </a:extLst>
           </p:cNvPr>
@@ -16680,7 +16680,7 @@
           <p:cNvPr id="9" name="">
             <a:extLst xmlns:a="http://schemas.openxmlformats.org/drawingml/2006/main">
               <a:ext uri="{FF2B5EF4-FFF2-40B4-BE49-F238E27FC236}">
-                <a16:creationId xmlns:a16="http://schemas.microsoft.com/office/drawing/2014/main" id="{DD51516A-15D3-49D2-8F64-4F355FF2A6A7}"/>
+                <a16:creationId xmlns:a16="http://schemas.microsoft.com/office/drawing/2014/main" id="{124D7523-C28B-4299-8234-278D607B8A5F}"/>
               </a:ext>
             </a:extLst>
           </p:cNvPr>
@@ -16729,7 +16729,7 @@
           <p:cNvPr id="10" name="">
             <a:extLst xmlns:a="http://schemas.openxmlformats.org/drawingml/2006/main">
               <a:ext uri="{FF2B5EF4-FFF2-40B4-BE49-F238E27FC236}">
-                <a16:creationId xmlns:a16="http://schemas.microsoft.com/office/drawing/2014/main" id="{E6F4BDF9-DD8E-450E-9CFF-B996281DD77A}"/>
+                <a16:creationId xmlns:a16="http://schemas.microsoft.com/office/drawing/2014/main" id="{862894C2-66CC-45B5-B45B-069E424D61DA}"/>
               </a:ext>
             </a:extLst>
           </p:cNvPr>
@@ -16778,7 +16778,7 @@
           <p:cNvPr id="11" name="">
             <a:extLst xmlns:a="http://schemas.openxmlformats.org/drawingml/2006/main">
               <a:ext uri="{FF2B5EF4-FFF2-40B4-BE49-F238E27FC236}">
-                <a16:creationId xmlns:a16="http://schemas.microsoft.com/office/drawing/2014/main" id="{ACDA968A-8D5F-4AB1-9D1C-D87C8AE2022C}"/>
+                <a16:creationId xmlns:a16="http://schemas.microsoft.com/office/drawing/2014/main" id="{055D6A4C-B10F-434F-A47F-36120E6D6048}"/>
               </a:ext>
             </a:extLst>
           </p:cNvPr>
@@ -16827,7 +16827,7 @@
           <p:cNvPr id="12" name="">
             <a:extLst xmlns:a="http://schemas.openxmlformats.org/drawingml/2006/main">
               <a:ext uri="{FF2B5EF4-FFF2-40B4-BE49-F238E27FC236}">
-                <a16:creationId xmlns:a16="http://schemas.microsoft.com/office/drawing/2014/main" id="{0F65F0F2-6F07-47FE-8D5F-70730EBB4D2D}"/>
+                <a16:creationId xmlns:a16="http://schemas.microsoft.com/office/drawing/2014/main" id="{A3E987B2-B703-4CF0-B59F-4D17E9CDF5A8}"/>
               </a:ext>
             </a:extLst>
           </p:cNvPr>
@@ -16876,7 +16876,7 @@
           <p:cNvPr id="13" name="">
             <a:extLst xmlns:a="http://schemas.openxmlformats.org/drawingml/2006/main">
               <a:ext uri="{FF2B5EF4-FFF2-40B4-BE49-F238E27FC236}">
-                <a16:creationId xmlns:a16="http://schemas.microsoft.com/office/drawing/2014/main" id="{3A846519-46B2-47D9-8A6D-ED5D20BB8DB2}"/>
+                <a16:creationId xmlns:a16="http://schemas.microsoft.com/office/drawing/2014/main" id="{79F4B893-FEF7-4BAC-B52E-FAECA191C4D2}"/>
               </a:ext>
             </a:extLst>
           </p:cNvPr>
@@ -16925,7 +16925,7 @@
           <p:cNvPr id="14" name="">
             <a:extLst xmlns:a="http://schemas.openxmlformats.org/drawingml/2006/main">
               <a:ext uri="{FF2B5EF4-FFF2-40B4-BE49-F238E27FC236}">
-                <a16:creationId xmlns:a16="http://schemas.microsoft.com/office/drawing/2014/main" id="{184D738F-6CBA-40CD-802E-4C2D943223E8}"/>
+                <a16:creationId xmlns:a16="http://schemas.microsoft.com/office/drawing/2014/main" id="{7AC90B1A-038B-4C87-B515-DC76E0B86C64}"/>
               </a:ext>
             </a:extLst>
           </p:cNvPr>
@@ -16974,7 +16974,7 @@
           <p:cNvPr id="15" name="">
             <a:extLst xmlns:a="http://schemas.openxmlformats.org/drawingml/2006/main">
               <a:ext uri="{FF2B5EF4-FFF2-40B4-BE49-F238E27FC236}">
-                <a16:creationId xmlns:a16="http://schemas.microsoft.com/office/drawing/2014/main" id="{8A6CB1B1-4A08-479D-85AD-3832A36F5810}"/>
+                <a16:creationId xmlns:a16="http://schemas.microsoft.com/office/drawing/2014/main" id="{CB6842AA-13FC-4745-B8D8-240DCE3D9B52}"/>
               </a:ext>
             </a:extLst>
           </p:cNvPr>
@@ -17023,7 +17023,7 @@
           <p:cNvPr id="16" name="">
             <a:extLst xmlns:a="http://schemas.openxmlformats.org/drawingml/2006/main">
               <a:ext uri="{FF2B5EF4-FFF2-40B4-BE49-F238E27FC236}">
-                <a16:creationId xmlns:a16="http://schemas.microsoft.com/office/drawing/2014/main" id="{2F413229-BF71-4D43-945B-F3F9524B6616}"/>
+                <a16:creationId xmlns:a16="http://schemas.microsoft.com/office/drawing/2014/main" id="{7022F252-0976-4D19-A1C6-56ADCC2D8A96}"/>
               </a:ext>
             </a:extLst>
           </p:cNvPr>
@@ -17072,7 +17072,7 @@
           <p:cNvPr id="17" name="">
             <a:extLst xmlns:a="http://schemas.openxmlformats.org/drawingml/2006/main">
               <a:ext uri="{FF2B5EF4-FFF2-40B4-BE49-F238E27FC236}">
-                <a16:creationId xmlns:a16="http://schemas.microsoft.com/office/drawing/2014/main" id="{56E37336-3C17-40C0-84DB-2B90047516D6}"/>
+                <a16:creationId xmlns:a16="http://schemas.microsoft.com/office/drawing/2014/main" id="{610E841A-1C1F-4356-8E13-DFFA13044B53}"/>
               </a:ext>
             </a:extLst>
           </p:cNvPr>
@@ -17119,7 +17119,7 @@
     </p:spTree>
     <p:extLst>
       <p:ext uri="{BB962C8B-B14F-4D97-AF65-F5344CB8AC3E}">
-        <p14:creationId xmlns:p14="http://schemas.microsoft.com/office/powerpoint/2010/main" val="1975411499"/>
+        <p14:creationId xmlns:p14="http://schemas.microsoft.com/office/powerpoint/2010/main" val="552826015"/>
       </p:ext>
     </p:extLst>
   </p:cSld>
@@ -17150,7 +17150,7 @@
           <p:cNvPr id="18" name="">
             <a:extLst xmlns:a="http://schemas.openxmlformats.org/drawingml/2006/main">
               <a:ext uri="{FF2B5EF4-FFF2-40B4-BE49-F238E27FC236}">
-                <a16:creationId xmlns:a16="http://schemas.microsoft.com/office/drawing/2014/main" id="{AFB5049A-3A7C-40B5-A7EA-249101E96918}"/>
+                <a16:creationId xmlns:a16="http://schemas.microsoft.com/office/drawing/2014/main" id="{F8DC5F10-8923-442A-8E15-62DC9B9B0B0E}"/>
               </a:ext>
             </a:extLst>
           </p:cNvPr>
@@ -17199,7 +17199,7 @@
           <p:cNvPr id="2" name="">
             <a:extLst xmlns:a="http://schemas.openxmlformats.org/drawingml/2006/main">
               <a:ext uri="{FF2B5EF4-FFF2-40B4-BE49-F238E27FC236}">
-                <a16:creationId xmlns:a16="http://schemas.microsoft.com/office/drawing/2014/main" id="{633B2E53-D46F-40A6-A584-F5A7649F18D0}"/>
+                <a16:creationId xmlns:a16="http://schemas.microsoft.com/office/drawing/2014/main" id="{4AEDF83E-804C-484E-9C59-2844BB133C65}"/>
               </a:ext>
             </a:extLst>
           </p:cNvPr>
@@ -17248,7 +17248,7 @@
           <p:cNvPr id="3" name="">
             <a:extLst xmlns:a="http://schemas.openxmlformats.org/drawingml/2006/main">
               <a:ext uri="{FF2B5EF4-FFF2-40B4-BE49-F238E27FC236}">
-                <a16:creationId xmlns:a16="http://schemas.microsoft.com/office/drawing/2014/main" id="{20762EAB-06C4-4717-AE2C-8E8648EFCA6A}"/>
+                <a16:creationId xmlns:a16="http://schemas.microsoft.com/office/drawing/2014/main" id="{75747D03-CC7B-48D6-A23B-968DB49BE610}"/>
               </a:ext>
             </a:extLst>
           </p:cNvPr>
@@ -17297,7 +17297,7 @@
           <p:cNvPr id="4" name="">
             <a:extLst xmlns:a="http://schemas.openxmlformats.org/drawingml/2006/main">
               <a:ext uri="{FF2B5EF4-FFF2-40B4-BE49-F238E27FC236}">
-                <a16:creationId xmlns:a16="http://schemas.microsoft.com/office/drawing/2014/main" id="{64934F82-FC91-4261-A83B-4DFB5C8B7AAE}"/>
+                <a16:creationId xmlns:a16="http://schemas.microsoft.com/office/drawing/2014/main" id="{E144364A-B5C2-489B-849B-4CE69FB0ADD6}"/>
               </a:ext>
             </a:extLst>
           </p:cNvPr>
@@ -17346,7 +17346,7 @@
           <p:cNvPr id="5" name="">
             <a:extLst xmlns:a="http://schemas.openxmlformats.org/drawingml/2006/main">
               <a:ext uri="{FF2B5EF4-FFF2-40B4-BE49-F238E27FC236}">
-                <a16:creationId xmlns:a16="http://schemas.microsoft.com/office/drawing/2014/main" id="{EA92B66F-8E5C-42D3-A45D-0C5650D84BE7}"/>
+                <a16:creationId xmlns:a16="http://schemas.microsoft.com/office/drawing/2014/main" id="{18FBD036-2494-4A38-9FD7-19DDE51BC6F5}"/>
               </a:ext>
             </a:extLst>
           </p:cNvPr>
@@ -17395,7 +17395,7 @@
           <p:cNvPr id="6" name="">
             <a:extLst xmlns:a="http://schemas.openxmlformats.org/drawingml/2006/main">
               <a:ext uri="{FF2B5EF4-FFF2-40B4-BE49-F238E27FC236}">
-                <a16:creationId xmlns:a16="http://schemas.microsoft.com/office/drawing/2014/main" id="{63D185AE-F847-4097-A6C6-B3D7A35453FF}"/>
+                <a16:creationId xmlns:a16="http://schemas.microsoft.com/office/drawing/2014/main" id="{EA3C4071-E5AC-4F7F-A6EA-0E3247977D17}"/>
               </a:ext>
             </a:extLst>
           </p:cNvPr>
@@ -17444,7 +17444,7 @@
           <p:cNvPr id="7" name="">
             <a:extLst xmlns:a="http://schemas.openxmlformats.org/drawingml/2006/main">
               <a:ext uri="{FF2B5EF4-FFF2-40B4-BE49-F238E27FC236}">
-                <a16:creationId xmlns:a16="http://schemas.microsoft.com/office/drawing/2014/main" id="{DDC51796-1C6C-4843-89A7-5F89CB849E68}"/>
+                <a16:creationId xmlns:a16="http://schemas.microsoft.com/office/drawing/2014/main" id="{3FCE17EA-5CFD-4C6A-ABB2-1AE1A5F026FE}"/>
               </a:ext>
             </a:extLst>
           </p:cNvPr>
@@ -17493,7 +17493,7 @@
           <p:cNvPr id="8" name="">
             <a:extLst xmlns:a="http://schemas.openxmlformats.org/drawingml/2006/main">
               <a:ext uri="{FF2B5EF4-FFF2-40B4-BE49-F238E27FC236}">
-                <a16:creationId xmlns:a16="http://schemas.microsoft.com/office/drawing/2014/main" id="{A0E9F296-9E43-4308-BBA9-4AA13949A102}"/>
+                <a16:creationId xmlns:a16="http://schemas.microsoft.com/office/drawing/2014/main" id="{6EB9B5E1-C621-4581-AE73-54BDE8F88B63}"/>
               </a:ext>
             </a:extLst>
           </p:cNvPr>
@@ -17542,7 +17542,7 @@
           <p:cNvPr id="9" name="">
             <a:extLst xmlns:a="http://schemas.openxmlformats.org/drawingml/2006/main">
               <a:ext uri="{FF2B5EF4-FFF2-40B4-BE49-F238E27FC236}">
-                <a16:creationId xmlns:a16="http://schemas.microsoft.com/office/drawing/2014/main" id="{A129E787-33E3-48EE-8603-05C6ECCB5584}"/>
+                <a16:creationId xmlns:a16="http://schemas.microsoft.com/office/drawing/2014/main" id="{82276D7B-C73A-49A6-B902-3B602709B3E9}"/>
               </a:ext>
             </a:extLst>
           </p:cNvPr>
@@ -17591,7 +17591,7 @@
           <p:cNvPr id="10" name="">
             <a:extLst xmlns:a="http://schemas.openxmlformats.org/drawingml/2006/main">
               <a:ext uri="{FF2B5EF4-FFF2-40B4-BE49-F238E27FC236}">
-                <a16:creationId xmlns:a16="http://schemas.microsoft.com/office/drawing/2014/main" id="{186575BC-F59F-41E0-92F9-EFD1D3DA3084}"/>
+                <a16:creationId xmlns:a16="http://schemas.microsoft.com/office/drawing/2014/main" id="{00E00E1C-5684-457B-A776-FF15C4C4AAB0}"/>
               </a:ext>
             </a:extLst>
           </p:cNvPr>
@@ -17640,7 +17640,7 @@
           <p:cNvPr id="11" name="">
             <a:extLst xmlns:a="http://schemas.openxmlformats.org/drawingml/2006/main">
               <a:ext uri="{FF2B5EF4-FFF2-40B4-BE49-F238E27FC236}">
-                <a16:creationId xmlns:a16="http://schemas.microsoft.com/office/drawing/2014/main" id="{F336D186-D87C-4EEE-A4D8-FCD38F31BDC4}"/>
+                <a16:creationId xmlns:a16="http://schemas.microsoft.com/office/drawing/2014/main" id="{05F0A70C-529D-44D9-A6F0-16A7BD900266}"/>
               </a:ext>
             </a:extLst>
           </p:cNvPr>
@@ -17689,7 +17689,7 @@
           <p:cNvPr id="12" name="">
             <a:extLst xmlns:a="http://schemas.openxmlformats.org/drawingml/2006/main">
               <a:ext uri="{FF2B5EF4-FFF2-40B4-BE49-F238E27FC236}">
-                <a16:creationId xmlns:a16="http://schemas.microsoft.com/office/drawing/2014/main" id="{0C2C9EB2-3F0E-4968-8917-E541267EC47E}"/>
+                <a16:creationId xmlns:a16="http://schemas.microsoft.com/office/drawing/2014/main" id="{DA6261E4-1953-4598-B49E-5AE5C8A12351}"/>
               </a:ext>
             </a:extLst>
           </p:cNvPr>
@@ -17738,7 +17738,7 @@
           <p:cNvPr id="13" name="">
             <a:extLst xmlns:a="http://schemas.openxmlformats.org/drawingml/2006/main">
               <a:ext uri="{FF2B5EF4-FFF2-40B4-BE49-F238E27FC236}">
-                <a16:creationId xmlns:a16="http://schemas.microsoft.com/office/drawing/2014/main" id="{F4057C2D-EC03-4454-861D-A1CAD984464E}"/>
+                <a16:creationId xmlns:a16="http://schemas.microsoft.com/office/drawing/2014/main" id="{A35B52B4-69E6-4A91-B3A7-FB552089AF09}"/>
               </a:ext>
             </a:extLst>
           </p:cNvPr>
@@ -17787,7 +17787,7 @@
           <p:cNvPr id="14" name="">
             <a:extLst xmlns:a="http://schemas.openxmlformats.org/drawingml/2006/main">
               <a:ext uri="{FF2B5EF4-FFF2-40B4-BE49-F238E27FC236}">
-                <a16:creationId xmlns:a16="http://schemas.microsoft.com/office/drawing/2014/main" id="{5B4AEE7E-6EF4-4B95-94A4-06958253CE4B}"/>
+                <a16:creationId xmlns:a16="http://schemas.microsoft.com/office/drawing/2014/main" id="{390679D1-93BB-4C82-A8D4-8CD37D130FF3}"/>
               </a:ext>
             </a:extLst>
           </p:cNvPr>
@@ -17836,7 +17836,7 @@
           <p:cNvPr id="15" name="">
             <a:extLst xmlns:a="http://schemas.openxmlformats.org/drawingml/2006/main">
               <a:ext uri="{FF2B5EF4-FFF2-40B4-BE49-F238E27FC236}">
-                <a16:creationId xmlns:a16="http://schemas.microsoft.com/office/drawing/2014/main" id="{C5A0C93D-C306-46CD-AB7D-6F74AF7013BA}"/>
+                <a16:creationId xmlns:a16="http://schemas.microsoft.com/office/drawing/2014/main" id="{864F3AC5-5BF2-4215-AF7C-02FA5F478349}"/>
               </a:ext>
             </a:extLst>
           </p:cNvPr>
@@ -17885,7 +17885,7 @@
           <p:cNvPr id="16" name="">
             <a:extLst xmlns:a="http://schemas.openxmlformats.org/drawingml/2006/main">
               <a:ext uri="{FF2B5EF4-FFF2-40B4-BE49-F238E27FC236}">
-                <a16:creationId xmlns:a16="http://schemas.microsoft.com/office/drawing/2014/main" id="{9E97B20C-140B-4E1A-866E-8C6280C59454}"/>
+                <a16:creationId xmlns:a16="http://schemas.microsoft.com/office/drawing/2014/main" id="{C5D2E385-4FD1-4DC0-8686-0A69E8F82385}"/>
               </a:ext>
             </a:extLst>
           </p:cNvPr>
@@ -17934,7 +17934,7 @@
           <p:cNvPr id="17" name="">
             <a:extLst xmlns:a="http://schemas.openxmlformats.org/drawingml/2006/main">
               <a:ext uri="{FF2B5EF4-FFF2-40B4-BE49-F238E27FC236}">
-                <a16:creationId xmlns:a16="http://schemas.microsoft.com/office/drawing/2014/main" id="{0998EB8F-7EAE-4401-827F-A3BDAEC35105}"/>
+                <a16:creationId xmlns:a16="http://schemas.microsoft.com/office/drawing/2014/main" id="{2D45A1E3-3E93-4366-ADA0-955F0C1DE9A3}"/>
               </a:ext>
             </a:extLst>
           </p:cNvPr>
@@ -17981,7 +17981,7 @@
     </p:spTree>
     <p:extLst>
       <p:ext uri="{BB962C8B-B14F-4D97-AF65-F5344CB8AC3E}">
-        <p14:creationId xmlns:p14="http://schemas.microsoft.com/office/powerpoint/2010/main" val="298017730"/>
+        <p14:creationId xmlns:p14="http://schemas.microsoft.com/office/powerpoint/2010/main" val="1031530151"/>
       </p:ext>
     </p:extLst>
   </p:cSld>
@@ -18012,7 +18012,7 @@
           <p:cNvPr id="16" name="">
             <a:extLst xmlns:a="http://schemas.openxmlformats.org/drawingml/2006/main">
               <a:ext uri="{FF2B5EF4-FFF2-40B4-BE49-F238E27FC236}">
-                <a16:creationId xmlns:a16="http://schemas.microsoft.com/office/drawing/2014/main" id="{46356D2E-AD7E-4C37-8888-075D0853C4C0}"/>
+                <a16:creationId xmlns:a16="http://schemas.microsoft.com/office/drawing/2014/main" id="{C7454DBC-66EE-44CA-A05E-31F6980F9A56}"/>
               </a:ext>
             </a:extLst>
           </p:cNvPr>
@@ -18061,7 +18061,7 @@
           <p:cNvPr id="2" name="">
             <a:extLst xmlns:a="http://schemas.openxmlformats.org/drawingml/2006/main">
               <a:ext uri="{FF2B5EF4-FFF2-40B4-BE49-F238E27FC236}">
-                <a16:creationId xmlns:a16="http://schemas.microsoft.com/office/drawing/2014/main" id="{040CDDBF-1046-4AA7-AD48-CB3D7E32061F}"/>
+                <a16:creationId xmlns:a16="http://schemas.microsoft.com/office/drawing/2014/main" id="{48EDEFFB-5BF8-4F86-8D6B-4228C610297D}"/>
               </a:ext>
             </a:extLst>
           </p:cNvPr>
@@ -18110,7 +18110,7 @@
           <p:cNvPr id="3" name="">
             <a:extLst xmlns:a="http://schemas.openxmlformats.org/drawingml/2006/main">
               <a:ext uri="{FF2B5EF4-FFF2-40B4-BE49-F238E27FC236}">
-                <a16:creationId xmlns:a16="http://schemas.microsoft.com/office/drawing/2014/main" id="{DACFE298-3A78-4305-ABDB-1D75DD4B0631}"/>
+                <a16:creationId xmlns:a16="http://schemas.microsoft.com/office/drawing/2014/main" id="{9C7244E7-C07A-420A-A6E6-63EB84C226F1}"/>
               </a:ext>
             </a:extLst>
           </p:cNvPr>
@@ -18159,7 +18159,7 @@
           <p:cNvPr id="4" name="">
             <a:extLst xmlns:a="http://schemas.openxmlformats.org/drawingml/2006/main">
               <a:ext uri="{FF2B5EF4-FFF2-40B4-BE49-F238E27FC236}">
-                <a16:creationId xmlns:a16="http://schemas.microsoft.com/office/drawing/2014/main" id="{B61CEE58-2D9E-48BC-BDE7-F71877889448}"/>
+                <a16:creationId xmlns:a16="http://schemas.microsoft.com/office/drawing/2014/main" id="{029A1437-A9C1-4ABB-B7E7-C45A18F0ED4A}"/>
               </a:ext>
             </a:extLst>
           </p:cNvPr>
@@ -18208,7 +18208,7 @@
           <p:cNvPr id="5" name="">
             <a:extLst xmlns:a="http://schemas.openxmlformats.org/drawingml/2006/main">
               <a:ext uri="{FF2B5EF4-FFF2-40B4-BE49-F238E27FC236}">
-                <a16:creationId xmlns:a16="http://schemas.microsoft.com/office/drawing/2014/main" id="{D8FDB346-3678-4C20-A3B3-1435D8B22CD8}"/>
+                <a16:creationId xmlns:a16="http://schemas.microsoft.com/office/drawing/2014/main" id="{05BB0ADB-521A-4516-BAE3-19D95724BFA0}"/>
               </a:ext>
             </a:extLst>
           </p:cNvPr>
@@ -18257,7 +18257,7 @@
           <p:cNvPr id="6" name="">
             <a:extLst xmlns:a="http://schemas.openxmlformats.org/drawingml/2006/main">
               <a:ext uri="{FF2B5EF4-FFF2-40B4-BE49-F238E27FC236}">
-                <a16:creationId xmlns:a16="http://schemas.microsoft.com/office/drawing/2014/main" id="{0C650987-96AD-4B9B-AF53-E730B2DA4B62}"/>
+                <a16:creationId xmlns:a16="http://schemas.microsoft.com/office/drawing/2014/main" id="{3814C3B6-324A-458E-BBAB-ABCA6B65F5D7}"/>
               </a:ext>
             </a:extLst>
           </p:cNvPr>
@@ -18306,7 +18306,7 @@
           <p:cNvPr id="7" name="">
             <a:extLst xmlns:a="http://schemas.openxmlformats.org/drawingml/2006/main">
               <a:ext uri="{FF2B5EF4-FFF2-40B4-BE49-F238E27FC236}">
-                <a16:creationId xmlns:a16="http://schemas.microsoft.com/office/drawing/2014/main" id="{E1F83CCD-9DED-4290-B944-99963F39AB9C}"/>
+                <a16:creationId xmlns:a16="http://schemas.microsoft.com/office/drawing/2014/main" id="{26BCAF4D-B00B-4308-B81B-09B918B80633}"/>
               </a:ext>
             </a:extLst>
           </p:cNvPr>
@@ -18355,7 +18355,7 @@
           <p:cNvPr id="8" name="">
             <a:extLst xmlns:a="http://schemas.openxmlformats.org/drawingml/2006/main">
               <a:ext uri="{FF2B5EF4-FFF2-40B4-BE49-F238E27FC236}">
-                <a16:creationId xmlns:a16="http://schemas.microsoft.com/office/drawing/2014/main" id="{123FF39A-3BF6-45B4-A053-63FE5F35EACE}"/>
+                <a16:creationId xmlns:a16="http://schemas.microsoft.com/office/drawing/2014/main" id="{D7008DBF-6999-4C9A-AA09-DE46AFE34EC9}"/>
               </a:ext>
             </a:extLst>
           </p:cNvPr>
@@ -18404,7 +18404,7 @@
           <p:cNvPr id="9" name="">
             <a:extLst xmlns:a="http://schemas.openxmlformats.org/drawingml/2006/main">
               <a:ext uri="{FF2B5EF4-FFF2-40B4-BE49-F238E27FC236}">
-                <a16:creationId xmlns:a16="http://schemas.microsoft.com/office/drawing/2014/main" id="{61FA14AC-AF72-4931-BC88-7AF31D797B6C}"/>
+                <a16:creationId xmlns:a16="http://schemas.microsoft.com/office/drawing/2014/main" id="{B06A745D-DFA0-4655-BCE3-B4E20AE7EA3C}"/>
               </a:ext>
             </a:extLst>
           </p:cNvPr>
@@ -18453,7 +18453,7 @@
           <p:cNvPr id="10" name="">
             <a:extLst xmlns:a="http://schemas.openxmlformats.org/drawingml/2006/main">
               <a:ext uri="{FF2B5EF4-FFF2-40B4-BE49-F238E27FC236}">
-                <a16:creationId xmlns:a16="http://schemas.microsoft.com/office/drawing/2014/main" id="{A46A3168-0A5F-4A25-AE81-B6D5CE41C479}"/>
+                <a16:creationId xmlns:a16="http://schemas.microsoft.com/office/drawing/2014/main" id="{B9AB2AB8-2869-4DD2-AD27-76D1D2F4C02F}"/>
               </a:ext>
             </a:extLst>
           </p:cNvPr>
@@ -18502,7 +18502,7 @@
           <p:cNvPr id="11" name="">
             <a:extLst xmlns:a="http://schemas.openxmlformats.org/drawingml/2006/main">
               <a:ext uri="{FF2B5EF4-FFF2-40B4-BE49-F238E27FC236}">
-                <a16:creationId xmlns:a16="http://schemas.microsoft.com/office/drawing/2014/main" id="{DF0244BD-8789-4984-B974-6DD33EC4AACC}"/>
+                <a16:creationId xmlns:a16="http://schemas.microsoft.com/office/drawing/2014/main" id="{164D2638-F44B-479A-B87B-D1D37573FD9A}"/>
               </a:ext>
             </a:extLst>
           </p:cNvPr>
@@ -18551,7 +18551,7 @@
           <p:cNvPr id="12" name="">
             <a:extLst xmlns:a="http://schemas.openxmlformats.org/drawingml/2006/main">
               <a:ext uri="{FF2B5EF4-FFF2-40B4-BE49-F238E27FC236}">
-                <a16:creationId xmlns:a16="http://schemas.microsoft.com/office/drawing/2014/main" id="{075441E9-3ED4-4474-AF21-B24A719F9420}"/>
+                <a16:creationId xmlns:a16="http://schemas.microsoft.com/office/drawing/2014/main" id="{5178A0D2-C8AB-422B-9155-E7D4B4B453BB}"/>
               </a:ext>
             </a:extLst>
           </p:cNvPr>
@@ -18600,7 +18600,7 @@
           <p:cNvPr id="13" name="">
             <a:extLst xmlns:a="http://schemas.openxmlformats.org/drawingml/2006/main">
               <a:ext uri="{FF2B5EF4-FFF2-40B4-BE49-F238E27FC236}">
-                <a16:creationId xmlns:a16="http://schemas.microsoft.com/office/drawing/2014/main" id="{96F36094-7624-4C21-A616-B285BDB95247}"/>
+                <a16:creationId xmlns:a16="http://schemas.microsoft.com/office/drawing/2014/main" id="{38A2AB89-3F3C-4917-A373-BC3836C606A3}"/>
               </a:ext>
             </a:extLst>
           </p:cNvPr>
@@ -18649,7 +18649,7 @@
           <p:cNvPr id="14" name="">
             <a:extLst xmlns:a="http://schemas.openxmlformats.org/drawingml/2006/main">
               <a:ext uri="{FF2B5EF4-FFF2-40B4-BE49-F238E27FC236}">
-                <a16:creationId xmlns:a16="http://schemas.microsoft.com/office/drawing/2014/main" id="{9033F904-4C66-416F-969E-E321EC2CB120}"/>
+                <a16:creationId xmlns:a16="http://schemas.microsoft.com/office/drawing/2014/main" id="{B3490E23-7E3C-44A6-A5E0-3ED1B54E332B}"/>
               </a:ext>
             </a:extLst>
           </p:cNvPr>
@@ -18698,7 +18698,7 @@
           <p:cNvPr id="15" name="">
             <a:extLst xmlns:a="http://schemas.openxmlformats.org/drawingml/2006/main">
               <a:ext uri="{FF2B5EF4-FFF2-40B4-BE49-F238E27FC236}">
-                <a16:creationId xmlns:a16="http://schemas.microsoft.com/office/drawing/2014/main" id="{D808D27A-03A8-4F44-BD1F-73694805B58C}"/>
+                <a16:creationId xmlns:a16="http://schemas.microsoft.com/office/drawing/2014/main" id="{AEAD0EB7-D280-4075-A7DF-E8CFC169BF5F}"/>
               </a:ext>
             </a:extLst>
           </p:cNvPr>
@@ -18745,7 +18745,7 @@
     </p:spTree>
     <p:extLst>
       <p:ext uri="{BB962C8B-B14F-4D97-AF65-F5344CB8AC3E}">
-        <p14:creationId xmlns:p14="http://schemas.microsoft.com/office/powerpoint/2010/main" val="1758047512"/>
+        <p14:creationId xmlns:p14="http://schemas.microsoft.com/office/powerpoint/2010/main" val="1548024450"/>
       </p:ext>
     </p:extLst>
   </p:cSld>

</xml_diff>